<commit_message>
Charts: data label placement, wrapping, keys and own text; rounded corners
Pie labels follow PowerPoint's measured placement for every position
(ctr, inEnd, outEnd, best fit inside or outside), moved labels keep
their manual offsets and get leader lines. Labels wrap at a fifth of
the chart's width, take the language's list separator, show legend
keys, bubble sizes, text of their own and text from cells. Chart areas
round their corners unless told otherwise, a manual plot area still
turns crowded category labels, horizontal value axes keep wider
intervals, and the second pie of a pie of pie starts where the
combined slice ends.

Co-Authored-By: Claude Opus 5.5 <noreply@anthropic.com>
</commit_message>
<xml_diff>
--- a/tests/corpus/pptx/generated/charts-details.pptx
+++ b/tests/corpus/pptx/generated/charts-details.pptx
@@ -218,7 +218,7 @@
               </c14:invertSolidFillFmt>
             </c:ext>
             <c:ext xmlns:c16="http://schemas.microsoft.com/office/drawing/2014/chart" uri="{C3380CC4-5D6E-409C-BE32-E72D297353CC}">
-              <c16:uniqueId val="{00000000-EA4E-4496-81B5-EE9721C23A0C}"/>
+              <c16:uniqueId val="{00000000-E5AC-453A-B7E2-2CB1464BBC10}"/>
             </c:ext>
           </c:extLst>
         </c:ser>
@@ -295,7 +295,7 @@
           </c:val>
           <c:extLst>
             <c:ext xmlns:c16="http://schemas.microsoft.com/office/drawing/2014/chart" uri="{C3380CC4-5D6E-409C-BE32-E72D297353CC}">
-              <c16:uniqueId val="{00000001-EA4E-4496-81B5-EE9721C23A0C}"/>
+              <c16:uniqueId val="{00000001-E5AC-453A-B7E2-2CB1464BBC10}"/>
             </c:ext>
           </c:extLst>
         </c:ser>
@@ -309,11 +309,11 @@
         </c:dLbls>
         <c:gapWidth val="219"/>
         <c:overlap val="-27"/>
-        <c:axId val="762690351"/>
-        <c:axId val="1293295183"/>
+        <c:axId val="5541200"/>
+        <c:axId val="1193382576"/>
       </c:barChart>
       <c:catAx>
-        <c:axId val="762690351"/>
+        <c:axId val="5541200"/>
         <c:scaling>
           <c:orientation val="minMax"/>
         </c:scaling>
@@ -356,7 +356,7 @@
             <a:endParaRPr lang="de-DE"/>
           </a:p>
         </c:txPr>
-        <c:crossAx val="1293295183"/>
+        <c:crossAx val="1193382576"/>
         <c:crosses val="autoZero"/>
         <c:auto val="1"/>
         <c:lblAlgn val="ctr"/>
@@ -364,7 +364,7 @@
         <c:noMultiLvlLbl val="0"/>
       </c:catAx>
       <c:valAx>
-        <c:axId val="1293295183"/>
+        <c:axId val="1193382576"/>
         <c:scaling>
           <c:orientation val="minMax"/>
         </c:scaling>
@@ -415,7 +415,7 @@
             <a:endParaRPr lang="de-DE"/>
           </a:p>
         </c:txPr>
-        <c:crossAx val="762690351"/>
+        <c:crossAx val="5541200"/>
         <c:crosses val="autoZero"/>
         <c:crossBetween val="between"/>
       </c:valAx>
@@ -590,7 +590,7 @@
           </c:val>
           <c:extLst>
             <c:ext xmlns:c16="http://schemas.microsoft.com/office/drawing/2014/chart" uri="{C3380CC4-5D6E-409C-BE32-E72D297353CC}">
-              <c16:uniqueId val="{00000000-2EC0-42D7-9A20-0DBBD52B7655}"/>
+              <c16:uniqueId val="{00000000-FDF9-40CF-9FBA-1BFC5126B945}"/>
             </c:ext>
           </c:extLst>
         </c:ser>
@@ -661,7 +661,7 @@
           </c:val>
           <c:extLst>
             <c:ext xmlns:c16="http://schemas.microsoft.com/office/drawing/2014/chart" uri="{C3380CC4-5D6E-409C-BE32-E72D297353CC}">
-              <c16:uniqueId val="{00000001-2EC0-42D7-9A20-0DBBD52B7655}"/>
+              <c16:uniqueId val="{00000001-FDF9-40CF-9FBA-1BFC5126B945}"/>
             </c:ext>
           </c:extLst>
         </c:ser>
@@ -732,7 +732,7 @@
           </c:val>
           <c:extLst>
             <c:ext xmlns:c16="http://schemas.microsoft.com/office/drawing/2014/chart" uri="{C3380CC4-5D6E-409C-BE32-E72D297353CC}">
-              <c16:uniqueId val="{00000002-2EC0-42D7-9A20-0DBBD52B7655}"/>
+              <c16:uniqueId val="{00000002-FDF9-40CF-9FBA-1BFC5126B945}"/>
             </c:ext>
           </c:extLst>
         </c:ser>
@@ -746,11 +746,11 @@
         </c:dLbls>
         <c:gapWidth val="219"/>
         <c:overlap val="-27"/>
-        <c:axId val="1529861360"/>
-        <c:axId val="1293498703"/>
+        <c:axId val="9931744"/>
+        <c:axId val="1193318256"/>
       </c:barChart>
       <c:catAx>
-        <c:axId val="1529861360"/>
+        <c:axId val="9931744"/>
         <c:scaling>
           <c:orientation val="minMax"/>
         </c:scaling>
@@ -793,7 +793,7 @@
             <a:endParaRPr lang="de-DE"/>
           </a:p>
         </c:txPr>
-        <c:crossAx val="1293498703"/>
+        <c:crossAx val="1193318256"/>
         <c:crosses val="autoZero"/>
         <c:auto val="1"/>
         <c:lblAlgn val="ctr"/>
@@ -801,7 +801,7 @@
         <c:noMultiLvlLbl val="0"/>
       </c:catAx>
       <c:valAx>
-        <c:axId val="1293498703"/>
+        <c:axId val="1193318256"/>
         <c:scaling>
           <c:orientation val="minMax"/>
         </c:scaling>
@@ -852,7 +852,7 @@
             <a:endParaRPr lang="de-DE"/>
           </a:p>
         </c:txPr>
-        <c:crossAx val="1529861360"/>
+        <c:crossAx val="9931744"/>
         <c:crosses val="autoZero"/>
         <c:crossBetween val="between"/>
       </c:valAx>
@@ -1074,7 +1074,7 @@
           <c:bubble3D val="0"/>
           <c:extLst>
             <c:ext xmlns:c16="http://schemas.microsoft.com/office/drawing/2014/chart" uri="{C3380CC4-5D6E-409C-BE32-E72D297353CC}">
-              <c16:uniqueId val="{00000000-F952-4C88-9305-B5EF48086852}"/>
+              <c16:uniqueId val="{00000000-FD6D-4A63-B7B5-FD4369761B74}"/>
             </c:ext>
           </c:extLst>
         </c:ser>
@@ -1088,11 +1088,11 @@
         </c:dLbls>
         <c:bubbleScale val="100"/>
         <c:showNegBubbles val="0"/>
-        <c:axId val="1303157263"/>
-        <c:axId val="1293511183"/>
+        <c:axId val="7285984"/>
+        <c:axId val="1193317776"/>
       </c:bubbleChart>
       <c:valAx>
-        <c:axId val="1303157263"/>
+        <c:axId val="7285984"/>
         <c:scaling>
           <c:orientation val="minMax"/>
         </c:scaling>
@@ -1149,12 +1149,12 @@
             <a:endParaRPr lang="de-DE"/>
           </a:p>
         </c:txPr>
-        <c:crossAx val="1293511183"/>
+        <c:crossAx val="1193317776"/>
         <c:crosses val="autoZero"/>
         <c:crossBetween val="midCat"/>
       </c:valAx>
       <c:valAx>
-        <c:axId val="1293511183"/>
+        <c:axId val="1193317776"/>
         <c:scaling>
           <c:orientation val="minMax"/>
         </c:scaling>
@@ -1211,7 +1211,7 @@
             <a:endParaRPr lang="de-DE"/>
           </a:p>
         </c:txPr>
-        <c:crossAx val="1303157263"/>
+        <c:crossAx val="7285984"/>
         <c:crosses val="autoZero"/>
         <c:crossBetween val="midCat"/>
       </c:valAx>
@@ -1377,7 +1377,7 @@
           </c:val>
           <c:extLst>
             <c:ext xmlns:c16="http://schemas.microsoft.com/office/drawing/2014/chart" uri="{C3380CC4-5D6E-409C-BE32-E72D297353CC}">
-              <c16:uniqueId val="{00000000-2C46-4E81-A1A2-F1830123E671}"/>
+              <c16:uniqueId val="{00000000-F0EC-435C-BB41-A4B49D094CC9}"/>
             </c:ext>
           </c:extLst>
         </c:ser>
@@ -1449,7 +1449,7 @@
           </c:val>
           <c:extLst>
             <c:ext xmlns:c16="http://schemas.microsoft.com/office/drawing/2014/chart" uri="{C3380CC4-5D6E-409C-BE32-E72D297353CC}">
-              <c16:uniqueId val="{00000001-2C46-4E81-A1A2-F1830123E671}"/>
+              <c16:uniqueId val="{00000001-F0EC-435C-BB41-A4B49D094CC9}"/>
             </c:ext>
           </c:extLst>
         </c:ser>
@@ -1463,11 +1463,11 @@
         </c:dLbls>
         <c:gapWidth val="219"/>
         <c:overlap val="-27"/>
-        <c:axId val="1305973295"/>
-        <c:axId val="1293342703"/>
+        <c:axId val="1987030751"/>
+        <c:axId val="1193437296"/>
       </c:barChart>
       <c:catAx>
-        <c:axId val="1305973295"/>
+        <c:axId val="1987030751"/>
         <c:scaling>
           <c:orientation val="minMax"/>
         </c:scaling>
@@ -1510,7 +1510,7 @@
             <a:endParaRPr lang="de-DE"/>
           </a:p>
         </c:txPr>
-        <c:crossAx val="1293342703"/>
+        <c:crossAx val="1193437296"/>
         <c:crosses val="autoZero"/>
         <c:auto val="1"/>
         <c:lblAlgn val="ctr"/>
@@ -1518,7 +1518,7 @@
         <c:noMultiLvlLbl val="0"/>
       </c:catAx>
       <c:valAx>
-        <c:axId val="1293342703"/>
+        <c:axId val="1193437296"/>
         <c:scaling>
           <c:orientation val="minMax"/>
         </c:scaling>
@@ -1569,7 +1569,7 @@
             <a:endParaRPr lang="de-DE"/>
           </a:p>
         </c:txPr>
-        <c:crossAx val="1305973295"/>
+        <c:crossAx val="1987030751"/>
         <c:crosses val="autoZero"/>
         <c:crossBetween val="between"/>
         <c:dispUnits>
@@ -1816,7 +1816,7 @@
           <c:smooth val="0"/>
           <c:extLst>
             <c:ext xmlns:c16="http://schemas.microsoft.com/office/drawing/2014/chart" uri="{C3380CC4-5D6E-409C-BE32-E72D297353CC}">
-              <c16:uniqueId val="{00000000-456F-4EFA-820D-D049B8FEFAB6}"/>
+              <c16:uniqueId val="{00000000-5BD0-4FF6-95FA-CDA1D93BCF44}"/>
             </c:ext>
           </c:extLst>
         </c:ser>
@@ -1829,11 +1829,11 @@
           <c:showBubbleSize val="0"/>
         </c:dLbls>
         <c:smooth val="0"/>
-        <c:axId val="1319064351"/>
-        <c:axId val="1293414703"/>
+        <c:axId val="49323520"/>
+        <c:axId val="1193483856"/>
       </c:lineChart>
       <c:catAx>
-        <c:axId val="1319064351"/>
+        <c:axId val="49323520"/>
         <c:scaling>
           <c:orientation val="minMax"/>
         </c:scaling>
@@ -1876,7 +1876,7 @@
             <a:endParaRPr lang="de-DE"/>
           </a:p>
         </c:txPr>
-        <c:crossAx val="1293414703"/>
+        <c:crossAx val="1193483856"/>
         <c:crosses val="autoZero"/>
         <c:auto val="1"/>
         <c:lblAlgn val="ctr"/>
@@ -1886,7 +1886,7 @@
         <c:noMultiLvlLbl val="0"/>
       </c:catAx>
       <c:valAx>
-        <c:axId val="1293414703"/>
+        <c:axId val="1193483856"/>
         <c:scaling>
           <c:orientation val="minMax"/>
         </c:scaling>
@@ -1937,7 +1937,7 @@
             <a:endParaRPr lang="de-DE"/>
           </a:p>
         </c:txPr>
-        <c:crossAx val="1319064351"/>
+        <c:crossAx val="49323520"/>
         <c:crosses val="autoZero"/>
         <c:crossBetween val="between"/>
         <c:dispUnits>
@@ -2147,7 +2147,7 @@
           </c:val>
           <c:extLst>
             <c:ext xmlns:c16="http://schemas.microsoft.com/office/drawing/2014/chart" uri="{C3380CC4-5D6E-409C-BE32-E72D297353CC}">
-              <c16:uniqueId val="{00000000-BF6C-451D-AA6B-2A2846B9DFE2}"/>
+              <c16:uniqueId val="{00000000-6EF6-4809-856B-8EA1D231904A}"/>
             </c:ext>
           </c:extLst>
         </c:ser>
@@ -2161,11 +2161,11 @@
         </c:dLbls>
         <c:gapWidth val="219"/>
         <c:overlap val="-27"/>
-        <c:axId val="762693599"/>
-        <c:axId val="1293417103"/>
+        <c:axId val="49307744"/>
+        <c:axId val="1193478576"/>
       </c:barChart>
       <c:dateAx>
-        <c:axId val="762693599"/>
+        <c:axId val="49307744"/>
         <c:scaling>
           <c:orientation val="minMax"/>
         </c:scaling>
@@ -2208,14 +2208,14 @@
             <a:endParaRPr lang="de-DE"/>
           </a:p>
         </c:txPr>
-        <c:crossAx val="1293417103"/>
+        <c:crossAx val="1193478576"/>
         <c:crosses val="autoZero"/>
         <c:auto val="0"/>
         <c:lblOffset val="100"/>
         <c:baseTimeUnit val="months"/>
       </c:dateAx>
       <c:valAx>
-        <c:axId val="1293417103"/>
+        <c:axId val="1193478576"/>
         <c:scaling>
           <c:orientation val="minMax"/>
         </c:scaling>
@@ -2266,7 +2266,7 @@
             <a:endParaRPr lang="de-DE"/>
           </a:p>
         </c:txPr>
-        <c:crossAx val="762693599"/>
+        <c:crossAx val="49307744"/>
         <c:crosses val="autoZero"/>
         <c:crossBetween val="between"/>
       </c:valAx>
@@ -2539,7 +2539,7 @@
           </c:val>
           <c:extLst>
             <c:ext xmlns:c16="http://schemas.microsoft.com/office/drawing/2014/chart" uri="{C3380CC4-5D6E-409C-BE32-E72D297353CC}">
-              <c16:uniqueId val="{00000000-E6DB-4114-9782-40588D0A98A6}"/>
+              <c16:uniqueId val="{00000000-A7F0-4FCA-A3FF-97B46DA82327}"/>
             </c:ext>
           </c:extLst>
         </c:ser>
@@ -2838,7 +2838,7 @@
           </c:val>
           <c:extLst>
             <c:ext xmlns:c16="http://schemas.microsoft.com/office/drawing/2014/chart" uri="{C3380CC4-5D6E-409C-BE32-E72D297353CC}">
-              <c16:uniqueId val="{00000000-19DA-45BD-9B55-6D1D20519AED}"/>
+              <c16:uniqueId val="{00000000-4D23-4B0E-9467-BFB82660AAFA}"/>
             </c:ext>
           </c:extLst>
         </c:ser>
@@ -3022,7 +3022,7 @@
             </c:spPr>
             <c:extLst>
               <c:ext xmlns:c16="http://schemas.microsoft.com/office/drawing/2014/chart" uri="{C3380CC4-5D6E-409C-BE32-E72D297353CC}">
-                <c16:uniqueId val="{00000001-B93C-4005-941A-8028D2A0672E}"/>
+                <c16:uniqueId val="{00000001-6BAE-440B-B6E0-77F1BD464184}"/>
               </c:ext>
             </c:extLst>
           </c:dPt>
@@ -3042,7 +3042,7 @@
             </c:spPr>
             <c:extLst>
               <c:ext xmlns:c16="http://schemas.microsoft.com/office/drawing/2014/chart" uri="{C3380CC4-5D6E-409C-BE32-E72D297353CC}">
-                <c16:uniqueId val="{00000002-B93C-4005-941A-8028D2A0672E}"/>
+                <c16:uniqueId val="{00000002-6BAE-440B-B6E0-77F1BD464184}"/>
               </c:ext>
             </c:extLst>
           </c:dPt>
@@ -3062,7 +3062,7 @@
             </c:spPr>
             <c:extLst>
               <c:ext xmlns:c16="http://schemas.microsoft.com/office/drawing/2014/chart" uri="{C3380CC4-5D6E-409C-BE32-E72D297353CC}">
-                <c16:uniqueId val="{00000003-B93C-4005-941A-8028D2A0672E}"/>
+                <c16:uniqueId val="{00000003-6BAE-440B-B6E0-77F1BD464184}"/>
               </c:ext>
             </c:extLst>
           </c:dPt>
@@ -3130,7 +3130,7 @@
               <c:extLst>
                 <c:ext xmlns:c15="http://schemas.microsoft.com/office/drawing/2012/chart" uri="{CE6537A1-D6FC-4f65-9D91-7224C49458BB}"/>
                 <c:ext xmlns:c16="http://schemas.microsoft.com/office/drawing/2014/chart" uri="{C3380CC4-5D6E-409C-BE32-E72D297353CC}">
-                  <c16:uniqueId val="{00000001-B93C-4005-941A-8028D2A0672E}"/>
+                  <c16:uniqueId val="{00000001-6BAE-440B-B6E0-77F1BD464184}"/>
                 </c:ext>
               </c:extLst>
             </c:dLbl>
@@ -3152,7 +3152,7 @@
               <c:extLst>
                 <c:ext xmlns:c15="http://schemas.microsoft.com/office/drawing/2012/chart" uri="{CE6537A1-D6FC-4f65-9D91-7224C49458BB}"/>
                 <c:ext xmlns:c16="http://schemas.microsoft.com/office/drawing/2014/chart" uri="{C3380CC4-5D6E-409C-BE32-E72D297353CC}">
-                  <c16:uniqueId val="{00000002-B93C-4005-941A-8028D2A0672E}"/>
+                  <c16:uniqueId val="{00000002-6BAE-440B-B6E0-77F1BD464184}"/>
                 </c:ext>
               </c:extLst>
             </c:dLbl>
@@ -3174,7 +3174,7 @@
               <c:extLst>
                 <c:ext xmlns:c15="http://schemas.microsoft.com/office/drawing/2012/chart" uri="{CE6537A1-D6FC-4f65-9D91-7224C49458BB}"/>
                 <c:ext xmlns:c16="http://schemas.microsoft.com/office/drawing/2014/chart" uri="{C3380CC4-5D6E-409C-BE32-E72D297353CC}">
-                  <c16:uniqueId val="{00000003-B93C-4005-941A-8028D2A0672E}"/>
+                  <c16:uniqueId val="{00000003-6BAE-440B-B6E0-77F1BD464184}"/>
                 </c:ext>
               </c:extLst>
             </c:dLbl>
@@ -3288,7 +3288,7 @@
           </c:val>
           <c:extLst>
             <c:ext xmlns:c16="http://schemas.microsoft.com/office/drawing/2014/chart" uri="{C3380CC4-5D6E-409C-BE32-E72D297353CC}">
-              <c16:uniqueId val="{00000000-B93C-4005-941A-8028D2A0672E}"/>
+              <c16:uniqueId val="{00000000-6BAE-440B-B6E0-77F1BD464184}"/>
             </c:ext>
           </c:extLst>
         </c:ser>
@@ -3507,7 +3507,7 @@
           </c:val>
           <c:extLst>
             <c:ext xmlns:c16="http://schemas.microsoft.com/office/drawing/2014/chart" uri="{C3380CC4-5D6E-409C-BE32-E72D297353CC}">
-              <c16:uniqueId val="{00000000-2D78-4C18-9ACC-D4B19181B82F}"/>
+              <c16:uniqueId val="{00000000-21DE-4DEF-84CC-ABF7B6A94DDD}"/>
             </c:ext>
           </c:extLst>
         </c:ser>
@@ -3535,6 +3535,78 @@
             <a:effectLst/>
           </c:spPr>
           <c:invertIfNegative val="0"/>
+          <c:dLbls>
+            <c:dLbl>
+              <c:idx val="2"/>
+              <c:tx>
+                <c:rich>
+                  <a:bodyPr/>
+                  <a:lstStyle/>
+                  <a:p>
+                    <a:r>
+                      <a:rPr lang="de-DE"/>
+                      <a:t>Own text</a:t>
+                    </a:r>
+                  </a:p>
+                </c:rich>
+              </c:tx>
+              <c:showLegendKey val="0"/>
+              <c:showVal val="1"/>
+              <c:showCatName val="0"/>
+              <c:showSerName val="0"/>
+              <c:showPercent val="0"/>
+              <c:showBubbleSize val="0"/>
+              <c:extLst>
+                <c:ext xmlns:c15="http://schemas.microsoft.com/office/drawing/2012/chart" uri="{CE6537A1-D6FC-4f65-9D91-7224C49458BB}">
+                  <c15:showDataLabelsRange val="0"/>
+                </c:ext>
+                <c:ext xmlns:c16="http://schemas.microsoft.com/office/drawing/2014/chart" uri="{C3380CC4-5D6E-409C-BE32-E72D297353CC}">
+                  <c16:uniqueId val="{00000003-21DE-4DEF-84CC-ABF7B6A94DDD}"/>
+                </c:ext>
+              </c:extLst>
+            </c:dLbl>
+            <c:spPr>
+              <a:noFill/>
+              <a:ln>
+                <a:noFill/>
+              </a:ln>
+              <a:effectLst/>
+            </c:spPr>
+            <c:txPr>
+              <a:bodyPr rot="0" spcFirstLastPara="1" vertOverflow="ellipsis" vert="horz" wrap="square" lIns="38100" tIns="19050" rIns="38100" bIns="19050" anchor="ctr" anchorCtr="1">
+                <a:spAutoFit/>
+              </a:bodyPr>
+              <a:lstStyle/>
+              <a:p>
+                <a:pPr>
+                  <a:defRPr sz="1197" b="0" i="0" u="none" strike="noStrike" kern="1200" baseline="0">
+                    <a:solidFill>
+                      <a:schemeClr val="tx1">
+                        <a:lumMod val="75000"/>
+                        <a:lumOff val="25000"/>
+                      </a:schemeClr>
+                    </a:solidFill>
+                    <a:latin typeface="+mn-lt"/>
+                    <a:ea typeface="+mn-ea"/>
+                    <a:cs typeface="+mn-cs"/>
+                  </a:defRPr>
+                </a:pPr>
+                <a:endParaRPr lang="de-DE"/>
+              </a:p>
+            </c:txPr>
+            <c:showLegendKey val="0"/>
+            <c:showVal val="1"/>
+            <c:showCatName val="0"/>
+            <c:showSerName val="0"/>
+            <c:showPercent val="0"/>
+            <c:showBubbleSize val="0"/>
+            <c:showLeaderLines val="0"/>
+            <c:extLst>
+              <c:ext xmlns:c15="http://schemas.microsoft.com/office/drawing/2012/chart" uri="{CE6537A1-D6FC-4f65-9D91-7224C49458BB}">
+                <c15:showLeaderLines val="0"/>
+              </c:ext>
+            </c:extLst>
+          </c:dLbls>
           <c:cat>
             <c:strRef>
               <c:f>Tabelle1!$A$2:$A$5</c:f>
@@ -3578,7 +3650,7 @@
           </c:val>
           <c:extLst>
             <c:ext xmlns:c16="http://schemas.microsoft.com/office/drawing/2014/chart" uri="{C3380CC4-5D6E-409C-BE32-E72D297353CC}">
-              <c16:uniqueId val="{00000001-2D78-4C18-9ACC-D4B19181B82F}"/>
+              <c16:uniqueId val="{00000001-21DE-4DEF-84CC-ABF7B6A94DDD}"/>
             </c:ext>
           </c:extLst>
         </c:ser>
@@ -3649,7 +3721,7 @@
           </c:val>
           <c:extLst>
             <c:ext xmlns:c16="http://schemas.microsoft.com/office/drawing/2014/chart" uri="{C3380CC4-5D6E-409C-BE32-E72D297353CC}">
-              <c16:uniqueId val="{00000002-2D78-4C18-9ACC-D4B19181B82F}"/>
+              <c16:uniqueId val="{00000002-21DE-4DEF-84CC-ABF7B6A94DDD}"/>
             </c:ext>
           </c:extLst>
         </c:ser>
@@ -3662,11 +3734,11 @@
           <c:showBubbleSize val="0"/>
         </c:dLbls>
         <c:gapWidth val="182"/>
-        <c:axId val="1529857184"/>
-        <c:axId val="1293502063"/>
+        <c:axId val="7288768"/>
+        <c:axId val="1193316816"/>
       </c:barChart>
       <c:catAx>
-        <c:axId val="1529857184"/>
+        <c:axId val="7288768"/>
         <c:scaling>
           <c:orientation val="minMax"/>
         </c:scaling>
@@ -3709,7 +3781,7 @@
             <a:endParaRPr lang="de-DE"/>
           </a:p>
         </c:txPr>
-        <c:crossAx val="1293502063"/>
+        <c:crossAx val="1193316816"/>
         <c:crosses val="autoZero"/>
         <c:auto val="1"/>
         <c:lblAlgn val="ctr"/>
@@ -3717,7 +3789,7 @@
         <c:noMultiLvlLbl val="0"/>
       </c:catAx>
       <c:valAx>
-        <c:axId val="1293502063"/>
+        <c:axId val="1193316816"/>
         <c:scaling>
           <c:orientation val="minMax"/>
         </c:scaling>
@@ -3768,7 +3840,7 @@
             <a:endParaRPr lang="de-DE"/>
           </a:p>
         </c:txPr>
-        <c:crossAx val="1529857184"/>
+        <c:crossAx val="7288768"/>
         <c:crosses val="autoZero"/>
         <c:crossBetween val="between"/>
       </c:valAx>
@@ -3933,7 +4005,7 @@
           </c:val>
           <c:extLst>
             <c:ext xmlns:c16="http://schemas.microsoft.com/office/drawing/2014/chart" uri="{C3380CC4-5D6E-409C-BE32-E72D297353CC}">
-              <c16:uniqueId val="{00000000-F2AA-449A-A273-A02BACD51C5A}"/>
+              <c16:uniqueId val="{00000000-D815-4B43-AE13-B0677E3EDC61}"/>
             </c:ext>
           </c:extLst>
         </c:ser>
@@ -4004,7 +4076,7 @@
           </c:val>
           <c:extLst>
             <c:ext xmlns:c16="http://schemas.microsoft.com/office/drawing/2014/chart" uri="{C3380CC4-5D6E-409C-BE32-E72D297353CC}">
-              <c16:uniqueId val="{00000001-F2AA-449A-A273-A02BACD51C5A}"/>
+              <c16:uniqueId val="{00000001-D815-4B43-AE13-B0677E3EDC61}"/>
             </c:ext>
           </c:extLst>
         </c:ser>
@@ -4075,7 +4147,7 @@
           </c:val>
           <c:extLst>
             <c:ext xmlns:c16="http://schemas.microsoft.com/office/drawing/2014/chart" uri="{C3380CC4-5D6E-409C-BE32-E72D297353CC}">
-              <c16:uniqueId val="{00000002-F2AA-449A-A273-A02BACD51C5A}"/>
+              <c16:uniqueId val="{00000002-D815-4B43-AE13-B0677E3EDC61}"/>
             </c:ext>
           </c:extLst>
         </c:ser>
@@ -4089,11 +4161,11 @@
         </c:dLbls>
         <c:gapWidth val="219"/>
         <c:overlap val="-27"/>
-        <c:axId val="1529851152"/>
-        <c:axId val="1293512623"/>
+        <c:axId val="9922928"/>
+        <c:axId val="1193309616"/>
       </c:barChart>
       <c:catAx>
-        <c:axId val="1529851152"/>
+        <c:axId val="9922928"/>
         <c:scaling>
           <c:orientation val="minMax"/>
         </c:scaling>
@@ -4136,7 +4208,7 @@
             <a:endParaRPr lang="de-DE"/>
           </a:p>
         </c:txPr>
-        <c:crossAx val="1293512623"/>
+        <c:crossAx val="1193309616"/>
         <c:crosses val="autoZero"/>
         <c:auto val="1"/>
         <c:lblAlgn val="ctr"/>
@@ -4144,7 +4216,7 @@
         <c:noMultiLvlLbl val="0"/>
       </c:catAx>
       <c:valAx>
-        <c:axId val="1293512623"/>
+        <c:axId val="1193309616"/>
         <c:scaling>
           <c:orientation val="minMax"/>
         </c:scaling>
@@ -4195,7 +4267,7 @@
             <a:endParaRPr lang="de-DE"/>
           </a:p>
         </c:txPr>
-        <c:crossAx val="1529851152"/>
+        <c:crossAx val="9922928"/>
         <c:crosses val="autoZero"/>
         <c:crossBetween val="between"/>
       </c:valAx>
@@ -4250,11 +4322,14 @@
     </c:extLst>
   </c:chart>
   <c:spPr>
-    <a:noFill/>
+    <a:solidFill>
+      <a:srgbClr val="F2F2F2"/>
+    </a:solidFill>
     <a:ln w="38100">
-      <a:noFill/>
+      <a:solidFill>
+        <a:srgbClr val="C00000"/>
+      </a:solidFill>
     </a:ln>
-    <a:effectLst/>
   </c:spPr>
   <c:txPr>
     <a:bodyPr/>
@@ -10376,7 +10451,7 @@
           <p:cNvPr id="2" name="Titel 1">
             <a:extLst>
               <a:ext uri="{FF2B5EF4-FFF2-40B4-BE49-F238E27FC236}">
-                <a16:creationId xmlns:a16="http://schemas.microsoft.com/office/drawing/2014/main" id="{C5EC9F1E-5580-D8E0-16FD-872062022832}"/>
+                <a16:creationId xmlns:a16="http://schemas.microsoft.com/office/drawing/2014/main" id="{0E19AFC3-E2A8-0DB5-FA14-964B6BD91643}"/>
               </a:ext>
             </a:extLst>
           </p:cNvPr>
@@ -10413,7 +10488,7 @@
           <p:cNvPr id="3" name="Untertitel 2">
             <a:extLst>
               <a:ext uri="{FF2B5EF4-FFF2-40B4-BE49-F238E27FC236}">
-                <a16:creationId xmlns:a16="http://schemas.microsoft.com/office/drawing/2014/main" id="{9705955A-DF0A-732A-14CE-AC123A971536}"/>
+                <a16:creationId xmlns:a16="http://schemas.microsoft.com/office/drawing/2014/main" id="{C1846205-EA0C-5F50-859D-C74B12E690C4}"/>
               </a:ext>
             </a:extLst>
           </p:cNvPr>
@@ -10483,7 +10558,7 @@
           <p:cNvPr id="4" name="Datumsplatzhalter 3">
             <a:extLst>
               <a:ext uri="{FF2B5EF4-FFF2-40B4-BE49-F238E27FC236}">
-                <a16:creationId xmlns:a16="http://schemas.microsoft.com/office/drawing/2014/main" id="{AD11646B-BAD1-1E65-E3D4-56E6866F1C14}"/>
+                <a16:creationId xmlns:a16="http://schemas.microsoft.com/office/drawing/2014/main" id="{EDA5AE3A-74CE-22FD-E5BA-EAAF42A3D420}"/>
               </a:ext>
             </a:extLst>
           </p:cNvPr>
@@ -10499,7 +10574,7 @@
           <a:bodyPr/>
           <a:lstStyle/>
           <a:p>
-            <a:fld id="{B4E8FD0B-BEC3-452C-A2F9-2CBD7A952C52}" type="datetimeFigureOut">
+            <a:fld id="{C9962047-E2C8-4734-A689-668B36BC6A1D}" type="datetimeFigureOut">
               <a:rPr lang="de-DE" smtClean="0"/>
               <a:t>09.10.2026</a:t>
             </a:fld>
@@ -10512,7 +10587,7 @@
           <p:cNvPr id="5" name="Fußzeilenplatzhalter 4">
             <a:extLst>
               <a:ext uri="{FF2B5EF4-FFF2-40B4-BE49-F238E27FC236}">
-                <a16:creationId xmlns:a16="http://schemas.microsoft.com/office/drawing/2014/main" id="{ADCA7B39-1263-62BF-50AE-A96DC6359B77}"/>
+                <a16:creationId xmlns:a16="http://schemas.microsoft.com/office/drawing/2014/main" id="{738389DF-8F8B-F67A-4E2E-0FBA7C6C2FAA}"/>
               </a:ext>
             </a:extLst>
           </p:cNvPr>
@@ -10537,7 +10612,7 @@
           <p:cNvPr id="6" name="Foliennummernplatzhalter 5">
             <a:extLst>
               <a:ext uri="{FF2B5EF4-FFF2-40B4-BE49-F238E27FC236}">
-                <a16:creationId xmlns:a16="http://schemas.microsoft.com/office/drawing/2014/main" id="{88E8EB8F-9DB9-2CC8-D8D0-64D0209EC077}"/>
+                <a16:creationId xmlns:a16="http://schemas.microsoft.com/office/drawing/2014/main" id="{E0B13E69-EB74-15BE-C901-50856BA54F44}"/>
               </a:ext>
             </a:extLst>
           </p:cNvPr>
@@ -10553,7 +10628,7 @@
           <a:bodyPr/>
           <a:lstStyle/>
           <a:p>
-            <a:fld id="{06CF1C40-8559-485A-BBC3-736EEB89885C}" type="slidenum">
+            <a:fld id="{377935EF-6752-464A-9B81-BA8CABB6107B}" type="slidenum">
               <a:rPr lang="de-DE" smtClean="0"/>
               <a:t>‹Nr.›</a:t>
             </a:fld>
@@ -10564,7 +10639,7 @@
     </p:spTree>
     <p:extLst>
       <p:ext uri="{BB962C8B-B14F-4D97-AF65-F5344CB8AC3E}">
-        <p14:creationId xmlns:p14="http://schemas.microsoft.com/office/powerpoint/2010/main" val="739931701"/>
+        <p14:creationId xmlns:p14="http://schemas.microsoft.com/office/powerpoint/2010/main" val="2394947834"/>
       </p:ext>
     </p:extLst>
   </p:cSld>
@@ -10596,7 +10671,7 @@
           <p:cNvPr id="2" name="Titel 1">
             <a:extLst>
               <a:ext uri="{FF2B5EF4-FFF2-40B4-BE49-F238E27FC236}">
-                <a16:creationId xmlns:a16="http://schemas.microsoft.com/office/drawing/2014/main" id="{BD89F417-D650-4FC9-2C74-1254088B0AD6}"/>
+                <a16:creationId xmlns:a16="http://schemas.microsoft.com/office/drawing/2014/main" id="{C4849DA7-7AED-0292-B6D9-40887B4DD5A8}"/>
               </a:ext>
             </a:extLst>
           </p:cNvPr>
@@ -10624,7 +10699,7 @@
           <p:cNvPr id="3" name="Vertikaler Textplatzhalter 2">
             <a:extLst>
               <a:ext uri="{FF2B5EF4-FFF2-40B4-BE49-F238E27FC236}">
-                <a16:creationId xmlns:a16="http://schemas.microsoft.com/office/drawing/2014/main" id="{CBE94306-47B2-761A-59F0-B48B49E1F2D6}"/>
+                <a16:creationId xmlns:a16="http://schemas.microsoft.com/office/drawing/2014/main" id="{19AFBBA2-E78A-ACF3-95CF-DD21CD9A5BDE}"/>
               </a:ext>
             </a:extLst>
           </p:cNvPr>
@@ -10681,7 +10756,7 @@
           <p:cNvPr id="4" name="Datumsplatzhalter 3">
             <a:extLst>
               <a:ext uri="{FF2B5EF4-FFF2-40B4-BE49-F238E27FC236}">
-                <a16:creationId xmlns:a16="http://schemas.microsoft.com/office/drawing/2014/main" id="{7D7D29D2-A7B7-54D7-8E38-702EE04B4DA0}"/>
+                <a16:creationId xmlns:a16="http://schemas.microsoft.com/office/drawing/2014/main" id="{D03AA1D4-2CCE-57D2-34F6-D5FC6F1499A8}"/>
               </a:ext>
             </a:extLst>
           </p:cNvPr>
@@ -10697,7 +10772,7 @@
           <a:bodyPr/>
           <a:lstStyle/>
           <a:p>
-            <a:fld id="{B4E8FD0B-BEC3-452C-A2F9-2CBD7A952C52}" type="datetimeFigureOut">
+            <a:fld id="{C9962047-E2C8-4734-A689-668B36BC6A1D}" type="datetimeFigureOut">
               <a:rPr lang="de-DE" smtClean="0"/>
               <a:t>09.10.2026</a:t>
             </a:fld>
@@ -10710,7 +10785,7 @@
           <p:cNvPr id="5" name="Fußzeilenplatzhalter 4">
             <a:extLst>
               <a:ext uri="{FF2B5EF4-FFF2-40B4-BE49-F238E27FC236}">
-                <a16:creationId xmlns:a16="http://schemas.microsoft.com/office/drawing/2014/main" id="{51D69989-6A14-6BDA-6B8D-9FBF22DA0346}"/>
+                <a16:creationId xmlns:a16="http://schemas.microsoft.com/office/drawing/2014/main" id="{C3CA4FBF-7890-AEBE-8904-11F0CDF1D7FF}"/>
               </a:ext>
             </a:extLst>
           </p:cNvPr>
@@ -10735,7 +10810,7 @@
           <p:cNvPr id="6" name="Foliennummernplatzhalter 5">
             <a:extLst>
               <a:ext uri="{FF2B5EF4-FFF2-40B4-BE49-F238E27FC236}">
-                <a16:creationId xmlns:a16="http://schemas.microsoft.com/office/drawing/2014/main" id="{D8BFBA7D-4102-34C2-E8BD-B3EFF6CC0EDE}"/>
+                <a16:creationId xmlns:a16="http://schemas.microsoft.com/office/drawing/2014/main" id="{376AB75F-77AB-FAB0-6AB7-06FA29349283}"/>
               </a:ext>
             </a:extLst>
           </p:cNvPr>
@@ -10751,7 +10826,7 @@
           <a:bodyPr/>
           <a:lstStyle/>
           <a:p>
-            <a:fld id="{06CF1C40-8559-485A-BBC3-736EEB89885C}" type="slidenum">
+            <a:fld id="{377935EF-6752-464A-9B81-BA8CABB6107B}" type="slidenum">
               <a:rPr lang="de-DE" smtClean="0"/>
               <a:t>‹Nr.›</a:t>
             </a:fld>
@@ -10762,7 +10837,7 @@
     </p:spTree>
     <p:extLst>
       <p:ext uri="{BB962C8B-B14F-4D97-AF65-F5344CB8AC3E}">
-        <p14:creationId xmlns:p14="http://schemas.microsoft.com/office/powerpoint/2010/main" val="503979405"/>
+        <p14:creationId xmlns:p14="http://schemas.microsoft.com/office/powerpoint/2010/main" val="3674571750"/>
       </p:ext>
     </p:extLst>
   </p:cSld>
@@ -10794,7 +10869,7 @@
           <p:cNvPr id="2" name="Vertikaler Titel 1">
             <a:extLst>
               <a:ext uri="{FF2B5EF4-FFF2-40B4-BE49-F238E27FC236}">
-                <a16:creationId xmlns:a16="http://schemas.microsoft.com/office/drawing/2014/main" id="{D0FD614E-F4FF-C2F8-D385-A0B876C3337E}"/>
+                <a16:creationId xmlns:a16="http://schemas.microsoft.com/office/drawing/2014/main" id="{61B5C6B4-CEB1-973A-B66F-DDF332725F9D}"/>
               </a:ext>
             </a:extLst>
           </p:cNvPr>
@@ -10827,7 +10902,7 @@
           <p:cNvPr id="3" name="Vertikaler Textplatzhalter 2">
             <a:extLst>
               <a:ext uri="{FF2B5EF4-FFF2-40B4-BE49-F238E27FC236}">
-                <a16:creationId xmlns:a16="http://schemas.microsoft.com/office/drawing/2014/main" id="{6ADB33A3-61D2-E35B-FEA2-C4F9CA26396D}"/>
+                <a16:creationId xmlns:a16="http://schemas.microsoft.com/office/drawing/2014/main" id="{13A9F277-C525-C6A8-1F77-74D63B364017}"/>
               </a:ext>
             </a:extLst>
           </p:cNvPr>
@@ -10889,7 +10964,7 @@
           <p:cNvPr id="4" name="Datumsplatzhalter 3">
             <a:extLst>
               <a:ext uri="{FF2B5EF4-FFF2-40B4-BE49-F238E27FC236}">
-                <a16:creationId xmlns:a16="http://schemas.microsoft.com/office/drawing/2014/main" id="{885BE9BD-5D74-6614-27D3-C3479CC09C4D}"/>
+                <a16:creationId xmlns:a16="http://schemas.microsoft.com/office/drawing/2014/main" id="{7408698F-AA60-FF9D-F9CA-419A9A43638C}"/>
               </a:ext>
             </a:extLst>
           </p:cNvPr>
@@ -10905,7 +10980,7 @@
           <a:bodyPr/>
           <a:lstStyle/>
           <a:p>
-            <a:fld id="{B4E8FD0B-BEC3-452C-A2F9-2CBD7A952C52}" type="datetimeFigureOut">
+            <a:fld id="{C9962047-E2C8-4734-A689-668B36BC6A1D}" type="datetimeFigureOut">
               <a:rPr lang="de-DE" smtClean="0"/>
               <a:t>09.10.2026</a:t>
             </a:fld>
@@ -10918,7 +10993,7 @@
           <p:cNvPr id="5" name="Fußzeilenplatzhalter 4">
             <a:extLst>
               <a:ext uri="{FF2B5EF4-FFF2-40B4-BE49-F238E27FC236}">
-                <a16:creationId xmlns:a16="http://schemas.microsoft.com/office/drawing/2014/main" id="{E1846674-6ACF-8E6D-AA92-A930D1D35111}"/>
+                <a16:creationId xmlns:a16="http://schemas.microsoft.com/office/drawing/2014/main" id="{8FBD0E1D-B72E-A129-CA21-69F1DBD6293F}"/>
               </a:ext>
             </a:extLst>
           </p:cNvPr>
@@ -10943,7 +11018,7 @@
           <p:cNvPr id="6" name="Foliennummernplatzhalter 5">
             <a:extLst>
               <a:ext uri="{FF2B5EF4-FFF2-40B4-BE49-F238E27FC236}">
-                <a16:creationId xmlns:a16="http://schemas.microsoft.com/office/drawing/2014/main" id="{D95DD264-BA10-ADCF-CE68-BEA6ECC9C1A1}"/>
+                <a16:creationId xmlns:a16="http://schemas.microsoft.com/office/drawing/2014/main" id="{688DD645-A71D-6926-E961-E7C2D7D31B18}"/>
               </a:ext>
             </a:extLst>
           </p:cNvPr>
@@ -10959,7 +11034,7 @@
           <a:bodyPr/>
           <a:lstStyle/>
           <a:p>
-            <a:fld id="{06CF1C40-8559-485A-BBC3-736EEB89885C}" type="slidenum">
+            <a:fld id="{377935EF-6752-464A-9B81-BA8CABB6107B}" type="slidenum">
               <a:rPr lang="de-DE" smtClean="0"/>
               <a:t>‹Nr.›</a:t>
             </a:fld>
@@ -10970,7 +11045,7 @@
     </p:spTree>
     <p:extLst>
       <p:ext uri="{BB962C8B-B14F-4D97-AF65-F5344CB8AC3E}">
-        <p14:creationId xmlns:p14="http://schemas.microsoft.com/office/powerpoint/2010/main" val="3020246724"/>
+        <p14:creationId xmlns:p14="http://schemas.microsoft.com/office/powerpoint/2010/main" val="2929395954"/>
       </p:ext>
     </p:extLst>
   </p:cSld>
@@ -11002,7 +11077,7 @@
           <p:cNvPr id="2" name="Titel 1">
             <a:extLst>
               <a:ext uri="{FF2B5EF4-FFF2-40B4-BE49-F238E27FC236}">
-                <a16:creationId xmlns:a16="http://schemas.microsoft.com/office/drawing/2014/main" id="{365F2B8B-9BF6-4B0F-6416-5E09376D3C43}"/>
+                <a16:creationId xmlns:a16="http://schemas.microsoft.com/office/drawing/2014/main" id="{61FB3DD5-27B6-8F7E-68A9-637A294793F8}"/>
               </a:ext>
             </a:extLst>
           </p:cNvPr>
@@ -11030,7 +11105,7 @@
           <p:cNvPr id="3" name="Inhaltsplatzhalter 2">
             <a:extLst>
               <a:ext uri="{FF2B5EF4-FFF2-40B4-BE49-F238E27FC236}">
-                <a16:creationId xmlns:a16="http://schemas.microsoft.com/office/drawing/2014/main" id="{A9CE7B19-ECEA-0901-E246-A6E5681218A2}"/>
+                <a16:creationId xmlns:a16="http://schemas.microsoft.com/office/drawing/2014/main" id="{6D158EB9-F8FF-D110-14AB-3C052A020577}"/>
               </a:ext>
             </a:extLst>
           </p:cNvPr>
@@ -11087,7 +11162,7 @@
           <p:cNvPr id="4" name="Datumsplatzhalter 3">
             <a:extLst>
               <a:ext uri="{FF2B5EF4-FFF2-40B4-BE49-F238E27FC236}">
-                <a16:creationId xmlns:a16="http://schemas.microsoft.com/office/drawing/2014/main" id="{4A104947-F0DB-0810-33F7-DFF1A4270D63}"/>
+                <a16:creationId xmlns:a16="http://schemas.microsoft.com/office/drawing/2014/main" id="{2140605A-56DD-BFF6-4334-653E0EDA353E}"/>
               </a:ext>
             </a:extLst>
           </p:cNvPr>
@@ -11103,7 +11178,7 @@
           <a:bodyPr/>
           <a:lstStyle/>
           <a:p>
-            <a:fld id="{B4E8FD0B-BEC3-452C-A2F9-2CBD7A952C52}" type="datetimeFigureOut">
+            <a:fld id="{C9962047-E2C8-4734-A689-668B36BC6A1D}" type="datetimeFigureOut">
               <a:rPr lang="de-DE" smtClean="0"/>
               <a:t>09.10.2026</a:t>
             </a:fld>
@@ -11116,7 +11191,7 @@
           <p:cNvPr id="5" name="Fußzeilenplatzhalter 4">
             <a:extLst>
               <a:ext uri="{FF2B5EF4-FFF2-40B4-BE49-F238E27FC236}">
-                <a16:creationId xmlns:a16="http://schemas.microsoft.com/office/drawing/2014/main" id="{8C5F5F15-2A0D-94FC-1C99-E889CBF02F75}"/>
+                <a16:creationId xmlns:a16="http://schemas.microsoft.com/office/drawing/2014/main" id="{6FC32648-F6AA-F1C2-99A2-218274DDF7A5}"/>
               </a:ext>
             </a:extLst>
           </p:cNvPr>
@@ -11141,7 +11216,7 @@
           <p:cNvPr id="6" name="Foliennummernplatzhalter 5">
             <a:extLst>
               <a:ext uri="{FF2B5EF4-FFF2-40B4-BE49-F238E27FC236}">
-                <a16:creationId xmlns:a16="http://schemas.microsoft.com/office/drawing/2014/main" id="{C279FD78-1D8E-4362-EC12-3AFC0FB8C2C4}"/>
+                <a16:creationId xmlns:a16="http://schemas.microsoft.com/office/drawing/2014/main" id="{00EFE42B-2473-9A30-2702-4DF340EE2D08}"/>
               </a:ext>
             </a:extLst>
           </p:cNvPr>
@@ -11157,7 +11232,7 @@
           <a:bodyPr/>
           <a:lstStyle/>
           <a:p>
-            <a:fld id="{06CF1C40-8559-485A-BBC3-736EEB89885C}" type="slidenum">
+            <a:fld id="{377935EF-6752-464A-9B81-BA8CABB6107B}" type="slidenum">
               <a:rPr lang="de-DE" smtClean="0"/>
               <a:t>‹Nr.›</a:t>
             </a:fld>
@@ -11168,7 +11243,7 @@
     </p:spTree>
     <p:extLst>
       <p:ext uri="{BB962C8B-B14F-4D97-AF65-F5344CB8AC3E}">
-        <p14:creationId xmlns:p14="http://schemas.microsoft.com/office/powerpoint/2010/main" val="918293886"/>
+        <p14:creationId xmlns:p14="http://schemas.microsoft.com/office/powerpoint/2010/main" val="426050687"/>
       </p:ext>
     </p:extLst>
   </p:cSld>
@@ -11200,7 +11275,7 @@
           <p:cNvPr id="2" name="Titel 1">
             <a:extLst>
               <a:ext uri="{FF2B5EF4-FFF2-40B4-BE49-F238E27FC236}">
-                <a16:creationId xmlns:a16="http://schemas.microsoft.com/office/drawing/2014/main" id="{43E6FD47-17CA-092F-39F7-956C5A553F0F}"/>
+                <a16:creationId xmlns:a16="http://schemas.microsoft.com/office/drawing/2014/main" id="{8348A74A-664C-4C2C-D379-5C858A3B255D}"/>
               </a:ext>
             </a:extLst>
           </p:cNvPr>
@@ -11237,7 +11312,7 @@
           <p:cNvPr id="3" name="Textplatzhalter 2">
             <a:extLst>
               <a:ext uri="{FF2B5EF4-FFF2-40B4-BE49-F238E27FC236}">
-                <a16:creationId xmlns:a16="http://schemas.microsoft.com/office/drawing/2014/main" id="{B7017595-20BC-4C00-2D41-BAC9FBC47256}"/>
+                <a16:creationId xmlns:a16="http://schemas.microsoft.com/office/drawing/2014/main" id="{F7C2EF23-F764-395D-3CFD-067C5959ED84}"/>
               </a:ext>
             </a:extLst>
           </p:cNvPr>
@@ -11362,7 +11437,7 @@
           <p:cNvPr id="4" name="Datumsplatzhalter 3">
             <a:extLst>
               <a:ext uri="{FF2B5EF4-FFF2-40B4-BE49-F238E27FC236}">
-                <a16:creationId xmlns:a16="http://schemas.microsoft.com/office/drawing/2014/main" id="{AB470668-1C68-60D8-58EF-A2BF3D45E337}"/>
+                <a16:creationId xmlns:a16="http://schemas.microsoft.com/office/drawing/2014/main" id="{388DA0E3-530D-1FE4-0EDF-C98C6AA3E857}"/>
               </a:ext>
             </a:extLst>
           </p:cNvPr>
@@ -11378,7 +11453,7 @@
           <a:bodyPr/>
           <a:lstStyle/>
           <a:p>
-            <a:fld id="{B4E8FD0B-BEC3-452C-A2F9-2CBD7A952C52}" type="datetimeFigureOut">
+            <a:fld id="{C9962047-E2C8-4734-A689-668B36BC6A1D}" type="datetimeFigureOut">
               <a:rPr lang="de-DE" smtClean="0"/>
               <a:t>09.10.2026</a:t>
             </a:fld>
@@ -11391,7 +11466,7 @@
           <p:cNvPr id="5" name="Fußzeilenplatzhalter 4">
             <a:extLst>
               <a:ext uri="{FF2B5EF4-FFF2-40B4-BE49-F238E27FC236}">
-                <a16:creationId xmlns:a16="http://schemas.microsoft.com/office/drawing/2014/main" id="{6C41BE4E-118A-D759-1FA0-200A86EB3927}"/>
+                <a16:creationId xmlns:a16="http://schemas.microsoft.com/office/drawing/2014/main" id="{634E895F-102F-88CC-0D58-64E8AB55B896}"/>
               </a:ext>
             </a:extLst>
           </p:cNvPr>
@@ -11416,7 +11491,7 @@
           <p:cNvPr id="6" name="Foliennummernplatzhalter 5">
             <a:extLst>
               <a:ext uri="{FF2B5EF4-FFF2-40B4-BE49-F238E27FC236}">
-                <a16:creationId xmlns:a16="http://schemas.microsoft.com/office/drawing/2014/main" id="{09DD1F21-C473-CDF9-080F-3238F795DED6}"/>
+                <a16:creationId xmlns:a16="http://schemas.microsoft.com/office/drawing/2014/main" id="{E31EB99E-A574-C128-D371-7EE6CE5E724E}"/>
               </a:ext>
             </a:extLst>
           </p:cNvPr>
@@ -11432,7 +11507,7 @@
           <a:bodyPr/>
           <a:lstStyle/>
           <a:p>
-            <a:fld id="{06CF1C40-8559-485A-BBC3-736EEB89885C}" type="slidenum">
+            <a:fld id="{377935EF-6752-464A-9B81-BA8CABB6107B}" type="slidenum">
               <a:rPr lang="de-DE" smtClean="0"/>
               <a:t>‹Nr.›</a:t>
             </a:fld>
@@ -11443,7 +11518,7 @@
     </p:spTree>
     <p:extLst>
       <p:ext uri="{BB962C8B-B14F-4D97-AF65-F5344CB8AC3E}">
-        <p14:creationId xmlns:p14="http://schemas.microsoft.com/office/powerpoint/2010/main" val="3515609582"/>
+        <p14:creationId xmlns:p14="http://schemas.microsoft.com/office/powerpoint/2010/main" val="1768514542"/>
       </p:ext>
     </p:extLst>
   </p:cSld>
@@ -11475,7 +11550,7 @@
           <p:cNvPr id="2" name="Titel 1">
             <a:extLst>
               <a:ext uri="{FF2B5EF4-FFF2-40B4-BE49-F238E27FC236}">
-                <a16:creationId xmlns:a16="http://schemas.microsoft.com/office/drawing/2014/main" id="{00B677F5-70D7-C905-543F-0AF0DD7DBB11}"/>
+                <a16:creationId xmlns:a16="http://schemas.microsoft.com/office/drawing/2014/main" id="{CC1E92D4-B7F2-72BC-B05B-F6BAFA631085}"/>
               </a:ext>
             </a:extLst>
           </p:cNvPr>
@@ -11503,7 +11578,7 @@
           <p:cNvPr id="3" name="Inhaltsplatzhalter 2">
             <a:extLst>
               <a:ext uri="{FF2B5EF4-FFF2-40B4-BE49-F238E27FC236}">
-                <a16:creationId xmlns:a16="http://schemas.microsoft.com/office/drawing/2014/main" id="{AC53D1F5-7020-E5E4-ED02-A6790629F958}"/>
+                <a16:creationId xmlns:a16="http://schemas.microsoft.com/office/drawing/2014/main" id="{8FBE7488-6420-F35D-0C79-FA4A43351BD5}"/>
               </a:ext>
             </a:extLst>
           </p:cNvPr>
@@ -11565,7 +11640,7 @@
           <p:cNvPr id="4" name="Inhaltsplatzhalter 3">
             <a:extLst>
               <a:ext uri="{FF2B5EF4-FFF2-40B4-BE49-F238E27FC236}">
-                <a16:creationId xmlns:a16="http://schemas.microsoft.com/office/drawing/2014/main" id="{18A7CC6E-5DE0-C62C-FBF7-FF7ED7CC73B8}"/>
+                <a16:creationId xmlns:a16="http://schemas.microsoft.com/office/drawing/2014/main" id="{208D87BB-9096-D5C7-3D69-61A7FAE26020}"/>
               </a:ext>
             </a:extLst>
           </p:cNvPr>
@@ -11627,7 +11702,7 @@
           <p:cNvPr id="5" name="Datumsplatzhalter 4">
             <a:extLst>
               <a:ext uri="{FF2B5EF4-FFF2-40B4-BE49-F238E27FC236}">
-                <a16:creationId xmlns:a16="http://schemas.microsoft.com/office/drawing/2014/main" id="{96AB99AB-FEC0-2AE8-16A2-49E497AD617C}"/>
+                <a16:creationId xmlns:a16="http://schemas.microsoft.com/office/drawing/2014/main" id="{9D92772D-6ABC-0E35-9415-D8C972A349B2}"/>
               </a:ext>
             </a:extLst>
           </p:cNvPr>
@@ -11643,7 +11718,7 @@
           <a:bodyPr/>
           <a:lstStyle/>
           <a:p>
-            <a:fld id="{B4E8FD0B-BEC3-452C-A2F9-2CBD7A952C52}" type="datetimeFigureOut">
+            <a:fld id="{C9962047-E2C8-4734-A689-668B36BC6A1D}" type="datetimeFigureOut">
               <a:rPr lang="de-DE" smtClean="0"/>
               <a:t>09.10.2026</a:t>
             </a:fld>
@@ -11656,7 +11731,7 @@
           <p:cNvPr id="6" name="Fußzeilenplatzhalter 5">
             <a:extLst>
               <a:ext uri="{FF2B5EF4-FFF2-40B4-BE49-F238E27FC236}">
-                <a16:creationId xmlns:a16="http://schemas.microsoft.com/office/drawing/2014/main" id="{869A92CD-0BD0-A058-38F1-D21D3802C897}"/>
+                <a16:creationId xmlns:a16="http://schemas.microsoft.com/office/drawing/2014/main" id="{6679E43D-3355-3D46-A3D4-099A5DF83AB0}"/>
               </a:ext>
             </a:extLst>
           </p:cNvPr>
@@ -11681,7 +11756,7 @@
           <p:cNvPr id="7" name="Foliennummernplatzhalter 6">
             <a:extLst>
               <a:ext uri="{FF2B5EF4-FFF2-40B4-BE49-F238E27FC236}">
-                <a16:creationId xmlns:a16="http://schemas.microsoft.com/office/drawing/2014/main" id="{124135F3-C779-303A-919D-EC7CD0D9EB03}"/>
+                <a16:creationId xmlns:a16="http://schemas.microsoft.com/office/drawing/2014/main" id="{25CD6765-E1CA-00F0-65D7-4567100FFB1A}"/>
               </a:ext>
             </a:extLst>
           </p:cNvPr>
@@ -11697,7 +11772,7 @@
           <a:bodyPr/>
           <a:lstStyle/>
           <a:p>
-            <a:fld id="{06CF1C40-8559-485A-BBC3-736EEB89885C}" type="slidenum">
+            <a:fld id="{377935EF-6752-464A-9B81-BA8CABB6107B}" type="slidenum">
               <a:rPr lang="de-DE" smtClean="0"/>
               <a:t>‹Nr.›</a:t>
             </a:fld>
@@ -11708,7 +11783,7 @@
     </p:spTree>
     <p:extLst>
       <p:ext uri="{BB962C8B-B14F-4D97-AF65-F5344CB8AC3E}">
-        <p14:creationId xmlns:p14="http://schemas.microsoft.com/office/powerpoint/2010/main" val="2898741277"/>
+        <p14:creationId xmlns:p14="http://schemas.microsoft.com/office/powerpoint/2010/main" val="1895703322"/>
       </p:ext>
     </p:extLst>
   </p:cSld>
@@ -11740,7 +11815,7 @@
           <p:cNvPr id="2" name="Titel 1">
             <a:extLst>
               <a:ext uri="{FF2B5EF4-FFF2-40B4-BE49-F238E27FC236}">
-                <a16:creationId xmlns:a16="http://schemas.microsoft.com/office/drawing/2014/main" id="{CEAFFA45-AC0B-4464-D6A2-50E6A9953F96}"/>
+                <a16:creationId xmlns:a16="http://schemas.microsoft.com/office/drawing/2014/main" id="{35AEEBCF-22B6-3F98-49F5-B9F2DDB8EFC6}"/>
               </a:ext>
             </a:extLst>
           </p:cNvPr>
@@ -11773,7 +11848,7 @@
           <p:cNvPr id="3" name="Textplatzhalter 2">
             <a:extLst>
               <a:ext uri="{FF2B5EF4-FFF2-40B4-BE49-F238E27FC236}">
-                <a16:creationId xmlns:a16="http://schemas.microsoft.com/office/drawing/2014/main" id="{296432AF-8787-B929-9568-44B386BAAC6D}"/>
+                <a16:creationId xmlns:a16="http://schemas.microsoft.com/office/drawing/2014/main" id="{A5F20308-E00A-7CAD-AC4D-CE341DABCCFE}"/>
               </a:ext>
             </a:extLst>
           </p:cNvPr>
@@ -11844,7 +11919,7 @@
           <p:cNvPr id="4" name="Inhaltsplatzhalter 3">
             <a:extLst>
               <a:ext uri="{FF2B5EF4-FFF2-40B4-BE49-F238E27FC236}">
-                <a16:creationId xmlns:a16="http://schemas.microsoft.com/office/drawing/2014/main" id="{8905409D-90DF-E1A2-2226-BE73822DED43}"/>
+                <a16:creationId xmlns:a16="http://schemas.microsoft.com/office/drawing/2014/main" id="{0091D037-9438-722B-9293-9ADE566ACF3D}"/>
               </a:ext>
             </a:extLst>
           </p:cNvPr>
@@ -11906,7 +11981,7 @@
           <p:cNvPr id="5" name="Textplatzhalter 4">
             <a:extLst>
               <a:ext uri="{FF2B5EF4-FFF2-40B4-BE49-F238E27FC236}">
-                <a16:creationId xmlns:a16="http://schemas.microsoft.com/office/drawing/2014/main" id="{8BE0BD9E-0D68-EDA3-D367-6C680CA29B44}"/>
+                <a16:creationId xmlns:a16="http://schemas.microsoft.com/office/drawing/2014/main" id="{FA259019-FB91-8673-0A6B-8F7EAA389946}"/>
               </a:ext>
             </a:extLst>
           </p:cNvPr>
@@ -11977,7 +12052,7 @@
           <p:cNvPr id="6" name="Inhaltsplatzhalter 5">
             <a:extLst>
               <a:ext uri="{FF2B5EF4-FFF2-40B4-BE49-F238E27FC236}">
-                <a16:creationId xmlns:a16="http://schemas.microsoft.com/office/drawing/2014/main" id="{84B3A2B7-7ADA-2773-CAF5-BFC4D3EF963A}"/>
+                <a16:creationId xmlns:a16="http://schemas.microsoft.com/office/drawing/2014/main" id="{A7535323-9854-90E8-BFF9-0AC471B1A13D}"/>
               </a:ext>
             </a:extLst>
           </p:cNvPr>
@@ -12039,7 +12114,7 @@
           <p:cNvPr id="7" name="Datumsplatzhalter 6">
             <a:extLst>
               <a:ext uri="{FF2B5EF4-FFF2-40B4-BE49-F238E27FC236}">
-                <a16:creationId xmlns:a16="http://schemas.microsoft.com/office/drawing/2014/main" id="{BDC3BCC1-DB9F-0FEA-B120-A49B0AC9E53B}"/>
+                <a16:creationId xmlns:a16="http://schemas.microsoft.com/office/drawing/2014/main" id="{5E3BF176-98A9-141F-6BAB-A109C3C63F64}"/>
               </a:ext>
             </a:extLst>
           </p:cNvPr>
@@ -12055,7 +12130,7 @@
           <a:bodyPr/>
           <a:lstStyle/>
           <a:p>
-            <a:fld id="{B4E8FD0B-BEC3-452C-A2F9-2CBD7A952C52}" type="datetimeFigureOut">
+            <a:fld id="{C9962047-E2C8-4734-A689-668B36BC6A1D}" type="datetimeFigureOut">
               <a:rPr lang="de-DE" smtClean="0"/>
               <a:t>09.10.2026</a:t>
             </a:fld>
@@ -12068,7 +12143,7 @@
           <p:cNvPr id="8" name="Fußzeilenplatzhalter 7">
             <a:extLst>
               <a:ext uri="{FF2B5EF4-FFF2-40B4-BE49-F238E27FC236}">
-                <a16:creationId xmlns:a16="http://schemas.microsoft.com/office/drawing/2014/main" id="{7F23B08C-46E3-8818-918C-7EA56543B557}"/>
+                <a16:creationId xmlns:a16="http://schemas.microsoft.com/office/drawing/2014/main" id="{E45AE3F5-3FEB-498F-2F35-BF711F86D22B}"/>
               </a:ext>
             </a:extLst>
           </p:cNvPr>
@@ -12093,7 +12168,7 @@
           <p:cNvPr id="9" name="Foliennummernplatzhalter 8">
             <a:extLst>
               <a:ext uri="{FF2B5EF4-FFF2-40B4-BE49-F238E27FC236}">
-                <a16:creationId xmlns:a16="http://schemas.microsoft.com/office/drawing/2014/main" id="{730179BD-1E14-8BA4-24CD-330CD91A5F7E}"/>
+                <a16:creationId xmlns:a16="http://schemas.microsoft.com/office/drawing/2014/main" id="{2D456F18-35F1-5141-B2C7-101CE2210F35}"/>
               </a:ext>
             </a:extLst>
           </p:cNvPr>
@@ -12109,7 +12184,7 @@
           <a:bodyPr/>
           <a:lstStyle/>
           <a:p>
-            <a:fld id="{06CF1C40-8559-485A-BBC3-736EEB89885C}" type="slidenum">
+            <a:fld id="{377935EF-6752-464A-9B81-BA8CABB6107B}" type="slidenum">
               <a:rPr lang="de-DE" smtClean="0"/>
               <a:t>‹Nr.›</a:t>
             </a:fld>
@@ -12120,7 +12195,7 @@
     </p:spTree>
     <p:extLst>
       <p:ext uri="{BB962C8B-B14F-4D97-AF65-F5344CB8AC3E}">
-        <p14:creationId xmlns:p14="http://schemas.microsoft.com/office/powerpoint/2010/main" val="1828910930"/>
+        <p14:creationId xmlns:p14="http://schemas.microsoft.com/office/powerpoint/2010/main" val="3958652924"/>
       </p:ext>
     </p:extLst>
   </p:cSld>
@@ -12152,7 +12227,7 @@
           <p:cNvPr id="2" name="Titel 1">
             <a:extLst>
               <a:ext uri="{FF2B5EF4-FFF2-40B4-BE49-F238E27FC236}">
-                <a16:creationId xmlns:a16="http://schemas.microsoft.com/office/drawing/2014/main" id="{5C2A7B97-8DEF-175E-3F3D-E5D2135C449F}"/>
+                <a16:creationId xmlns:a16="http://schemas.microsoft.com/office/drawing/2014/main" id="{0CD36973-E164-7F2F-ADE1-74B16AAC3BA9}"/>
               </a:ext>
             </a:extLst>
           </p:cNvPr>
@@ -12180,7 +12255,7 @@
           <p:cNvPr id="3" name="Datumsplatzhalter 2">
             <a:extLst>
               <a:ext uri="{FF2B5EF4-FFF2-40B4-BE49-F238E27FC236}">
-                <a16:creationId xmlns:a16="http://schemas.microsoft.com/office/drawing/2014/main" id="{42567BD4-FDB9-5DAF-20E9-9BAD2B814CE4}"/>
+                <a16:creationId xmlns:a16="http://schemas.microsoft.com/office/drawing/2014/main" id="{8749C6C8-1B0E-7363-2D9E-AC01F791350A}"/>
               </a:ext>
             </a:extLst>
           </p:cNvPr>
@@ -12196,7 +12271,7 @@
           <a:bodyPr/>
           <a:lstStyle/>
           <a:p>
-            <a:fld id="{B4E8FD0B-BEC3-452C-A2F9-2CBD7A952C52}" type="datetimeFigureOut">
+            <a:fld id="{C9962047-E2C8-4734-A689-668B36BC6A1D}" type="datetimeFigureOut">
               <a:rPr lang="de-DE" smtClean="0"/>
               <a:t>09.10.2026</a:t>
             </a:fld>
@@ -12209,7 +12284,7 @@
           <p:cNvPr id="4" name="Fußzeilenplatzhalter 3">
             <a:extLst>
               <a:ext uri="{FF2B5EF4-FFF2-40B4-BE49-F238E27FC236}">
-                <a16:creationId xmlns:a16="http://schemas.microsoft.com/office/drawing/2014/main" id="{EDAC47A1-F9EE-AF3F-8479-D68EA5A81308}"/>
+                <a16:creationId xmlns:a16="http://schemas.microsoft.com/office/drawing/2014/main" id="{96B94F9A-7AC6-02E3-C999-C2446E8F6EEE}"/>
               </a:ext>
             </a:extLst>
           </p:cNvPr>
@@ -12234,7 +12309,7 @@
           <p:cNvPr id="5" name="Foliennummernplatzhalter 4">
             <a:extLst>
               <a:ext uri="{FF2B5EF4-FFF2-40B4-BE49-F238E27FC236}">
-                <a16:creationId xmlns:a16="http://schemas.microsoft.com/office/drawing/2014/main" id="{9DDFD52D-8BA3-393A-6DF4-BC8F350662E7}"/>
+                <a16:creationId xmlns:a16="http://schemas.microsoft.com/office/drawing/2014/main" id="{07B18CDE-6776-F703-01D8-B5CE5256F1EB}"/>
               </a:ext>
             </a:extLst>
           </p:cNvPr>
@@ -12250,7 +12325,7 @@
           <a:bodyPr/>
           <a:lstStyle/>
           <a:p>
-            <a:fld id="{06CF1C40-8559-485A-BBC3-736EEB89885C}" type="slidenum">
+            <a:fld id="{377935EF-6752-464A-9B81-BA8CABB6107B}" type="slidenum">
               <a:rPr lang="de-DE" smtClean="0"/>
               <a:t>‹Nr.›</a:t>
             </a:fld>
@@ -12261,7 +12336,7 @@
     </p:spTree>
     <p:extLst>
       <p:ext uri="{BB962C8B-B14F-4D97-AF65-F5344CB8AC3E}">
-        <p14:creationId xmlns:p14="http://schemas.microsoft.com/office/powerpoint/2010/main" val="273121254"/>
+        <p14:creationId xmlns:p14="http://schemas.microsoft.com/office/powerpoint/2010/main" val="169783146"/>
       </p:ext>
     </p:extLst>
   </p:cSld>
@@ -12293,7 +12368,7 @@
           <p:cNvPr id="2" name="Datumsplatzhalter 1">
             <a:extLst>
               <a:ext uri="{FF2B5EF4-FFF2-40B4-BE49-F238E27FC236}">
-                <a16:creationId xmlns:a16="http://schemas.microsoft.com/office/drawing/2014/main" id="{D0F1519A-1A86-3D15-6FF7-15162C7868DE}"/>
+                <a16:creationId xmlns:a16="http://schemas.microsoft.com/office/drawing/2014/main" id="{158E9554-FA0B-F30E-7A88-E7B924E35B11}"/>
               </a:ext>
             </a:extLst>
           </p:cNvPr>
@@ -12309,7 +12384,7 @@
           <a:bodyPr/>
           <a:lstStyle/>
           <a:p>
-            <a:fld id="{B4E8FD0B-BEC3-452C-A2F9-2CBD7A952C52}" type="datetimeFigureOut">
+            <a:fld id="{C9962047-E2C8-4734-A689-668B36BC6A1D}" type="datetimeFigureOut">
               <a:rPr lang="de-DE" smtClean="0"/>
               <a:t>09.10.2026</a:t>
             </a:fld>
@@ -12322,7 +12397,7 @@
           <p:cNvPr id="3" name="Fußzeilenplatzhalter 2">
             <a:extLst>
               <a:ext uri="{FF2B5EF4-FFF2-40B4-BE49-F238E27FC236}">
-                <a16:creationId xmlns:a16="http://schemas.microsoft.com/office/drawing/2014/main" id="{B7D0363A-58A0-CA64-D74D-C0203C17328E}"/>
+                <a16:creationId xmlns:a16="http://schemas.microsoft.com/office/drawing/2014/main" id="{3F52906A-5827-DA11-1C5B-D48FAF9FFE0E}"/>
               </a:ext>
             </a:extLst>
           </p:cNvPr>
@@ -12347,7 +12422,7 @@
           <p:cNvPr id="4" name="Foliennummernplatzhalter 3">
             <a:extLst>
               <a:ext uri="{FF2B5EF4-FFF2-40B4-BE49-F238E27FC236}">
-                <a16:creationId xmlns:a16="http://schemas.microsoft.com/office/drawing/2014/main" id="{EB4CF888-C865-B7F7-6FCC-7B8400AAB56F}"/>
+                <a16:creationId xmlns:a16="http://schemas.microsoft.com/office/drawing/2014/main" id="{8F9DC859-2261-56C1-6BC7-8A8A748F9A52}"/>
               </a:ext>
             </a:extLst>
           </p:cNvPr>
@@ -12363,7 +12438,7 @@
           <a:bodyPr/>
           <a:lstStyle/>
           <a:p>
-            <a:fld id="{06CF1C40-8559-485A-BBC3-736EEB89885C}" type="slidenum">
+            <a:fld id="{377935EF-6752-464A-9B81-BA8CABB6107B}" type="slidenum">
               <a:rPr lang="de-DE" smtClean="0"/>
               <a:t>‹Nr.›</a:t>
             </a:fld>
@@ -12374,7 +12449,7 @@
     </p:spTree>
     <p:extLst>
       <p:ext uri="{BB962C8B-B14F-4D97-AF65-F5344CB8AC3E}">
-        <p14:creationId xmlns:p14="http://schemas.microsoft.com/office/powerpoint/2010/main" val="3183152453"/>
+        <p14:creationId xmlns:p14="http://schemas.microsoft.com/office/powerpoint/2010/main" val="1177588628"/>
       </p:ext>
     </p:extLst>
   </p:cSld>
@@ -12406,7 +12481,7 @@
           <p:cNvPr id="2" name="Titel 1">
             <a:extLst>
               <a:ext uri="{FF2B5EF4-FFF2-40B4-BE49-F238E27FC236}">
-                <a16:creationId xmlns:a16="http://schemas.microsoft.com/office/drawing/2014/main" id="{EE197ACE-99FB-787D-FA51-BED56889926E}"/>
+                <a16:creationId xmlns:a16="http://schemas.microsoft.com/office/drawing/2014/main" id="{C308A7BC-173E-1950-4483-C7EB83B61D49}"/>
               </a:ext>
             </a:extLst>
           </p:cNvPr>
@@ -12443,7 +12518,7 @@
           <p:cNvPr id="3" name="Inhaltsplatzhalter 2">
             <a:extLst>
               <a:ext uri="{FF2B5EF4-FFF2-40B4-BE49-F238E27FC236}">
-                <a16:creationId xmlns:a16="http://schemas.microsoft.com/office/drawing/2014/main" id="{16AAA19B-56D1-2D69-2014-649E0003AD98}"/>
+                <a16:creationId xmlns:a16="http://schemas.microsoft.com/office/drawing/2014/main" id="{49C968DD-E16F-5781-2591-D0C44BE24CD2}"/>
               </a:ext>
             </a:extLst>
           </p:cNvPr>
@@ -12533,7 +12608,7 @@
           <p:cNvPr id="4" name="Textplatzhalter 3">
             <a:extLst>
               <a:ext uri="{FF2B5EF4-FFF2-40B4-BE49-F238E27FC236}">
-                <a16:creationId xmlns:a16="http://schemas.microsoft.com/office/drawing/2014/main" id="{D30C1151-24B8-07F9-9FD3-59F082FF2A1E}"/>
+                <a16:creationId xmlns:a16="http://schemas.microsoft.com/office/drawing/2014/main" id="{0B094689-8E08-F31B-1118-170B9C7F44C1}"/>
               </a:ext>
             </a:extLst>
           </p:cNvPr>
@@ -12604,7 +12679,7 @@
           <p:cNvPr id="5" name="Datumsplatzhalter 4">
             <a:extLst>
               <a:ext uri="{FF2B5EF4-FFF2-40B4-BE49-F238E27FC236}">
-                <a16:creationId xmlns:a16="http://schemas.microsoft.com/office/drawing/2014/main" id="{7CC44BF8-A68D-5802-FAE8-06DFD175E22C}"/>
+                <a16:creationId xmlns:a16="http://schemas.microsoft.com/office/drawing/2014/main" id="{7B0FD140-7B5F-380D-B51A-4DE60F181BD5}"/>
               </a:ext>
             </a:extLst>
           </p:cNvPr>
@@ -12620,7 +12695,7 @@
           <a:bodyPr/>
           <a:lstStyle/>
           <a:p>
-            <a:fld id="{B4E8FD0B-BEC3-452C-A2F9-2CBD7A952C52}" type="datetimeFigureOut">
+            <a:fld id="{C9962047-E2C8-4734-A689-668B36BC6A1D}" type="datetimeFigureOut">
               <a:rPr lang="de-DE" smtClean="0"/>
               <a:t>09.10.2026</a:t>
             </a:fld>
@@ -12633,7 +12708,7 @@
           <p:cNvPr id="6" name="Fußzeilenplatzhalter 5">
             <a:extLst>
               <a:ext uri="{FF2B5EF4-FFF2-40B4-BE49-F238E27FC236}">
-                <a16:creationId xmlns:a16="http://schemas.microsoft.com/office/drawing/2014/main" id="{1F5D536B-CE77-05B5-7BDC-F88CC722206A}"/>
+                <a16:creationId xmlns:a16="http://schemas.microsoft.com/office/drawing/2014/main" id="{6F92BBD0-2657-2EB2-0A74-4F49C69ECDAF}"/>
               </a:ext>
             </a:extLst>
           </p:cNvPr>
@@ -12658,7 +12733,7 @@
           <p:cNvPr id="7" name="Foliennummernplatzhalter 6">
             <a:extLst>
               <a:ext uri="{FF2B5EF4-FFF2-40B4-BE49-F238E27FC236}">
-                <a16:creationId xmlns:a16="http://schemas.microsoft.com/office/drawing/2014/main" id="{95E1724A-6DF0-EF2C-DF1D-40A1D7394A1C}"/>
+                <a16:creationId xmlns:a16="http://schemas.microsoft.com/office/drawing/2014/main" id="{63C5E45C-8966-BA9E-BE27-097E6D3BC534}"/>
               </a:ext>
             </a:extLst>
           </p:cNvPr>
@@ -12674,7 +12749,7 @@
           <a:bodyPr/>
           <a:lstStyle/>
           <a:p>
-            <a:fld id="{06CF1C40-8559-485A-BBC3-736EEB89885C}" type="slidenum">
+            <a:fld id="{377935EF-6752-464A-9B81-BA8CABB6107B}" type="slidenum">
               <a:rPr lang="de-DE" smtClean="0"/>
               <a:t>‹Nr.›</a:t>
             </a:fld>
@@ -12685,7 +12760,7 @@
     </p:spTree>
     <p:extLst>
       <p:ext uri="{BB962C8B-B14F-4D97-AF65-F5344CB8AC3E}">
-        <p14:creationId xmlns:p14="http://schemas.microsoft.com/office/powerpoint/2010/main" val="581704940"/>
+        <p14:creationId xmlns:p14="http://schemas.microsoft.com/office/powerpoint/2010/main" val="1848074316"/>
       </p:ext>
     </p:extLst>
   </p:cSld>
@@ -12717,7 +12792,7 @@
           <p:cNvPr id="2" name="Titel 1">
             <a:extLst>
               <a:ext uri="{FF2B5EF4-FFF2-40B4-BE49-F238E27FC236}">
-                <a16:creationId xmlns:a16="http://schemas.microsoft.com/office/drawing/2014/main" id="{BE4C10DA-F790-A759-0A99-02D1EAA9E951}"/>
+                <a16:creationId xmlns:a16="http://schemas.microsoft.com/office/drawing/2014/main" id="{14CD96D7-1832-F3B8-9842-C2AB2F369333}"/>
               </a:ext>
             </a:extLst>
           </p:cNvPr>
@@ -12754,7 +12829,7 @@
           <p:cNvPr id="3" name="Bildplatzhalter 2">
             <a:extLst>
               <a:ext uri="{FF2B5EF4-FFF2-40B4-BE49-F238E27FC236}">
-                <a16:creationId xmlns:a16="http://schemas.microsoft.com/office/drawing/2014/main" id="{296A7C43-D5E1-82AF-A1C7-9BE03F1C4ABB}"/>
+                <a16:creationId xmlns:a16="http://schemas.microsoft.com/office/drawing/2014/main" id="{065477DC-3A8F-4FA1-2657-57EBDE61CD42}"/>
               </a:ext>
             </a:extLst>
           </p:cNvPr>
@@ -12821,7 +12896,7 @@
           <p:cNvPr id="4" name="Textplatzhalter 3">
             <a:extLst>
               <a:ext uri="{FF2B5EF4-FFF2-40B4-BE49-F238E27FC236}">
-                <a16:creationId xmlns:a16="http://schemas.microsoft.com/office/drawing/2014/main" id="{813A8603-8A67-0D53-AA11-B381084C7400}"/>
+                <a16:creationId xmlns:a16="http://schemas.microsoft.com/office/drawing/2014/main" id="{64E94A0F-249A-4F8B-2A13-58551DA6368A}"/>
               </a:ext>
             </a:extLst>
           </p:cNvPr>
@@ -12892,7 +12967,7 @@
           <p:cNvPr id="5" name="Datumsplatzhalter 4">
             <a:extLst>
               <a:ext uri="{FF2B5EF4-FFF2-40B4-BE49-F238E27FC236}">
-                <a16:creationId xmlns:a16="http://schemas.microsoft.com/office/drawing/2014/main" id="{94CE3DA0-7594-CBDF-D8E0-1E3D70981215}"/>
+                <a16:creationId xmlns:a16="http://schemas.microsoft.com/office/drawing/2014/main" id="{5897B951-D8FE-0CC1-9BE2-5B2364167F77}"/>
               </a:ext>
             </a:extLst>
           </p:cNvPr>
@@ -12908,7 +12983,7 @@
           <a:bodyPr/>
           <a:lstStyle/>
           <a:p>
-            <a:fld id="{B4E8FD0B-BEC3-452C-A2F9-2CBD7A952C52}" type="datetimeFigureOut">
+            <a:fld id="{C9962047-E2C8-4734-A689-668B36BC6A1D}" type="datetimeFigureOut">
               <a:rPr lang="de-DE" smtClean="0"/>
               <a:t>09.10.2026</a:t>
             </a:fld>
@@ -12921,7 +12996,7 @@
           <p:cNvPr id="6" name="Fußzeilenplatzhalter 5">
             <a:extLst>
               <a:ext uri="{FF2B5EF4-FFF2-40B4-BE49-F238E27FC236}">
-                <a16:creationId xmlns:a16="http://schemas.microsoft.com/office/drawing/2014/main" id="{67B2F337-C84A-CCCE-1201-C7D53DD782DB}"/>
+                <a16:creationId xmlns:a16="http://schemas.microsoft.com/office/drawing/2014/main" id="{F598447C-5F4F-4037-8549-1DB1952A21E9}"/>
               </a:ext>
             </a:extLst>
           </p:cNvPr>
@@ -12946,7 +13021,7 @@
           <p:cNvPr id="7" name="Foliennummernplatzhalter 6">
             <a:extLst>
               <a:ext uri="{FF2B5EF4-FFF2-40B4-BE49-F238E27FC236}">
-                <a16:creationId xmlns:a16="http://schemas.microsoft.com/office/drawing/2014/main" id="{20210F27-57C3-AD57-91DF-C8809E890CB9}"/>
+                <a16:creationId xmlns:a16="http://schemas.microsoft.com/office/drawing/2014/main" id="{C6CAED72-85B7-E6AD-2B12-A1DFF0A3B352}"/>
               </a:ext>
             </a:extLst>
           </p:cNvPr>
@@ -12962,7 +13037,7 @@
           <a:bodyPr/>
           <a:lstStyle/>
           <a:p>
-            <a:fld id="{06CF1C40-8559-485A-BBC3-736EEB89885C}" type="slidenum">
+            <a:fld id="{377935EF-6752-464A-9B81-BA8CABB6107B}" type="slidenum">
               <a:rPr lang="de-DE" smtClean="0"/>
               <a:t>‹Nr.›</a:t>
             </a:fld>
@@ -12973,7 +13048,7 @@
     </p:spTree>
     <p:extLst>
       <p:ext uri="{BB962C8B-B14F-4D97-AF65-F5344CB8AC3E}">
-        <p14:creationId xmlns:p14="http://schemas.microsoft.com/office/powerpoint/2010/main" val="3197101087"/>
+        <p14:creationId xmlns:p14="http://schemas.microsoft.com/office/powerpoint/2010/main" val="3927644076"/>
       </p:ext>
     </p:extLst>
   </p:cSld>
@@ -13010,7 +13085,7 @@
           <p:cNvPr id="2" name="Titelplatzhalter 1">
             <a:extLst>
               <a:ext uri="{FF2B5EF4-FFF2-40B4-BE49-F238E27FC236}">
-                <a16:creationId xmlns:a16="http://schemas.microsoft.com/office/drawing/2014/main" id="{9A0AB17B-94E4-ED70-B6A5-C6A3BF7C3A67}"/>
+                <a16:creationId xmlns:a16="http://schemas.microsoft.com/office/drawing/2014/main" id="{48AF5C9E-86AA-08EC-FAA7-CC4932ED966B}"/>
               </a:ext>
             </a:extLst>
           </p:cNvPr>
@@ -13048,7 +13123,7 @@
           <p:cNvPr id="3" name="Textplatzhalter 2">
             <a:extLst>
               <a:ext uri="{FF2B5EF4-FFF2-40B4-BE49-F238E27FC236}">
-                <a16:creationId xmlns:a16="http://schemas.microsoft.com/office/drawing/2014/main" id="{D1F99CD3-D016-1D06-640D-BB80D86BAADD}"/>
+                <a16:creationId xmlns:a16="http://schemas.microsoft.com/office/drawing/2014/main" id="{F5EAB3AB-9B8B-780F-02EB-845E2095ACFC}"/>
               </a:ext>
             </a:extLst>
           </p:cNvPr>
@@ -13115,7 +13190,7 @@
           <p:cNvPr id="4" name="Datumsplatzhalter 3">
             <a:extLst>
               <a:ext uri="{FF2B5EF4-FFF2-40B4-BE49-F238E27FC236}">
-                <a16:creationId xmlns:a16="http://schemas.microsoft.com/office/drawing/2014/main" id="{FF9845B9-0B32-F8CE-2455-70422B8165D8}"/>
+                <a16:creationId xmlns:a16="http://schemas.microsoft.com/office/drawing/2014/main" id="{56F16CA4-79D3-C070-004C-B4263D2E5270}"/>
               </a:ext>
             </a:extLst>
           </p:cNvPr>
@@ -13149,7 +13224,7 @@
             </a:lvl1pPr>
           </a:lstStyle>
           <a:p>
-            <a:fld id="{B4E8FD0B-BEC3-452C-A2F9-2CBD7A952C52}" type="datetimeFigureOut">
+            <a:fld id="{C9962047-E2C8-4734-A689-668B36BC6A1D}" type="datetimeFigureOut">
               <a:rPr lang="de-DE" smtClean="0"/>
               <a:t>09.10.2026</a:t>
             </a:fld>
@@ -13162,7 +13237,7 @@
           <p:cNvPr id="5" name="Fußzeilenplatzhalter 4">
             <a:extLst>
               <a:ext uri="{FF2B5EF4-FFF2-40B4-BE49-F238E27FC236}">
-                <a16:creationId xmlns:a16="http://schemas.microsoft.com/office/drawing/2014/main" id="{6FFAD640-3F35-CC4D-B27E-DAE1C81F45D4}"/>
+                <a16:creationId xmlns:a16="http://schemas.microsoft.com/office/drawing/2014/main" id="{1E85DF77-F128-4654-BFE8-DEABCE832339}"/>
               </a:ext>
             </a:extLst>
           </p:cNvPr>
@@ -13205,7 +13280,7 @@
           <p:cNvPr id="6" name="Foliennummernplatzhalter 5">
             <a:extLst>
               <a:ext uri="{FF2B5EF4-FFF2-40B4-BE49-F238E27FC236}">
-                <a16:creationId xmlns:a16="http://schemas.microsoft.com/office/drawing/2014/main" id="{A1594835-471D-911B-25DC-F582C11F7D5B}"/>
+                <a16:creationId xmlns:a16="http://schemas.microsoft.com/office/drawing/2014/main" id="{0C936764-7B3D-A5D8-779A-73F3E7A778BF}"/>
               </a:ext>
             </a:extLst>
           </p:cNvPr>
@@ -13239,7 +13314,7 @@
             </a:lvl1pPr>
           </a:lstStyle>
           <a:p>
-            <a:fld id="{06CF1C40-8559-485A-BBC3-736EEB89885C}" type="slidenum">
+            <a:fld id="{377935EF-6752-464A-9B81-BA8CABB6107B}" type="slidenum">
               <a:rPr lang="de-DE" smtClean="0"/>
               <a:t>‹Nr.›</a:t>
             </a:fld>
@@ -13250,7 +13325,7 @@
     </p:spTree>
     <p:extLst>
       <p:ext uri="{BB962C8B-B14F-4D97-AF65-F5344CB8AC3E}">
-        <p14:creationId xmlns:p14="http://schemas.microsoft.com/office/powerpoint/2010/main" val="1827687098"/>
+        <p14:creationId xmlns:p14="http://schemas.microsoft.com/office/powerpoint/2010/main" val="2024606226"/>
       </p:ext>
     </p:extLst>
   </p:cSld>
@@ -13573,7 +13648,7 @@
           <p:cNvPr id="2" name="Titel 1">
             <a:extLst>
               <a:ext uri="{FF2B5EF4-FFF2-40B4-BE49-F238E27FC236}">
-                <a16:creationId xmlns:a16="http://schemas.microsoft.com/office/drawing/2014/main" id="{42DB15F6-6172-B248-8669-E0D65E5CE539}"/>
+                <a16:creationId xmlns:a16="http://schemas.microsoft.com/office/drawing/2014/main" id="{53EAACA3-EA18-3ACE-25AC-E907D276298B}"/>
               </a:ext>
             </a:extLst>
           </p:cNvPr>
@@ -13602,7 +13677,7 @@
           <p:cNvPr id="3" name="Diagramm 2">
             <a:extLst>
               <a:ext uri="{FF2B5EF4-FFF2-40B4-BE49-F238E27FC236}">
-                <a16:creationId xmlns:a16="http://schemas.microsoft.com/office/drawing/2014/main" id="{01C06C77-653D-0003-3134-6F1FFB4B33A8}"/>
+                <a16:creationId xmlns:a16="http://schemas.microsoft.com/office/drawing/2014/main" id="{3C01D9CD-217A-BF19-0576-56876BED3974}"/>
               </a:ext>
             </a:extLst>
           </p:cNvPr>
@@ -13610,7 +13685,7 @@
           <p:nvPr>
             <p:extLst>
               <p:ext uri="{D42A27DB-BD31-4B8C-83A1-F6EECF244321}">
-                <p14:modId xmlns:p14="http://schemas.microsoft.com/office/powerpoint/2010/main" val="3328303671"/>
+                <p14:modId xmlns:p14="http://schemas.microsoft.com/office/powerpoint/2010/main" val="1182428717"/>
               </p:ext>
             </p:extLst>
           </p:nvPr>
@@ -13630,7 +13705,7 @@
           <p:cNvPr id="4" name="Diagramm 3">
             <a:extLst>
               <a:ext uri="{FF2B5EF4-FFF2-40B4-BE49-F238E27FC236}">
-                <a16:creationId xmlns:a16="http://schemas.microsoft.com/office/drawing/2014/main" id="{5DE022C0-30D9-FFD0-FB62-169EC22067B0}"/>
+                <a16:creationId xmlns:a16="http://schemas.microsoft.com/office/drawing/2014/main" id="{004CD60A-EE22-DC67-2238-21BD621425C7}"/>
               </a:ext>
             </a:extLst>
           </p:cNvPr>
@@ -13638,7 +13713,7 @@
           <p:nvPr>
             <p:extLst>
               <p:ext uri="{D42A27DB-BD31-4B8C-83A1-F6EECF244321}">
-                <p14:modId xmlns:p14="http://schemas.microsoft.com/office/powerpoint/2010/main" val="3054068498"/>
+                <p14:modId xmlns:p14="http://schemas.microsoft.com/office/powerpoint/2010/main" val="213811935"/>
               </p:ext>
             </p:extLst>
           </p:nvPr>
@@ -13656,7 +13731,7 @@
     </p:spTree>
     <p:extLst>
       <p:ext uri="{BB962C8B-B14F-4D97-AF65-F5344CB8AC3E}">
-        <p14:creationId xmlns:p14="http://schemas.microsoft.com/office/powerpoint/2010/main" val="2219254677"/>
+        <p14:creationId xmlns:p14="http://schemas.microsoft.com/office/powerpoint/2010/main" val="574115935"/>
       </p:ext>
     </p:extLst>
   </p:cSld>
@@ -13688,7 +13763,7 @@
           <p:cNvPr id="2" name="Titel 1">
             <a:extLst>
               <a:ext uri="{FF2B5EF4-FFF2-40B4-BE49-F238E27FC236}">
-                <a16:creationId xmlns:a16="http://schemas.microsoft.com/office/drawing/2014/main" id="{4F6080D1-0C68-2979-5787-3D8562B2B76F}"/>
+                <a16:creationId xmlns:a16="http://schemas.microsoft.com/office/drawing/2014/main" id="{55B283F3-AAE8-6F9F-3294-65661F15FE66}"/>
               </a:ext>
             </a:extLst>
           </p:cNvPr>
@@ -13717,7 +13792,7 @@
           <p:cNvPr id="3" name="Diagramm 2">
             <a:extLst>
               <a:ext uri="{FF2B5EF4-FFF2-40B4-BE49-F238E27FC236}">
-                <a16:creationId xmlns:a16="http://schemas.microsoft.com/office/drawing/2014/main" id="{81D1604C-1B05-FC82-6A79-A27A88C8C45C}"/>
+                <a16:creationId xmlns:a16="http://schemas.microsoft.com/office/drawing/2014/main" id="{AA9C8BB1-BC88-4A6B-7042-5392F19B64BA}"/>
               </a:ext>
             </a:extLst>
           </p:cNvPr>
@@ -13725,7 +13800,7 @@
           <p:nvPr>
             <p:extLst>
               <p:ext uri="{D42A27DB-BD31-4B8C-83A1-F6EECF244321}">
-                <p14:modId xmlns:p14="http://schemas.microsoft.com/office/powerpoint/2010/main" val="2534443672"/>
+                <p14:modId xmlns:p14="http://schemas.microsoft.com/office/powerpoint/2010/main" val="140767115"/>
               </p:ext>
             </p:extLst>
           </p:nvPr>
@@ -13745,7 +13820,7 @@
           <p:cNvPr id="4" name="Diagramm 3">
             <a:extLst>
               <a:ext uri="{FF2B5EF4-FFF2-40B4-BE49-F238E27FC236}">
-                <a16:creationId xmlns:a16="http://schemas.microsoft.com/office/drawing/2014/main" id="{470B58BA-DDE8-C69E-3CB9-C1AD08BC611B}"/>
+                <a16:creationId xmlns:a16="http://schemas.microsoft.com/office/drawing/2014/main" id="{6DCDB0FD-B923-D61B-B587-5E08AECC82FD}"/>
               </a:ext>
             </a:extLst>
           </p:cNvPr>
@@ -13753,7 +13828,7 @@
           <p:nvPr>
             <p:extLst>
               <p:ext uri="{D42A27DB-BD31-4B8C-83A1-F6EECF244321}">
-                <p14:modId xmlns:p14="http://schemas.microsoft.com/office/powerpoint/2010/main" val="4103862961"/>
+                <p14:modId xmlns:p14="http://schemas.microsoft.com/office/powerpoint/2010/main" val="3640681988"/>
               </p:ext>
             </p:extLst>
           </p:nvPr>
@@ -13771,7 +13846,7 @@
     </p:spTree>
     <p:extLst>
       <p:ext uri="{BB962C8B-B14F-4D97-AF65-F5344CB8AC3E}">
-        <p14:creationId xmlns:p14="http://schemas.microsoft.com/office/powerpoint/2010/main" val="568557169"/>
+        <p14:creationId xmlns:p14="http://schemas.microsoft.com/office/powerpoint/2010/main" val="809531301"/>
       </p:ext>
     </p:extLst>
   </p:cSld>
@@ -13803,7 +13878,7 @@
           <p:cNvPr id="2" name="Titel 1">
             <a:extLst>
               <a:ext uri="{FF2B5EF4-FFF2-40B4-BE49-F238E27FC236}">
-                <a16:creationId xmlns:a16="http://schemas.microsoft.com/office/drawing/2014/main" id="{BA5D2A6B-B2AF-936F-209B-B5E4F0A86961}"/>
+                <a16:creationId xmlns:a16="http://schemas.microsoft.com/office/drawing/2014/main" id="{17EF85DC-365B-8C08-DF61-5F2A0C62A9DA}"/>
               </a:ext>
             </a:extLst>
           </p:cNvPr>
@@ -13832,7 +13907,7 @@
           <p:cNvPr id="3" name="Diagramm 2">
             <a:extLst>
               <a:ext uri="{FF2B5EF4-FFF2-40B4-BE49-F238E27FC236}">
-                <a16:creationId xmlns:a16="http://schemas.microsoft.com/office/drawing/2014/main" id="{71CC4C9B-DF55-6291-78BF-BBA729C076B6}"/>
+                <a16:creationId xmlns:a16="http://schemas.microsoft.com/office/drawing/2014/main" id="{EF7938AA-373C-4FDC-20F0-03B14C0E1B61}"/>
               </a:ext>
             </a:extLst>
           </p:cNvPr>
@@ -13840,7 +13915,7 @@
           <p:nvPr>
             <p:extLst>
               <p:ext uri="{D42A27DB-BD31-4B8C-83A1-F6EECF244321}">
-                <p14:modId xmlns:p14="http://schemas.microsoft.com/office/powerpoint/2010/main" val="4075858349"/>
+                <p14:modId xmlns:p14="http://schemas.microsoft.com/office/powerpoint/2010/main" val="305480100"/>
               </p:ext>
             </p:extLst>
           </p:nvPr>
@@ -13860,7 +13935,7 @@
           <p:cNvPr id="4" name="Diagramm 3">
             <a:extLst>
               <a:ext uri="{FF2B5EF4-FFF2-40B4-BE49-F238E27FC236}">
-                <a16:creationId xmlns:a16="http://schemas.microsoft.com/office/drawing/2014/main" id="{21704992-5ABE-E014-E79E-C5BC7EF93E1A}"/>
+                <a16:creationId xmlns:a16="http://schemas.microsoft.com/office/drawing/2014/main" id="{16BE79A1-D4CD-2A81-165B-E9C78AEF96FC}"/>
               </a:ext>
             </a:extLst>
           </p:cNvPr>
@@ -13868,7 +13943,7 @@
           <p:nvPr>
             <p:extLst>
               <p:ext uri="{D42A27DB-BD31-4B8C-83A1-F6EECF244321}">
-                <p14:modId xmlns:p14="http://schemas.microsoft.com/office/powerpoint/2010/main" val="1087504404"/>
+                <p14:modId xmlns:p14="http://schemas.microsoft.com/office/powerpoint/2010/main" val="3610986942"/>
               </p:ext>
             </p:extLst>
           </p:nvPr>
@@ -13886,7 +13961,7 @@
     </p:spTree>
     <p:extLst>
       <p:ext uri="{BB962C8B-B14F-4D97-AF65-F5344CB8AC3E}">
-        <p14:creationId xmlns:p14="http://schemas.microsoft.com/office/powerpoint/2010/main" val="3735687364"/>
+        <p14:creationId xmlns:p14="http://schemas.microsoft.com/office/powerpoint/2010/main" val="1911903433"/>
       </p:ext>
     </p:extLst>
   </p:cSld>
@@ -13918,7 +13993,7 @@
           <p:cNvPr id="2" name="Titel 1">
             <a:extLst>
               <a:ext uri="{FF2B5EF4-FFF2-40B4-BE49-F238E27FC236}">
-                <a16:creationId xmlns:a16="http://schemas.microsoft.com/office/drawing/2014/main" id="{22A8608E-CC26-9A27-A886-35BD20C72CE1}"/>
+                <a16:creationId xmlns:a16="http://schemas.microsoft.com/office/drawing/2014/main" id="{2B29FBC4-6C87-A850-5505-08939A71CAED}"/>
               </a:ext>
             </a:extLst>
           </p:cNvPr>
@@ -13947,7 +14022,7 @@
           <p:cNvPr id="3" name="Diagramm 2">
             <a:extLst>
               <a:ext uri="{FF2B5EF4-FFF2-40B4-BE49-F238E27FC236}">
-                <a16:creationId xmlns:a16="http://schemas.microsoft.com/office/drawing/2014/main" id="{9890EBE1-15E6-7622-0413-C7E204E28409}"/>
+                <a16:creationId xmlns:a16="http://schemas.microsoft.com/office/drawing/2014/main" id="{29DD8E1E-9EE9-47DA-54CA-EB348088445C}"/>
               </a:ext>
             </a:extLst>
           </p:cNvPr>
@@ -13955,7 +14030,7 @@
           <p:nvPr>
             <p:extLst>
               <p:ext uri="{D42A27DB-BD31-4B8C-83A1-F6EECF244321}">
-                <p14:modId xmlns:p14="http://schemas.microsoft.com/office/powerpoint/2010/main" val="1991838621"/>
+                <p14:modId xmlns:p14="http://schemas.microsoft.com/office/powerpoint/2010/main" val="1272251118"/>
               </p:ext>
             </p:extLst>
           </p:nvPr>
@@ -13975,7 +14050,7 @@
           <p:cNvPr id="4" name="Diagramm 3">
             <a:extLst>
               <a:ext uri="{FF2B5EF4-FFF2-40B4-BE49-F238E27FC236}">
-                <a16:creationId xmlns:a16="http://schemas.microsoft.com/office/drawing/2014/main" id="{A0BC1F1E-3F01-5522-5900-8F79D6A07348}"/>
+                <a16:creationId xmlns:a16="http://schemas.microsoft.com/office/drawing/2014/main" id="{8B5A2F1B-4046-67F1-4BD6-AEB895ACD733}"/>
               </a:ext>
             </a:extLst>
           </p:cNvPr>
@@ -13983,7 +14058,7 @@
           <p:nvPr>
             <p:extLst>
               <p:ext uri="{D42A27DB-BD31-4B8C-83A1-F6EECF244321}">
-                <p14:modId xmlns:p14="http://schemas.microsoft.com/office/powerpoint/2010/main" val="2313407440"/>
+                <p14:modId xmlns:p14="http://schemas.microsoft.com/office/powerpoint/2010/main" val="85409089"/>
               </p:ext>
             </p:extLst>
           </p:nvPr>
@@ -14001,7 +14076,7 @@
     </p:spTree>
     <p:extLst>
       <p:ext uri="{BB962C8B-B14F-4D97-AF65-F5344CB8AC3E}">
-        <p14:creationId xmlns:p14="http://schemas.microsoft.com/office/powerpoint/2010/main" val="2699520542"/>
+        <p14:creationId xmlns:p14="http://schemas.microsoft.com/office/powerpoint/2010/main" val="2256778902"/>
       </p:ext>
     </p:extLst>
   </p:cSld>
@@ -14033,7 +14108,7 @@
           <p:cNvPr id="2" name="Titel 1">
             <a:extLst>
               <a:ext uri="{FF2B5EF4-FFF2-40B4-BE49-F238E27FC236}">
-                <a16:creationId xmlns:a16="http://schemas.microsoft.com/office/drawing/2014/main" id="{F4D209FF-A863-BF2D-D47F-B9A682108F30}"/>
+                <a16:creationId xmlns:a16="http://schemas.microsoft.com/office/drawing/2014/main" id="{FB0BF6E0-8AD4-83B2-BFCE-B8A40613758A}"/>
               </a:ext>
             </a:extLst>
           </p:cNvPr>
@@ -14062,7 +14137,7 @@
           <p:cNvPr id="3" name="Diagramm 2">
             <a:extLst>
               <a:ext uri="{FF2B5EF4-FFF2-40B4-BE49-F238E27FC236}">
-                <a16:creationId xmlns:a16="http://schemas.microsoft.com/office/drawing/2014/main" id="{09B6C76D-0779-5634-CF0F-71E9CFAB3EE0}"/>
+                <a16:creationId xmlns:a16="http://schemas.microsoft.com/office/drawing/2014/main" id="{B515185C-EB13-37E4-6198-5B8551135277}"/>
               </a:ext>
             </a:extLst>
           </p:cNvPr>
@@ -14070,7 +14145,7 @@
           <p:nvPr>
             <p:extLst>
               <p:ext uri="{D42A27DB-BD31-4B8C-83A1-F6EECF244321}">
-                <p14:modId xmlns:p14="http://schemas.microsoft.com/office/powerpoint/2010/main" val="4200001305"/>
+                <p14:modId xmlns:p14="http://schemas.microsoft.com/office/powerpoint/2010/main" val="3249793868"/>
               </p:ext>
             </p:extLst>
           </p:nvPr>
@@ -14090,7 +14165,7 @@
           <p:cNvPr id="4" name="Diagramm 3">
             <a:extLst>
               <a:ext uri="{FF2B5EF4-FFF2-40B4-BE49-F238E27FC236}">
-                <a16:creationId xmlns:a16="http://schemas.microsoft.com/office/drawing/2014/main" id="{9C736988-7896-FE1F-3068-F6742A7FDAFC}"/>
+                <a16:creationId xmlns:a16="http://schemas.microsoft.com/office/drawing/2014/main" id="{E6B5FB2D-438F-541C-CB69-BC963D53560B}"/>
               </a:ext>
             </a:extLst>
           </p:cNvPr>
@@ -14098,7 +14173,7 @@
           <p:nvPr>
             <p:extLst>
               <p:ext uri="{D42A27DB-BD31-4B8C-83A1-F6EECF244321}">
-                <p14:modId xmlns:p14="http://schemas.microsoft.com/office/powerpoint/2010/main" val="8983842"/>
+                <p14:modId xmlns:p14="http://schemas.microsoft.com/office/powerpoint/2010/main" val="2509046853"/>
               </p:ext>
             </p:extLst>
           </p:nvPr>
@@ -14118,7 +14193,7 @@
           <p:cNvPr id="5" name="Diagramm 4">
             <a:extLst>
               <a:ext uri="{FF2B5EF4-FFF2-40B4-BE49-F238E27FC236}">
-                <a16:creationId xmlns:a16="http://schemas.microsoft.com/office/drawing/2014/main" id="{2B6A3B49-13DA-B2BE-7A4F-60F5808EE989}"/>
+                <a16:creationId xmlns:a16="http://schemas.microsoft.com/office/drawing/2014/main" id="{04CCB4E4-9096-93DE-2539-B80D7DE722AC}"/>
               </a:ext>
             </a:extLst>
           </p:cNvPr>
@@ -14126,7 +14201,7 @@
           <p:nvPr>
             <p:extLst>
               <p:ext uri="{D42A27DB-BD31-4B8C-83A1-F6EECF244321}">
-                <p14:modId xmlns:p14="http://schemas.microsoft.com/office/powerpoint/2010/main" val="1087530668"/>
+                <p14:modId xmlns:p14="http://schemas.microsoft.com/office/powerpoint/2010/main" val="3083615134"/>
               </p:ext>
             </p:extLst>
           </p:nvPr>
@@ -14144,7 +14219,7 @@
     </p:spTree>
     <p:extLst>
       <p:ext uri="{BB962C8B-B14F-4D97-AF65-F5344CB8AC3E}">
-        <p14:creationId xmlns:p14="http://schemas.microsoft.com/office/powerpoint/2010/main" val="2411272805"/>
+        <p14:creationId xmlns:p14="http://schemas.microsoft.com/office/powerpoint/2010/main" val="971056430"/>
       </p:ext>
     </p:extLst>
   </p:cSld>

</xml_diff>

<commit_message>
Charts: data labels keep the formatting of their own text's runs
A point label's own rich text with formatted runs is laid out like a
title, each line as tall as its largest run; charts-details gets a slide
with bold, colored, italic and resized label runs (99.6 %).

Co-Authored-By: Claude Opus 5.5 <noreply@anthropic.com>
</commit_message>
<xml_diff>
--- a/tests/corpus/pptx/generated/charts-details.pptx
+++ b/tests/corpus/pptx/generated/charts-details.pptx
@@ -10,6 +10,7 @@
     <p:sldId id="258" r:id="rId4"/>
     <p:sldId id="259" r:id="rId5"/>
     <p:sldId id="260" r:id="rId6"/>
+    <p:sldId id="261" r:id="rId7"/>
   </p:sldIdLst>
   <p:sldSz cx="12192000" cy="6858000"/>
   <p:notesSz cx="6858000" cy="9144000"/>
@@ -218,7 +219,7 @@
               </c14:invertSolidFillFmt>
             </c:ext>
             <c:ext xmlns:c16="http://schemas.microsoft.com/office/drawing/2014/chart" uri="{C3380CC4-5D6E-409C-BE32-E72D297353CC}">
-              <c16:uniqueId val="{00000000-E5AC-453A-B7E2-2CB1464BBC10}"/>
+              <c16:uniqueId val="{00000000-BD11-45C6-8358-6F666B084A8E}"/>
             </c:ext>
           </c:extLst>
         </c:ser>
@@ -295,7 +296,7 @@
           </c:val>
           <c:extLst>
             <c:ext xmlns:c16="http://schemas.microsoft.com/office/drawing/2014/chart" uri="{C3380CC4-5D6E-409C-BE32-E72D297353CC}">
-              <c16:uniqueId val="{00000001-E5AC-453A-B7E2-2CB1464BBC10}"/>
+              <c16:uniqueId val="{00000001-BD11-45C6-8358-6F666B084A8E}"/>
             </c:ext>
           </c:extLst>
         </c:ser>
@@ -309,11 +310,11 @@
         </c:dLbls>
         <c:gapWidth val="219"/>
         <c:overlap val="-27"/>
-        <c:axId val="5541200"/>
-        <c:axId val="1193382576"/>
+        <c:axId val="1591169120"/>
+        <c:axId val="253415760"/>
       </c:barChart>
       <c:catAx>
-        <c:axId val="5541200"/>
+        <c:axId val="1591169120"/>
         <c:scaling>
           <c:orientation val="minMax"/>
         </c:scaling>
@@ -356,7 +357,7 @@
             <a:endParaRPr lang="de-DE"/>
           </a:p>
         </c:txPr>
-        <c:crossAx val="1193382576"/>
+        <c:crossAx val="253415760"/>
         <c:crosses val="autoZero"/>
         <c:auto val="1"/>
         <c:lblAlgn val="ctr"/>
@@ -364,7 +365,7 @@
         <c:noMultiLvlLbl val="0"/>
       </c:catAx>
       <c:valAx>
-        <c:axId val="1193382576"/>
+        <c:axId val="253415760"/>
         <c:scaling>
           <c:orientation val="minMax"/>
         </c:scaling>
@@ -415,7 +416,7 @@
             <a:endParaRPr lang="de-DE"/>
           </a:p>
         </c:txPr>
-        <c:crossAx val="5541200"/>
+        <c:crossAx val="1591169120"/>
         <c:crosses val="autoZero"/>
         <c:crossBetween val="between"/>
       </c:valAx>
@@ -590,7 +591,7 @@
           </c:val>
           <c:extLst>
             <c:ext xmlns:c16="http://schemas.microsoft.com/office/drawing/2014/chart" uri="{C3380CC4-5D6E-409C-BE32-E72D297353CC}">
-              <c16:uniqueId val="{00000000-FDF9-40CF-9FBA-1BFC5126B945}"/>
+              <c16:uniqueId val="{00000000-70A3-477C-9386-6AFC858F24B2}"/>
             </c:ext>
           </c:extLst>
         </c:ser>
@@ -661,7 +662,7 @@
           </c:val>
           <c:extLst>
             <c:ext xmlns:c16="http://schemas.microsoft.com/office/drawing/2014/chart" uri="{C3380CC4-5D6E-409C-BE32-E72D297353CC}">
-              <c16:uniqueId val="{00000001-FDF9-40CF-9FBA-1BFC5126B945}"/>
+              <c16:uniqueId val="{00000001-70A3-477C-9386-6AFC858F24B2}"/>
             </c:ext>
           </c:extLst>
         </c:ser>
@@ -732,7 +733,7 @@
           </c:val>
           <c:extLst>
             <c:ext xmlns:c16="http://schemas.microsoft.com/office/drawing/2014/chart" uri="{C3380CC4-5D6E-409C-BE32-E72D297353CC}">
-              <c16:uniqueId val="{00000002-FDF9-40CF-9FBA-1BFC5126B945}"/>
+              <c16:uniqueId val="{00000002-70A3-477C-9386-6AFC858F24B2}"/>
             </c:ext>
           </c:extLst>
         </c:ser>
@@ -746,11 +747,11 @@
         </c:dLbls>
         <c:gapWidth val="219"/>
         <c:overlap val="-27"/>
-        <c:axId val="9931744"/>
-        <c:axId val="1193318256"/>
+        <c:axId val="1680444480"/>
+        <c:axId val="253615440"/>
       </c:barChart>
       <c:catAx>
-        <c:axId val="9931744"/>
+        <c:axId val="1680444480"/>
         <c:scaling>
           <c:orientation val="minMax"/>
         </c:scaling>
@@ -793,7 +794,7 @@
             <a:endParaRPr lang="de-DE"/>
           </a:p>
         </c:txPr>
-        <c:crossAx val="1193318256"/>
+        <c:crossAx val="253615440"/>
         <c:crosses val="autoZero"/>
         <c:auto val="1"/>
         <c:lblAlgn val="ctr"/>
@@ -801,7 +802,7 @@
         <c:noMultiLvlLbl val="0"/>
       </c:catAx>
       <c:valAx>
-        <c:axId val="1193318256"/>
+        <c:axId val="253615440"/>
         <c:scaling>
           <c:orientation val="minMax"/>
         </c:scaling>
@@ -852,7 +853,7 @@
             <a:endParaRPr lang="de-DE"/>
           </a:p>
         </c:txPr>
-        <c:crossAx val="9931744"/>
+        <c:crossAx val="1680444480"/>
         <c:crosses val="autoZero"/>
         <c:crossBetween val="between"/>
       </c:valAx>
@@ -1074,7 +1075,7 @@
           <c:bubble3D val="0"/>
           <c:extLst>
             <c:ext xmlns:c16="http://schemas.microsoft.com/office/drawing/2014/chart" uri="{C3380CC4-5D6E-409C-BE32-E72D297353CC}">
-              <c16:uniqueId val="{00000000-FD6D-4A63-B7B5-FD4369761B74}"/>
+              <c16:uniqueId val="{00000000-0A42-4A81-8552-9EEF17DDD587}"/>
             </c:ext>
           </c:extLst>
         </c:ser>
@@ -1088,11 +1089,11 @@
         </c:dLbls>
         <c:bubbleScale val="100"/>
         <c:showNegBubbles val="0"/>
-        <c:axId val="7285984"/>
-        <c:axId val="1193317776"/>
+        <c:axId val="1595860896"/>
+        <c:axId val="253641360"/>
       </c:bubbleChart>
       <c:valAx>
-        <c:axId val="7285984"/>
+        <c:axId val="1595860896"/>
         <c:scaling>
           <c:orientation val="minMax"/>
         </c:scaling>
@@ -1149,12 +1150,12 @@
             <a:endParaRPr lang="de-DE"/>
           </a:p>
         </c:txPr>
-        <c:crossAx val="1193317776"/>
+        <c:crossAx val="253641360"/>
         <c:crosses val="autoZero"/>
         <c:crossBetween val="midCat"/>
       </c:valAx>
       <c:valAx>
-        <c:axId val="1193317776"/>
+        <c:axId val="253641360"/>
         <c:scaling>
           <c:orientation val="minMax"/>
         </c:scaling>
@@ -1211,9 +1212,1137 @@
             <a:endParaRPr lang="de-DE"/>
           </a:p>
         </c:txPr>
-        <c:crossAx val="7285984"/>
+        <c:crossAx val="1595860896"/>
         <c:crosses val="autoZero"/>
         <c:crossBetween val="midCat"/>
+      </c:valAx>
+      <c:spPr>
+        <a:noFill/>
+        <a:ln>
+          <a:noFill/>
+        </a:ln>
+        <a:effectLst/>
+      </c:spPr>
+    </c:plotArea>
+    <c:legend>
+      <c:legendPos val="b"/>
+      <c:overlay val="0"/>
+      <c:spPr>
+        <a:noFill/>
+        <a:ln>
+          <a:noFill/>
+        </a:ln>
+        <a:effectLst/>
+      </c:spPr>
+      <c:txPr>
+        <a:bodyPr rot="0" spcFirstLastPara="1" vertOverflow="ellipsis" vert="horz" wrap="square" anchor="ctr" anchorCtr="1"/>
+        <a:lstStyle/>
+        <a:p>
+          <a:pPr>
+            <a:defRPr sz="1197" b="0" i="0" u="none" strike="noStrike" kern="1200" baseline="0">
+              <a:solidFill>
+                <a:schemeClr val="tx1">
+                  <a:lumMod val="65000"/>
+                  <a:lumOff val="35000"/>
+                </a:schemeClr>
+              </a:solidFill>
+              <a:latin typeface="+mn-lt"/>
+              <a:ea typeface="+mn-ea"/>
+              <a:cs typeface="+mn-cs"/>
+            </a:defRPr>
+          </a:pPr>
+          <a:endParaRPr lang="de-DE"/>
+        </a:p>
+      </c:txPr>
+    </c:legend>
+    <c:plotVisOnly val="1"/>
+    <c:dispBlanksAs val="gap"/>
+    <c:showDLblsOverMax val="0"/>
+    <c:extLst>
+      <c:ext xmlns:c16r3="http://schemas.microsoft.com/office/drawing/2017/03/chart" uri="{56B9EC1D-385E-4148-901F-78D8002777C0}">
+        <c16r3:dataDisplayOptions16>
+          <c16r3:dispNaAsBlank val="1"/>
+        </c16r3:dataDisplayOptions16>
+      </c:ext>
+    </c:extLst>
+  </c:chart>
+  <c:spPr>
+    <a:noFill/>
+    <a:ln>
+      <a:noFill/>
+    </a:ln>
+    <a:effectLst/>
+  </c:spPr>
+  <c:txPr>
+    <a:bodyPr/>
+    <a:lstStyle/>
+    <a:p>
+      <a:pPr>
+        <a:defRPr/>
+      </a:pPr>
+      <a:endParaRPr lang="de-DE"/>
+    </a:p>
+  </c:txPr>
+  <c:externalData r:id="rId3">
+    <c:autoUpdate val="0"/>
+  </c:externalData>
+</c:chartSpace>
+</file>
+
+<file path=ppt/charts/chart12.xml><?xml version="1.0" encoding="utf-8"?>
+<c:chartSpace xmlns:c="http://schemas.openxmlformats.org/drawingml/2006/chart" xmlns:a="http://schemas.openxmlformats.org/drawingml/2006/main" xmlns:r="http://schemas.openxmlformats.org/officeDocument/2006/relationships" xmlns:c16r2="http://schemas.microsoft.com/office/drawing/2015/06/chart">
+  <c:date1904 val="0"/>
+  <c:lang val="de-DE"/>
+  <c:roundedCorners val="0"/>
+  <mc:AlternateContent xmlns:mc="http://schemas.openxmlformats.org/markup-compatibility/2006">
+    <mc:Choice xmlns:c14="http://schemas.microsoft.com/office/drawing/2007/8/2/chart" Requires="c14">
+      <c14:style val="102"/>
+    </mc:Choice>
+    <mc:Fallback>
+      <c:style val="2"/>
+    </mc:Fallback>
+  </mc:AlternateContent>
+  <c:chart>
+    <c:autoTitleDeleted val="0"/>
+    <c:plotArea>
+      <c:layout/>
+      <c:barChart>
+        <c:barDir val="col"/>
+        <c:grouping val="clustered"/>
+        <c:varyColors val="0"/>
+        <c:ser>
+          <c:idx val="0"/>
+          <c:order val="0"/>
+          <c:tx>
+            <c:strRef>
+              <c:f>Tabelle1!$B$1</c:f>
+              <c:strCache>
+                <c:ptCount val="1"/>
+                <c:pt idx="0">
+                  <c:v>Datenreihe 1</c:v>
+                </c:pt>
+              </c:strCache>
+            </c:strRef>
+          </c:tx>
+          <c:spPr>
+            <a:solidFill>
+              <a:schemeClr val="accent1"/>
+            </a:solidFill>
+            <a:ln>
+              <a:noFill/>
+            </a:ln>
+            <a:effectLst/>
+          </c:spPr>
+          <c:invertIfNegative val="0"/>
+          <c:dLbls>
+            <c:dLbl>
+              <c:idx val="1"/>
+              <c:tx>
+                <c:rich>
+                  <a:bodyPr rot="0" spcFirstLastPara="1" vertOverflow="ellipsis" vert="horz" wrap="square" lIns="38100" tIns="19050" rIns="38100" bIns="19050" anchor="ctr" anchorCtr="1">
+                    <a:spAutoFit/>
+                  </a:bodyPr>
+                  <a:lstStyle/>
+                  <a:p>
+                    <a:pPr>
+                      <a:defRPr sz="1197" b="0" i="1" u="none" strike="noStrike" kern="1200" baseline="0">
+                        <a:solidFill>
+                          <a:schemeClr val="tx1">
+                            <a:lumMod val="75000"/>
+                            <a:lumOff val="25000"/>
+                          </a:schemeClr>
+                        </a:solidFill>
+                        <a:latin typeface="+mn-lt"/>
+                        <a:ea typeface="+mn-ea"/>
+                        <a:cs typeface="+mn-cs"/>
+                      </a:defRPr>
+                    </a:pPr>
+                    <a:r>
+                      <a:rPr lang="de-DE" i="1"/>
+                      <a:t>low</a:t>
+                    </a:r>
+                  </a:p>
+                </c:rich>
+              </c:tx>
+              <c:spPr>
+                <a:noFill/>
+                <a:ln>
+                  <a:noFill/>
+                </a:ln>
+                <a:effectLst/>
+              </c:spPr>
+              <c:txPr>
+                <a:bodyPr rot="0" spcFirstLastPara="1" vertOverflow="ellipsis" vert="horz" wrap="square" lIns="38100" tIns="19050" rIns="38100" bIns="19050" anchor="ctr" anchorCtr="1">
+                  <a:spAutoFit/>
+                </a:bodyPr>
+                <a:lstStyle/>
+                <a:p>
+                  <a:pPr>
+                    <a:defRPr sz="1197" b="0" i="1" u="none" strike="noStrike" kern="1200" baseline="0">
+                      <a:solidFill>
+                        <a:schemeClr val="tx1">
+                          <a:lumMod val="75000"/>
+                          <a:lumOff val="25000"/>
+                        </a:schemeClr>
+                      </a:solidFill>
+                      <a:latin typeface="+mn-lt"/>
+                      <a:ea typeface="+mn-ea"/>
+                      <a:cs typeface="+mn-cs"/>
+                    </a:defRPr>
+                  </a:pPr>
+                  <a:endParaRPr lang="de-DE"/>
+                </a:p>
+              </c:txPr>
+              <c:showLegendKey val="0"/>
+              <c:showVal val="1"/>
+              <c:showCatName val="0"/>
+              <c:showSerName val="0"/>
+              <c:showPercent val="0"/>
+              <c:showBubbleSize val="0"/>
+              <c:extLst>
+                <c:ext xmlns:c15="http://schemas.microsoft.com/office/drawing/2012/chart" uri="{CE6537A1-D6FC-4f65-9D91-7224C49458BB}">
+                  <c15:showDataLabelsRange val="0"/>
+                </c:ext>
+                <c:ext xmlns:c16="http://schemas.microsoft.com/office/drawing/2014/chart" uri="{C3380CC4-5D6E-409C-BE32-E72D297353CC}">
+                  <c16:uniqueId val="{00000004-CAB9-46FE-9C46-4EB4BE152DB1}"/>
+                </c:ext>
+              </c:extLst>
+            </c:dLbl>
+            <c:dLbl>
+              <c:idx val="3"/>
+              <c:tx>
+                <c:rich>
+                  <a:bodyPr rot="0" spcFirstLastPara="1" vertOverflow="ellipsis" vert="horz" wrap="square" lIns="38100" tIns="19050" rIns="38100" bIns="19050" anchor="ctr" anchorCtr="1">
+                    <a:spAutoFit/>
+                  </a:bodyPr>
+                  <a:lstStyle/>
+                  <a:p>
+                    <a:pPr>
+                      <a:defRPr sz="1197" b="0" i="0" u="none" strike="noStrike" kern="1200" baseline="0">
+                        <a:solidFill>
+                          <a:srgbClr val="C00000"/>
+                        </a:solidFill>
+                        <a:latin typeface="+mn-lt"/>
+                        <a:ea typeface="+mn-ea"/>
+                        <a:cs typeface="+mn-cs"/>
+                      </a:defRPr>
+                    </a:pPr>
+                    <a:r>
+                      <a:rPr lang="de-DE" sz="1600" b="1">
+                        <a:solidFill>
+                          <a:srgbClr val="C00000"/>
+                        </a:solidFill>
+                      </a:rPr>
+                      <a:t>Peak</a:t>
+                    </a:r>
+                    <a:r>
+                      <a:rPr lang="de-DE">
+                        <a:solidFill>
+                          <a:srgbClr val="C00000"/>
+                        </a:solidFill>
+                      </a:rPr>
+                      <a:t> 4.5</a:t>
+                    </a:r>
+                  </a:p>
+                </c:rich>
+              </c:tx>
+              <c:spPr>
+                <a:noFill/>
+                <a:ln>
+                  <a:noFill/>
+                </a:ln>
+                <a:effectLst/>
+              </c:spPr>
+              <c:txPr>
+                <a:bodyPr rot="0" spcFirstLastPara="1" vertOverflow="ellipsis" vert="horz" wrap="square" lIns="38100" tIns="19050" rIns="38100" bIns="19050" anchor="ctr" anchorCtr="1">
+                  <a:spAutoFit/>
+                </a:bodyPr>
+                <a:lstStyle/>
+                <a:p>
+                  <a:pPr>
+                    <a:defRPr sz="1197" b="0" i="0" u="none" strike="noStrike" kern="1200" baseline="0">
+                      <a:solidFill>
+                        <a:srgbClr val="C00000"/>
+                      </a:solidFill>
+                      <a:latin typeface="+mn-lt"/>
+                      <a:ea typeface="+mn-ea"/>
+                      <a:cs typeface="+mn-cs"/>
+                    </a:defRPr>
+                  </a:pPr>
+                  <a:endParaRPr lang="de-DE"/>
+                </a:p>
+              </c:txPr>
+              <c:showLegendKey val="0"/>
+              <c:showVal val="1"/>
+              <c:showCatName val="0"/>
+              <c:showSerName val="0"/>
+              <c:showPercent val="0"/>
+              <c:showBubbleSize val="0"/>
+              <c:extLst>
+                <c:ext xmlns:c15="http://schemas.microsoft.com/office/drawing/2012/chart" uri="{CE6537A1-D6FC-4f65-9D91-7224C49458BB}">
+                  <c15:showDataLabelsRange val="0"/>
+                </c:ext>
+                <c:ext xmlns:c16="http://schemas.microsoft.com/office/drawing/2014/chart" uri="{C3380CC4-5D6E-409C-BE32-E72D297353CC}">
+                  <c16:uniqueId val="{00000003-CAB9-46FE-9C46-4EB4BE152DB1}"/>
+                </c:ext>
+              </c:extLst>
+            </c:dLbl>
+            <c:spPr>
+              <a:noFill/>
+              <a:ln>
+                <a:noFill/>
+              </a:ln>
+              <a:effectLst/>
+            </c:spPr>
+            <c:txPr>
+              <a:bodyPr rot="0" spcFirstLastPara="1" vertOverflow="ellipsis" vert="horz" wrap="square" lIns="38100" tIns="19050" rIns="38100" bIns="19050" anchor="ctr" anchorCtr="1">
+                <a:spAutoFit/>
+              </a:bodyPr>
+              <a:lstStyle/>
+              <a:p>
+                <a:pPr>
+                  <a:defRPr sz="1197" b="0" i="0" u="none" strike="noStrike" kern="1200" baseline="0">
+                    <a:solidFill>
+                      <a:schemeClr val="tx1">
+                        <a:lumMod val="75000"/>
+                        <a:lumOff val="25000"/>
+                      </a:schemeClr>
+                    </a:solidFill>
+                    <a:latin typeface="+mn-lt"/>
+                    <a:ea typeface="+mn-ea"/>
+                    <a:cs typeface="+mn-cs"/>
+                  </a:defRPr>
+                </a:pPr>
+                <a:endParaRPr lang="de-DE"/>
+              </a:p>
+            </c:txPr>
+            <c:showLegendKey val="0"/>
+            <c:showVal val="1"/>
+            <c:showCatName val="0"/>
+            <c:showSerName val="0"/>
+            <c:showPercent val="0"/>
+            <c:showBubbleSize val="0"/>
+            <c:showLeaderLines val="0"/>
+            <c:extLst>
+              <c:ext xmlns:c15="http://schemas.microsoft.com/office/drawing/2012/chart" uri="{CE6537A1-D6FC-4f65-9D91-7224C49458BB}">
+                <c15:showLeaderLines val="0"/>
+              </c:ext>
+            </c:extLst>
+          </c:dLbls>
+          <c:cat>
+            <c:strRef>
+              <c:f>Tabelle1!$A$2:$A$5</c:f>
+              <c:strCache>
+                <c:ptCount val="4"/>
+                <c:pt idx="0">
+                  <c:v>Kategorie 1</c:v>
+                </c:pt>
+                <c:pt idx="1">
+                  <c:v>Kategorie 2</c:v>
+                </c:pt>
+                <c:pt idx="2">
+                  <c:v>Kategorie 3</c:v>
+                </c:pt>
+                <c:pt idx="3">
+                  <c:v>Kategorie 4</c:v>
+                </c:pt>
+              </c:strCache>
+            </c:strRef>
+          </c:cat>
+          <c:val>
+            <c:numRef>
+              <c:f>Tabelle1!$B$2:$B$5</c:f>
+              <c:numCache>
+                <c:formatCode>General</c:formatCode>
+                <c:ptCount val="4"/>
+                <c:pt idx="0">
+                  <c:v>4.3</c:v>
+                </c:pt>
+                <c:pt idx="1">
+                  <c:v>2.5</c:v>
+                </c:pt>
+                <c:pt idx="2">
+                  <c:v>3.5</c:v>
+                </c:pt>
+                <c:pt idx="3">
+                  <c:v>4.5</c:v>
+                </c:pt>
+              </c:numCache>
+            </c:numRef>
+          </c:val>
+          <c:extLst>
+            <c:ext xmlns:c16="http://schemas.microsoft.com/office/drawing/2014/chart" uri="{C3380CC4-5D6E-409C-BE32-E72D297353CC}">
+              <c16:uniqueId val="{00000000-CAB9-46FE-9C46-4EB4BE152DB1}"/>
+            </c:ext>
+          </c:extLst>
+        </c:ser>
+        <c:ser>
+          <c:idx val="1"/>
+          <c:order val="1"/>
+          <c:tx>
+            <c:strRef>
+              <c:f>Tabelle1!$C$1</c:f>
+              <c:strCache>
+                <c:ptCount val="1"/>
+                <c:pt idx="0">
+                  <c:v>Datenreihe 2</c:v>
+                </c:pt>
+              </c:strCache>
+            </c:strRef>
+          </c:tx>
+          <c:spPr>
+            <a:solidFill>
+              <a:schemeClr val="accent2"/>
+            </a:solidFill>
+            <a:ln>
+              <a:noFill/>
+            </a:ln>
+            <a:effectLst/>
+          </c:spPr>
+          <c:invertIfNegative val="0"/>
+          <c:cat>
+            <c:strRef>
+              <c:f>Tabelle1!$A$2:$A$5</c:f>
+              <c:strCache>
+                <c:ptCount val="4"/>
+                <c:pt idx="0">
+                  <c:v>Kategorie 1</c:v>
+                </c:pt>
+                <c:pt idx="1">
+                  <c:v>Kategorie 2</c:v>
+                </c:pt>
+                <c:pt idx="2">
+                  <c:v>Kategorie 3</c:v>
+                </c:pt>
+                <c:pt idx="3">
+                  <c:v>Kategorie 4</c:v>
+                </c:pt>
+              </c:strCache>
+            </c:strRef>
+          </c:cat>
+          <c:val>
+            <c:numRef>
+              <c:f>Tabelle1!$C$2:$C$5</c:f>
+              <c:numCache>
+                <c:formatCode>General</c:formatCode>
+                <c:ptCount val="4"/>
+                <c:pt idx="0">
+                  <c:v>2.4</c:v>
+                </c:pt>
+                <c:pt idx="1">
+                  <c:v>4.4000000000000004</c:v>
+                </c:pt>
+                <c:pt idx="2">
+                  <c:v>1.8</c:v>
+                </c:pt>
+                <c:pt idx="3">
+                  <c:v>2.8</c:v>
+                </c:pt>
+              </c:numCache>
+            </c:numRef>
+          </c:val>
+          <c:extLst>
+            <c:ext xmlns:c16="http://schemas.microsoft.com/office/drawing/2014/chart" uri="{C3380CC4-5D6E-409C-BE32-E72D297353CC}">
+              <c16:uniqueId val="{00000001-CAB9-46FE-9C46-4EB4BE152DB1}"/>
+            </c:ext>
+          </c:extLst>
+        </c:ser>
+        <c:ser>
+          <c:idx val="2"/>
+          <c:order val="2"/>
+          <c:tx>
+            <c:strRef>
+              <c:f>Tabelle1!$D$1</c:f>
+              <c:strCache>
+                <c:ptCount val="1"/>
+                <c:pt idx="0">
+                  <c:v>Datenreihe 3</c:v>
+                </c:pt>
+              </c:strCache>
+            </c:strRef>
+          </c:tx>
+          <c:spPr>
+            <a:solidFill>
+              <a:schemeClr val="accent3"/>
+            </a:solidFill>
+            <a:ln>
+              <a:noFill/>
+            </a:ln>
+            <a:effectLst/>
+          </c:spPr>
+          <c:invertIfNegative val="0"/>
+          <c:cat>
+            <c:strRef>
+              <c:f>Tabelle1!$A$2:$A$5</c:f>
+              <c:strCache>
+                <c:ptCount val="4"/>
+                <c:pt idx="0">
+                  <c:v>Kategorie 1</c:v>
+                </c:pt>
+                <c:pt idx="1">
+                  <c:v>Kategorie 2</c:v>
+                </c:pt>
+                <c:pt idx="2">
+                  <c:v>Kategorie 3</c:v>
+                </c:pt>
+                <c:pt idx="3">
+                  <c:v>Kategorie 4</c:v>
+                </c:pt>
+              </c:strCache>
+            </c:strRef>
+          </c:cat>
+          <c:val>
+            <c:numRef>
+              <c:f>Tabelle1!$D$2:$D$5</c:f>
+              <c:numCache>
+                <c:formatCode>General</c:formatCode>
+                <c:ptCount val="4"/>
+                <c:pt idx="0">
+                  <c:v>2</c:v>
+                </c:pt>
+                <c:pt idx="1">
+                  <c:v>2</c:v>
+                </c:pt>
+                <c:pt idx="2">
+                  <c:v>3</c:v>
+                </c:pt>
+                <c:pt idx="3">
+                  <c:v>5</c:v>
+                </c:pt>
+              </c:numCache>
+            </c:numRef>
+          </c:val>
+          <c:extLst>
+            <c:ext xmlns:c16="http://schemas.microsoft.com/office/drawing/2014/chart" uri="{C3380CC4-5D6E-409C-BE32-E72D297353CC}">
+              <c16:uniqueId val="{00000002-CAB9-46FE-9C46-4EB4BE152DB1}"/>
+            </c:ext>
+          </c:extLst>
+        </c:ser>
+        <c:dLbls>
+          <c:showLegendKey val="0"/>
+          <c:showVal val="0"/>
+          <c:showCatName val="0"/>
+          <c:showSerName val="0"/>
+          <c:showPercent val="0"/>
+          <c:showBubbleSize val="0"/>
+        </c:dLbls>
+        <c:gapWidth val="219"/>
+        <c:overlap val="-27"/>
+        <c:axId val="1595915152"/>
+        <c:axId val="253673040"/>
+      </c:barChart>
+      <c:catAx>
+        <c:axId val="1595915152"/>
+        <c:scaling>
+          <c:orientation val="minMax"/>
+        </c:scaling>
+        <c:delete val="0"/>
+        <c:axPos val="b"/>
+        <c:numFmt formatCode="General" sourceLinked="1"/>
+        <c:majorTickMark val="none"/>
+        <c:minorTickMark val="none"/>
+        <c:tickLblPos val="nextTo"/>
+        <c:spPr>
+          <a:noFill/>
+          <a:ln w="9525" cap="flat" cmpd="sng" algn="ctr">
+            <a:solidFill>
+              <a:schemeClr val="tx1">
+                <a:lumMod val="15000"/>
+                <a:lumOff val="85000"/>
+              </a:schemeClr>
+            </a:solidFill>
+            <a:round/>
+          </a:ln>
+          <a:effectLst/>
+        </c:spPr>
+        <c:txPr>
+          <a:bodyPr rot="-60000000" spcFirstLastPara="1" vertOverflow="ellipsis" vert="horz" wrap="square" anchor="ctr" anchorCtr="1"/>
+          <a:lstStyle/>
+          <a:p>
+            <a:pPr>
+              <a:defRPr sz="1197" b="0" i="0" u="none" strike="noStrike" kern="1200" baseline="0">
+                <a:solidFill>
+                  <a:schemeClr val="tx1">
+                    <a:lumMod val="65000"/>
+                    <a:lumOff val="35000"/>
+                  </a:schemeClr>
+                </a:solidFill>
+                <a:latin typeface="+mn-lt"/>
+                <a:ea typeface="+mn-ea"/>
+                <a:cs typeface="+mn-cs"/>
+              </a:defRPr>
+            </a:pPr>
+            <a:endParaRPr lang="de-DE"/>
+          </a:p>
+        </c:txPr>
+        <c:crossAx val="253673040"/>
+        <c:crosses val="autoZero"/>
+        <c:auto val="1"/>
+        <c:lblAlgn val="ctr"/>
+        <c:lblOffset val="100"/>
+        <c:noMultiLvlLbl val="0"/>
+      </c:catAx>
+      <c:valAx>
+        <c:axId val="253673040"/>
+        <c:scaling>
+          <c:orientation val="minMax"/>
+        </c:scaling>
+        <c:delete val="0"/>
+        <c:axPos val="l"/>
+        <c:majorGridlines>
+          <c:spPr>
+            <a:ln w="9525" cap="flat" cmpd="sng" algn="ctr">
+              <a:solidFill>
+                <a:schemeClr val="tx1">
+                  <a:lumMod val="15000"/>
+                  <a:lumOff val="85000"/>
+                </a:schemeClr>
+              </a:solidFill>
+              <a:round/>
+            </a:ln>
+            <a:effectLst/>
+          </c:spPr>
+        </c:majorGridlines>
+        <c:numFmt formatCode="General" sourceLinked="1"/>
+        <c:majorTickMark val="none"/>
+        <c:minorTickMark val="none"/>
+        <c:tickLblPos val="nextTo"/>
+        <c:spPr>
+          <a:noFill/>
+          <a:ln>
+            <a:noFill/>
+          </a:ln>
+          <a:effectLst/>
+        </c:spPr>
+        <c:txPr>
+          <a:bodyPr rot="-60000000" spcFirstLastPara="1" vertOverflow="ellipsis" vert="horz" wrap="square" anchor="ctr" anchorCtr="1"/>
+          <a:lstStyle/>
+          <a:p>
+            <a:pPr>
+              <a:defRPr sz="1197" b="0" i="0" u="none" strike="noStrike" kern="1200" baseline="0">
+                <a:solidFill>
+                  <a:schemeClr val="tx1">
+                    <a:lumMod val="65000"/>
+                    <a:lumOff val="35000"/>
+                  </a:schemeClr>
+                </a:solidFill>
+                <a:latin typeface="+mn-lt"/>
+                <a:ea typeface="+mn-ea"/>
+                <a:cs typeface="+mn-cs"/>
+              </a:defRPr>
+            </a:pPr>
+            <a:endParaRPr lang="de-DE"/>
+          </a:p>
+        </c:txPr>
+        <c:crossAx val="1595915152"/>
+        <c:crosses val="autoZero"/>
+        <c:crossBetween val="between"/>
+      </c:valAx>
+      <c:spPr>
+        <a:noFill/>
+        <a:ln>
+          <a:noFill/>
+        </a:ln>
+        <a:effectLst/>
+      </c:spPr>
+    </c:plotArea>
+    <c:legend>
+      <c:legendPos val="b"/>
+      <c:overlay val="0"/>
+      <c:spPr>
+        <a:noFill/>
+        <a:ln>
+          <a:noFill/>
+        </a:ln>
+        <a:effectLst/>
+      </c:spPr>
+      <c:txPr>
+        <a:bodyPr rot="0" spcFirstLastPara="1" vertOverflow="ellipsis" vert="horz" wrap="square" anchor="ctr" anchorCtr="1"/>
+        <a:lstStyle/>
+        <a:p>
+          <a:pPr>
+            <a:defRPr sz="1197" b="0" i="0" u="none" strike="noStrike" kern="1200" baseline="0">
+              <a:solidFill>
+                <a:schemeClr val="tx1">
+                  <a:lumMod val="65000"/>
+                  <a:lumOff val="35000"/>
+                </a:schemeClr>
+              </a:solidFill>
+              <a:latin typeface="+mn-lt"/>
+              <a:ea typeface="+mn-ea"/>
+              <a:cs typeface="+mn-cs"/>
+            </a:defRPr>
+          </a:pPr>
+          <a:endParaRPr lang="de-DE"/>
+        </a:p>
+      </c:txPr>
+    </c:legend>
+    <c:plotVisOnly val="1"/>
+    <c:dispBlanksAs val="gap"/>
+    <c:showDLblsOverMax val="0"/>
+    <c:extLst>
+      <c:ext xmlns:c16r3="http://schemas.microsoft.com/office/drawing/2017/03/chart" uri="{56B9EC1D-385E-4148-901F-78D8002777C0}">
+        <c16r3:dataDisplayOptions16>
+          <c16r3:dispNaAsBlank val="1"/>
+        </c16r3:dataDisplayOptions16>
+      </c:ext>
+    </c:extLst>
+  </c:chart>
+  <c:spPr>
+    <a:noFill/>
+    <a:ln>
+      <a:noFill/>
+    </a:ln>
+    <a:effectLst/>
+  </c:spPr>
+  <c:txPr>
+    <a:bodyPr/>
+    <a:lstStyle/>
+    <a:p>
+      <a:pPr>
+        <a:defRPr/>
+      </a:pPr>
+      <a:endParaRPr lang="de-DE"/>
+    </a:p>
+  </c:txPr>
+  <c:externalData r:id="rId3">
+    <c:autoUpdate val="0"/>
+  </c:externalData>
+</c:chartSpace>
+</file>
+
+<file path=ppt/charts/chart13.xml><?xml version="1.0" encoding="utf-8"?>
+<c:chartSpace xmlns:c="http://schemas.openxmlformats.org/drawingml/2006/chart" xmlns:a="http://schemas.openxmlformats.org/drawingml/2006/main" xmlns:r="http://schemas.openxmlformats.org/officeDocument/2006/relationships" xmlns:c16r2="http://schemas.microsoft.com/office/drawing/2015/06/chart">
+  <c:date1904 val="0"/>
+  <c:lang val="de-DE"/>
+  <c:roundedCorners val="0"/>
+  <mc:AlternateContent xmlns:mc="http://schemas.openxmlformats.org/markup-compatibility/2006">
+    <mc:Choice xmlns:c14="http://schemas.microsoft.com/office/drawing/2007/8/2/chart" Requires="c14">
+      <c14:style val="102"/>
+    </mc:Choice>
+    <mc:Fallback>
+      <c:style val="2"/>
+    </mc:Fallback>
+  </mc:AlternateContent>
+  <c:chart>
+    <c:autoTitleDeleted val="0"/>
+    <c:plotArea>
+      <c:layout/>
+      <c:barChart>
+        <c:barDir val="bar"/>
+        <c:grouping val="clustered"/>
+        <c:varyColors val="0"/>
+        <c:ser>
+          <c:idx val="0"/>
+          <c:order val="0"/>
+          <c:tx>
+            <c:strRef>
+              <c:f>Tabelle1!$B$1</c:f>
+              <c:strCache>
+                <c:ptCount val="1"/>
+                <c:pt idx="0">
+                  <c:v>Datenreihe 1</c:v>
+                </c:pt>
+              </c:strCache>
+            </c:strRef>
+          </c:tx>
+          <c:spPr>
+            <a:solidFill>
+              <a:schemeClr val="accent1"/>
+            </a:solidFill>
+            <a:ln>
+              <a:noFill/>
+            </a:ln>
+            <a:effectLst/>
+          </c:spPr>
+          <c:invertIfNegative val="0"/>
+          <c:cat>
+            <c:strRef>
+              <c:f>Tabelle1!$A$2:$A$5</c:f>
+              <c:strCache>
+                <c:ptCount val="4"/>
+                <c:pt idx="0">
+                  <c:v>Kategorie 1</c:v>
+                </c:pt>
+                <c:pt idx="1">
+                  <c:v>Kategorie 2</c:v>
+                </c:pt>
+                <c:pt idx="2">
+                  <c:v>Kategorie 3</c:v>
+                </c:pt>
+                <c:pt idx="3">
+                  <c:v>Kategorie 4</c:v>
+                </c:pt>
+              </c:strCache>
+            </c:strRef>
+          </c:cat>
+          <c:val>
+            <c:numRef>
+              <c:f>Tabelle1!$B$2:$B$5</c:f>
+              <c:numCache>
+                <c:formatCode>General</c:formatCode>
+                <c:ptCount val="4"/>
+                <c:pt idx="0">
+                  <c:v>4.3</c:v>
+                </c:pt>
+                <c:pt idx="1">
+                  <c:v>2.5</c:v>
+                </c:pt>
+                <c:pt idx="2">
+                  <c:v>3.5</c:v>
+                </c:pt>
+                <c:pt idx="3">
+                  <c:v>4.5</c:v>
+                </c:pt>
+              </c:numCache>
+            </c:numRef>
+          </c:val>
+          <c:extLst>
+            <c:ext xmlns:c16="http://schemas.microsoft.com/office/drawing/2014/chart" uri="{C3380CC4-5D6E-409C-BE32-E72D297353CC}">
+              <c16:uniqueId val="{00000000-06B2-4A75-86B2-AE195452C7BE}"/>
+            </c:ext>
+          </c:extLst>
+        </c:ser>
+        <c:ser>
+          <c:idx val="1"/>
+          <c:order val="1"/>
+          <c:tx>
+            <c:strRef>
+              <c:f>Tabelle1!$C$1</c:f>
+              <c:strCache>
+                <c:ptCount val="1"/>
+                <c:pt idx="0">
+                  <c:v>Datenreihe 2</c:v>
+                </c:pt>
+              </c:strCache>
+            </c:strRef>
+          </c:tx>
+          <c:spPr>
+            <a:solidFill>
+              <a:schemeClr val="accent2"/>
+            </a:solidFill>
+            <a:ln>
+              <a:noFill/>
+            </a:ln>
+            <a:effectLst/>
+          </c:spPr>
+          <c:invertIfNegative val="0"/>
+          <c:dLbls>
+            <c:dLbl>
+              <c:idx val="0"/>
+              <c:tx>
+                <c:rich>
+                  <a:bodyPr/>
+                  <a:lstStyle/>
+                  <a:p>
+                    <a:r>
+                      <a:rPr lang="de-DE" sz="2000"/>
+                      <a:t>Big</a:t>
+                    </a:r>
+                    <a:r>
+                      <a:rPr lang="de-DE"/>
+                      <a:t> and </a:t>
+                    </a:r>
+                    <a:r>
+                      <a:rPr lang="de-DE" sz="800"/>
+                      <a:t>small</a:t>
+                    </a:r>
+                  </a:p>
+                </c:rich>
+              </c:tx>
+              <c:showLegendKey val="0"/>
+              <c:showVal val="1"/>
+              <c:showCatName val="0"/>
+              <c:showSerName val="0"/>
+              <c:showPercent val="0"/>
+              <c:showBubbleSize val="0"/>
+              <c:extLst>
+                <c:ext xmlns:c15="http://schemas.microsoft.com/office/drawing/2012/chart" uri="{CE6537A1-D6FC-4f65-9D91-7224C49458BB}">
+                  <c15:showDataLabelsRange val="0"/>
+                </c:ext>
+                <c:ext xmlns:c16="http://schemas.microsoft.com/office/drawing/2014/chart" uri="{C3380CC4-5D6E-409C-BE32-E72D297353CC}">
+                  <c16:uniqueId val="{00000003-06B2-4A75-86B2-AE195452C7BE}"/>
+                </c:ext>
+              </c:extLst>
+            </c:dLbl>
+            <c:spPr>
+              <a:noFill/>
+              <a:ln>
+                <a:noFill/>
+              </a:ln>
+              <a:effectLst/>
+            </c:spPr>
+            <c:txPr>
+              <a:bodyPr rot="0" spcFirstLastPara="1" vertOverflow="ellipsis" vert="horz" wrap="square" lIns="38100" tIns="19050" rIns="38100" bIns="19050" anchor="ctr" anchorCtr="1">
+                <a:spAutoFit/>
+              </a:bodyPr>
+              <a:lstStyle/>
+              <a:p>
+                <a:pPr>
+                  <a:defRPr sz="1197" b="0" i="0" u="none" strike="noStrike" kern="1200" baseline="0">
+                    <a:solidFill>
+                      <a:schemeClr val="tx1">
+                        <a:lumMod val="75000"/>
+                        <a:lumOff val="25000"/>
+                      </a:schemeClr>
+                    </a:solidFill>
+                    <a:latin typeface="+mn-lt"/>
+                    <a:ea typeface="+mn-ea"/>
+                    <a:cs typeface="+mn-cs"/>
+                  </a:defRPr>
+                </a:pPr>
+                <a:endParaRPr lang="de-DE"/>
+              </a:p>
+            </c:txPr>
+            <c:showLegendKey val="0"/>
+            <c:showVal val="1"/>
+            <c:showCatName val="0"/>
+            <c:showSerName val="0"/>
+            <c:showPercent val="0"/>
+            <c:showBubbleSize val="0"/>
+            <c:showLeaderLines val="0"/>
+            <c:extLst>
+              <c:ext xmlns:c15="http://schemas.microsoft.com/office/drawing/2012/chart" uri="{CE6537A1-D6FC-4f65-9D91-7224C49458BB}">
+                <c15:showLeaderLines val="0"/>
+              </c:ext>
+            </c:extLst>
+          </c:dLbls>
+          <c:cat>
+            <c:strRef>
+              <c:f>Tabelle1!$A$2:$A$5</c:f>
+              <c:strCache>
+                <c:ptCount val="4"/>
+                <c:pt idx="0">
+                  <c:v>Kategorie 1</c:v>
+                </c:pt>
+                <c:pt idx="1">
+                  <c:v>Kategorie 2</c:v>
+                </c:pt>
+                <c:pt idx="2">
+                  <c:v>Kategorie 3</c:v>
+                </c:pt>
+                <c:pt idx="3">
+                  <c:v>Kategorie 4</c:v>
+                </c:pt>
+              </c:strCache>
+            </c:strRef>
+          </c:cat>
+          <c:val>
+            <c:numRef>
+              <c:f>Tabelle1!$C$2:$C$5</c:f>
+              <c:numCache>
+                <c:formatCode>General</c:formatCode>
+                <c:ptCount val="4"/>
+                <c:pt idx="0">
+                  <c:v>2.4</c:v>
+                </c:pt>
+                <c:pt idx="1">
+                  <c:v>4.4000000000000004</c:v>
+                </c:pt>
+                <c:pt idx="2">
+                  <c:v>1.8</c:v>
+                </c:pt>
+                <c:pt idx="3">
+                  <c:v>2.8</c:v>
+                </c:pt>
+              </c:numCache>
+            </c:numRef>
+          </c:val>
+          <c:extLst>
+            <c:ext xmlns:c16="http://schemas.microsoft.com/office/drawing/2014/chart" uri="{C3380CC4-5D6E-409C-BE32-E72D297353CC}">
+              <c16:uniqueId val="{00000001-06B2-4A75-86B2-AE195452C7BE}"/>
+            </c:ext>
+          </c:extLst>
+        </c:ser>
+        <c:ser>
+          <c:idx val="2"/>
+          <c:order val="2"/>
+          <c:tx>
+            <c:strRef>
+              <c:f>Tabelle1!$D$1</c:f>
+              <c:strCache>
+                <c:ptCount val="1"/>
+                <c:pt idx="0">
+                  <c:v>Datenreihe 3</c:v>
+                </c:pt>
+              </c:strCache>
+            </c:strRef>
+          </c:tx>
+          <c:spPr>
+            <a:solidFill>
+              <a:schemeClr val="accent3"/>
+            </a:solidFill>
+            <a:ln>
+              <a:noFill/>
+            </a:ln>
+            <a:effectLst/>
+          </c:spPr>
+          <c:invertIfNegative val="0"/>
+          <c:cat>
+            <c:strRef>
+              <c:f>Tabelle1!$A$2:$A$5</c:f>
+              <c:strCache>
+                <c:ptCount val="4"/>
+                <c:pt idx="0">
+                  <c:v>Kategorie 1</c:v>
+                </c:pt>
+                <c:pt idx="1">
+                  <c:v>Kategorie 2</c:v>
+                </c:pt>
+                <c:pt idx="2">
+                  <c:v>Kategorie 3</c:v>
+                </c:pt>
+                <c:pt idx="3">
+                  <c:v>Kategorie 4</c:v>
+                </c:pt>
+              </c:strCache>
+            </c:strRef>
+          </c:cat>
+          <c:val>
+            <c:numRef>
+              <c:f>Tabelle1!$D$2:$D$5</c:f>
+              <c:numCache>
+                <c:formatCode>General</c:formatCode>
+                <c:ptCount val="4"/>
+                <c:pt idx="0">
+                  <c:v>2</c:v>
+                </c:pt>
+                <c:pt idx="1">
+                  <c:v>2</c:v>
+                </c:pt>
+                <c:pt idx="2">
+                  <c:v>3</c:v>
+                </c:pt>
+                <c:pt idx="3">
+                  <c:v>5</c:v>
+                </c:pt>
+              </c:numCache>
+            </c:numRef>
+          </c:val>
+          <c:extLst>
+            <c:ext xmlns:c16="http://schemas.microsoft.com/office/drawing/2014/chart" uri="{C3380CC4-5D6E-409C-BE32-E72D297353CC}">
+              <c16:uniqueId val="{00000002-06B2-4A75-86B2-AE195452C7BE}"/>
+            </c:ext>
+          </c:extLst>
+        </c:ser>
+        <c:dLbls>
+          <c:showLegendKey val="0"/>
+          <c:showVal val="0"/>
+          <c:showCatName val="0"/>
+          <c:showSerName val="0"/>
+          <c:showPercent val="0"/>
+          <c:showBubbleSize val="0"/>
+        </c:dLbls>
+        <c:gapWidth val="182"/>
+        <c:axId val="1595873888"/>
+        <c:axId val="253427280"/>
+      </c:barChart>
+      <c:catAx>
+        <c:axId val="1595873888"/>
+        <c:scaling>
+          <c:orientation val="minMax"/>
+        </c:scaling>
+        <c:delete val="0"/>
+        <c:axPos val="l"/>
+        <c:numFmt formatCode="General" sourceLinked="1"/>
+        <c:majorTickMark val="none"/>
+        <c:minorTickMark val="none"/>
+        <c:tickLblPos val="nextTo"/>
+        <c:spPr>
+          <a:noFill/>
+          <a:ln w="9525" cap="flat" cmpd="sng" algn="ctr">
+            <a:solidFill>
+              <a:schemeClr val="tx1">
+                <a:lumMod val="15000"/>
+                <a:lumOff val="85000"/>
+              </a:schemeClr>
+            </a:solidFill>
+            <a:round/>
+          </a:ln>
+          <a:effectLst/>
+        </c:spPr>
+        <c:txPr>
+          <a:bodyPr rot="-60000000" spcFirstLastPara="1" vertOverflow="ellipsis" vert="horz" wrap="square" anchor="ctr" anchorCtr="1"/>
+          <a:lstStyle/>
+          <a:p>
+            <a:pPr>
+              <a:defRPr sz="1197" b="0" i="0" u="none" strike="noStrike" kern="1200" baseline="0">
+                <a:solidFill>
+                  <a:schemeClr val="tx1">
+                    <a:lumMod val="65000"/>
+                    <a:lumOff val="35000"/>
+                  </a:schemeClr>
+                </a:solidFill>
+                <a:latin typeface="+mn-lt"/>
+                <a:ea typeface="+mn-ea"/>
+                <a:cs typeface="+mn-cs"/>
+              </a:defRPr>
+            </a:pPr>
+            <a:endParaRPr lang="de-DE"/>
+          </a:p>
+        </c:txPr>
+        <c:crossAx val="253427280"/>
+        <c:crosses val="autoZero"/>
+        <c:auto val="1"/>
+        <c:lblAlgn val="ctr"/>
+        <c:lblOffset val="100"/>
+        <c:noMultiLvlLbl val="0"/>
+      </c:catAx>
+      <c:valAx>
+        <c:axId val="253427280"/>
+        <c:scaling>
+          <c:orientation val="minMax"/>
+        </c:scaling>
+        <c:delete val="0"/>
+        <c:axPos val="b"/>
+        <c:majorGridlines>
+          <c:spPr>
+            <a:ln w="9525" cap="flat" cmpd="sng" algn="ctr">
+              <a:solidFill>
+                <a:schemeClr val="tx1">
+                  <a:lumMod val="15000"/>
+                  <a:lumOff val="85000"/>
+                </a:schemeClr>
+              </a:solidFill>
+              <a:round/>
+            </a:ln>
+            <a:effectLst/>
+          </c:spPr>
+        </c:majorGridlines>
+        <c:numFmt formatCode="General" sourceLinked="1"/>
+        <c:majorTickMark val="none"/>
+        <c:minorTickMark val="none"/>
+        <c:tickLblPos val="nextTo"/>
+        <c:spPr>
+          <a:noFill/>
+          <a:ln>
+            <a:noFill/>
+          </a:ln>
+          <a:effectLst/>
+        </c:spPr>
+        <c:txPr>
+          <a:bodyPr rot="-60000000" spcFirstLastPara="1" vertOverflow="ellipsis" vert="horz" wrap="square" anchor="ctr" anchorCtr="1"/>
+          <a:lstStyle/>
+          <a:p>
+            <a:pPr>
+              <a:defRPr sz="1197" b="0" i="0" u="none" strike="noStrike" kern="1200" baseline="0">
+                <a:solidFill>
+                  <a:schemeClr val="tx1">
+                    <a:lumMod val="65000"/>
+                    <a:lumOff val="35000"/>
+                  </a:schemeClr>
+                </a:solidFill>
+                <a:latin typeface="+mn-lt"/>
+                <a:ea typeface="+mn-ea"/>
+                <a:cs typeface="+mn-cs"/>
+              </a:defRPr>
+            </a:pPr>
+            <a:endParaRPr lang="de-DE"/>
+          </a:p>
+        </c:txPr>
+        <c:crossAx val="1595873888"/>
+        <c:crosses val="autoZero"/>
+        <c:crossBetween val="between"/>
       </c:valAx>
       <c:spPr>
         <a:noFill/>
@@ -1377,7 +2506,7 @@
           </c:val>
           <c:extLst>
             <c:ext xmlns:c16="http://schemas.microsoft.com/office/drawing/2014/chart" uri="{C3380CC4-5D6E-409C-BE32-E72D297353CC}">
-              <c16:uniqueId val="{00000000-F0EC-435C-BB41-A4B49D094CC9}"/>
+              <c16:uniqueId val="{00000000-DE06-49DC-BF5E-147DD96DA6F2}"/>
             </c:ext>
           </c:extLst>
         </c:ser>
@@ -1449,7 +2578,7 @@
           </c:val>
           <c:extLst>
             <c:ext xmlns:c16="http://schemas.microsoft.com/office/drawing/2014/chart" uri="{C3380CC4-5D6E-409C-BE32-E72D297353CC}">
-              <c16:uniqueId val="{00000001-F0EC-435C-BB41-A4B49D094CC9}"/>
+              <c16:uniqueId val="{00000001-DE06-49DC-BF5E-147DD96DA6F2}"/>
             </c:ext>
           </c:extLst>
         </c:ser>
@@ -1463,11 +2592,11 @@
         </c:dLbls>
         <c:gapWidth val="219"/>
         <c:overlap val="-27"/>
-        <c:axId val="1987030751"/>
-        <c:axId val="1193437296"/>
+        <c:axId val="1593218848"/>
+        <c:axId val="253437360"/>
       </c:barChart>
       <c:catAx>
-        <c:axId val="1987030751"/>
+        <c:axId val="1593218848"/>
         <c:scaling>
           <c:orientation val="minMax"/>
         </c:scaling>
@@ -1510,7 +2639,7 @@
             <a:endParaRPr lang="de-DE"/>
           </a:p>
         </c:txPr>
-        <c:crossAx val="1193437296"/>
+        <c:crossAx val="253437360"/>
         <c:crosses val="autoZero"/>
         <c:auto val="1"/>
         <c:lblAlgn val="ctr"/>
@@ -1518,7 +2647,7 @@
         <c:noMultiLvlLbl val="0"/>
       </c:catAx>
       <c:valAx>
-        <c:axId val="1193437296"/>
+        <c:axId val="253437360"/>
         <c:scaling>
           <c:orientation val="minMax"/>
         </c:scaling>
@@ -1569,7 +2698,7 @@
             <a:endParaRPr lang="de-DE"/>
           </a:p>
         </c:txPr>
-        <c:crossAx val="1987030751"/>
+        <c:crossAx val="1593218848"/>
         <c:crosses val="autoZero"/>
         <c:crossBetween val="between"/>
         <c:dispUnits>
@@ -1816,7 +2945,7 @@
           <c:smooth val="0"/>
           <c:extLst>
             <c:ext xmlns:c16="http://schemas.microsoft.com/office/drawing/2014/chart" uri="{C3380CC4-5D6E-409C-BE32-E72D297353CC}">
-              <c16:uniqueId val="{00000000-5BD0-4FF6-95FA-CDA1D93BCF44}"/>
+              <c16:uniqueId val="{00000000-0888-42E8-8384-B6C1933A1A0A}"/>
             </c:ext>
           </c:extLst>
         </c:ser>
@@ -1829,11 +2958,11 @@
           <c:showBubbleSize val="0"/>
         </c:dLbls>
         <c:smooth val="0"/>
-        <c:axId val="49323520"/>
-        <c:axId val="1193483856"/>
+        <c:axId val="1593226272"/>
+        <c:axId val="253452240"/>
       </c:lineChart>
       <c:catAx>
-        <c:axId val="49323520"/>
+        <c:axId val="1593226272"/>
         <c:scaling>
           <c:orientation val="minMax"/>
         </c:scaling>
@@ -1876,7 +3005,7 @@
             <a:endParaRPr lang="de-DE"/>
           </a:p>
         </c:txPr>
-        <c:crossAx val="1193483856"/>
+        <c:crossAx val="253452240"/>
         <c:crosses val="autoZero"/>
         <c:auto val="1"/>
         <c:lblAlgn val="ctr"/>
@@ -1886,7 +3015,7 @@
         <c:noMultiLvlLbl val="0"/>
       </c:catAx>
       <c:valAx>
-        <c:axId val="1193483856"/>
+        <c:axId val="253452240"/>
         <c:scaling>
           <c:orientation val="minMax"/>
         </c:scaling>
@@ -1937,7 +3066,7 @@
             <a:endParaRPr lang="de-DE"/>
           </a:p>
         </c:txPr>
-        <c:crossAx val="49323520"/>
+        <c:crossAx val="1593226272"/>
         <c:crosses val="autoZero"/>
         <c:crossBetween val="between"/>
         <c:dispUnits>
@@ -2147,7 +3276,7 @@
           </c:val>
           <c:extLst>
             <c:ext xmlns:c16="http://schemas.microsoft.com/office/drawing/2014/chart" uri="{C3380CC4-5D6E-409C-BE32-E72D297353CC}">
-              <c16:uniqueId val="{00000000-6EF6-4809-856B-8EA1D231904A}"/>
+              <c16:uniqueId val="{00000000-AF0C-4BEB-9B50-B91ED622C911}"/>
             </c:ext>
           </c:extLst>
         </c:ser>
@@ -2161,11 +3290,11 @@
         </c:dLbls>
         <c:gapWidth val="219"/>
         <c:overlap val="-27"/>
-        <c:axId val="49307744"/>
-        <c:axId val="1193478576"/>
+        <c:axId val="1593224416"/>
+        <c:axId val="253457040"/>
       </c:barChart>
       <c:dateAx>
-        <c:axId val="49307744"/>
+        <c:axId val="1593224416"/>
         <c:scaling>
           <c:orientation val="minMax"/>
         </c:scaling>
@@ -2208,14 +3337,14 @@
             <a:endParaRPr lang="de-DE"/>
           </a:p>
         </c:txPr>
-        <c:crossAx val="1193478576"/>
+        <c:crossAx val="253457040"/>
         <c:crosses val="autoZero"/>
         <c:auto val="0"/>
         <c:lblOffset val="100"/>
         <c:baseTimeUnit val="months"/>
       </c:dateAx>
       <c:valAx>
-        <c:axId val="1193478576"/>
+        <c:axId val="253457040"/>
         <c:scaling>
           <c:orientation val="minMax"/>
         </c:scaling>
@@ -2266,7 +3395,7 @@
             <a:endParaRPr lang="de-DE"/>
           </a:p>
         </c:txPr>
-        <c:crossAx val="49307744"/>
+        <c:crossAx val="1593224416"/>
         <c:crosses val="autoZero"/>
         <c:crossBetween val="between"/>
       </c:valAx>
@@ -2539,7 +3668,7 @@
           </c:val>
           <c:extLst>
             <c:ext xmlns:c16="http://schemas.microsoft.com/office/drawing/2014/chart" uri="{C3380CC4-5D6E-409C-BE32-E72D297353CC}">
-              <c16:uniqueId val="{00000000-A7F0-4FCA-A3FF-97B46DA82327}"/>
+              <c16:uniqueId val="{00000000-F5E0-4296-A13C-5C43C11D61D1}"/>
             </c:ext>
           </c:extLst>
         </c:ser>
@@ -2838,7 +3967,7 @@
           </c:val>
           <c:extLst>
             <c:ext xmlns:c16="http://schemas.microsoft.com/office/drawing/2014/chart" uri="{C3380CC4-5D6E-409C-BE32-E72D297353CC}">
-              <c16:uniqueId val="{00000000-4D23-4B0E-9467-BFB82660AAFA}"/>
+              <c16:uniqueId val="{00000000-84BD-4D03-A956-C7AC88266384}"/>
             </c:ext>
           </c:extLst>
         </c:ser>
@@ -3022,7 +4151,7 @@
             </c:spPr>
             <c:extLst>
               <c:ext xmlns:c16="http://schemas.microsoft.com/office/drawing/2014/chart" uri="{C3380CC4-5D6E-409C-BE32-E72D297353CC}">
-                <c16:uniqueId val="{00000001-6BAE-440B-B6E0-77F1BD464184}"/>
+                <c16:uniqueId val="{00000001-638B-4B80-AA7C-FE7844F8EC05}"/>
               </c:ext>
             </c:extLst>
           </c:dPt>
@@ -3042,7 +4171,7 @@
             </c:spPr>
             <c:extLst>
               <c:ext xmlns:c16="http://schemas.microsoft.com/office/drawing/2014/chart" uri="{C3380CC4-5D6E-409C-BE32-E72D297353CC}">
-                <c16:uniqueId val="{00000002-6BAE-440B-B6E0-77F1BD464184}"/>
+                <c16:uniqueId val="{00000002-638B-4B80-AA7C-FE7844F8EC05}"/>
               </c:ext>
             </c:extLst>
           </c:dPt>
@@ -3062,7 +4191,7 @@
             </c:spPr>
             <c:extLst>
               <c:ext xmlns:c16="http://schemas.microsoft.com/office/drawing/2014/chart" uri="{C3380CC4-5D6E-409C-BE32-E72D297353CC}">
-                <c16:uniqueId val="{00000003-6BAE-440B-B6E0-77F1BD464184}"/>
+                <c16:uniqueId val="{00000003-638B-4B80-AA7C-FE7844F8EC05}"/>
               </c:ext>
             </c:extLst>
           </c:dPt>
@@ -3130,7 +4259,7 @@
               <c:extLst>
                 <c:ext xmlns:c15="http://schemas.microsoft.com/office/drawing/2012/chart" uri="{CE6537A1-D6FC-4f65-9D91-7224C49458BB}"/>
                 <c:ext xmlns:c16="http://schemas.microsoft.com/office/drawing/2014/chart" uri="{C3380CC4-5D6E-409C-BE32-E72D297353CC}">
-                  <c16:uniqueId val="{00000001-6BAE-440B-B6E0-77F1BD464184}"/>
+                  <c16:uniqueId val="{00000001-638B-4B80-AA7C-FE7844F8EC05}"/>
                 </c:ext>
               </c:extLst>
             </c:dLbl>
@@ -3152,7 +4281,7 @@
               <c:extLst>
                 <c:ext xmlns:c15="http://schemas.microsoft.com/office/drawing/2012/chart" uri="{CE6537A1-D6FC-4f65-9D91-7224C49458BB}"/>
                 <c:ext xmlns:c16="http://schemas.microsoft.com/office/drawing/2014/chart" uri="{C3380CC4-5D6E-409C-BE32-E72D297353CC}">
-                  <c16:uniqueId val="{00000002-6BAE-440B-B6E0-77F1BD464184}"/>
+                  <c16:uniqueId val="{00000002-638B-4B80-AA7C-FE7844F8EC05}"/>
                 </c:ext>
               </c:extLst>
             </c:dLbl>
@@ -3174,7 +4303,7 @@
               <c:extLst>
                 <c:ext xmlns:c15="http://schemas.microsoft.com/office/drawing/2012/chart" uri="{CE6537A1-D6FC-4f65-9D91-7224C49458BB}"/>
                 <c:ext xmlns:c16="http://schemas.microsoft.com/office/drawing/2014/chart" uri="{C3380CC4-5D6E-409C-BE32-E72D297353CC}">
-                  <c16:uniqueId val="{00000003-6BAE-440B-B6E0-77F1BD464184}"/>
+                  <c16:uniqueId val="{00000003-638B-4B80-AA7C-FE7844F8EC05}"/>
                 </c:ext>
               </c:extLst>
             </c:dLbl>
@@ -3288,7 +4417,7 @@
           </c:val>
           <c:extLst>
             <c:ext xmlns:c16="http://schemas.microsoft.com/office/drawing/2014/chart" uri="{C3380CC4-5D6E-409C-BE32-E72D297353CC}">
-              <c16:uniqueId val="{00000000-6BAE-440B-B6E0-77F1BD464184}"/>
+              <c16:uniqueId val="{00000000-638B-4B80-AA7C-FE7844F8EC05}"/>
             </c:ext>
           </c:extLst>
         </c:ser>
@@ -3507,7 +4636,7 @@
           </c:val>
           <c:extLst>
             <c:ext xmlns:c16="http://schemas.microsoft.com/office/drawing/2014/chart" uri="{C3380CC4-5D6E-409C-BE32-E72D297353CC}">
-              <c16:uniqueId val="{00000000-21DE-4DEF-84CC-ABF7B6A94DDD}"/>
+              <c16:uniqueId val="{00000000-3009-4620-9441-502F2FA6EBF7}"/>
             </c:ext>
           </c:extLst>
         </c:ser>
@@ -3561,7 +4690,7 @@
                   <c15:showDataLabelsRange val="0"/>
                 </c:ext>
                 <c:ext xmlns:c16="http://schemas.microsoft.com/office/drawing/2014/chart" uri="{C3380CC4-5D6E-409C-BE32-E72D297353CC}">
-                  <c16:uniqueId val="{00000003-21DE-4DEF-84CC-ABF7B6A94DDD}"/>
+                  <c16:uniqueId val="{00000003-3009-4620-9441-502F2FA6EBF7}"/>
                 </c:ext>
               </c:extLst>
             </c:dLbl>
@@ -3650,7 +4779,7 @@
           </c:val>
           <c:extLst>
             <c:ext xmlns:c16="http://schemas.microsoft.com/office/drawing/2014/chart" uri="{C3380CC4-5D6E-409C-BE32-E72D297353CC}">
-              <c16:uniqueId val="{00000001-21DE-4DEF-84CC-ABF7B6A94DDD}"/>
+              <c16:uniqueId val="{00000001-3009-4620-9441-502F2FA6EBF7}"/>
             </c:ext>
           </c:extLst>
         </c:ser>
@@ -3721,7 +4850,7 @@
           </c:val>
           <c:extLst>
             <c:ext xmlns:c16="http://schemas.microsoft.com/office/drawing/2014/chart" uri="{C3380CC4-5D6E-409C-BE32-E72D297353CC}">
-              <c16:uniqueId val="{00000002-21DE-4DEF-84CC-ABF7B6A94DDD}"/>
+              <c16:uniqueId val="{00000002-3009-4620-9441-502F2FA6EBF7}"/>
             </c:ext>
           </c:extLst>
         </c:ser>
@@ -3734,11 +4863,11 @@
           <c:showBubbleSize val="0"/>
         </c:dLbls>
         <c:gapWidth val="182"/>
-        <c:axId val="7288768"/>
-        <c:axId val="1193316816"/>
+        <c:axId val="1680449584"/>
+        <c:axId val="253570800"/>
       </c:barChart>
       <c:catAx>
-        <c:axId val="7288768"/>
+        <c:axId val="1680449584"/>
         <c:scaling>
           <c:orientation val="minMax"/>
         </c:scaling>
@@ -3781,7 +4910,7 @@
             <a:endParaRPr lang="de-DE"/>
           </a:p>
         </c:txPr>
-        <c:crossAx val="1193316816"/>
+        <c:crossAx val="253570800"/>
         <c:crosses val="autoZero"/>
         <c:auto val="1"/>
         <c:lblAlgn val="ctr"/>
@@ -3789,7 +4918,7 @@
         <c:noMultiLvlLbl val="0"/>
       </c:catAx>
       <c:valAx>
-        <c:axId val="1193316816"/>
+        <c:axId val="253570800"/>
         <c:scaling>
           <c:orientation val="minMax"/>
         </c:scaling>
@@ -3840,7 +4969,7 @@
             <a:endParaRPr lang="de-DE"/>
           </a:p>
         </c:txPr>
-        <c:crossAx val="7288768"/>
+        <c:crossAx val="1680449584"/>
         <c:crosses val="autoZero"/>
         <c:crossBetween val="between"/>
       </c:valAx>
@@ -4005,7 +5134,7 @@
           </c:val>
           <c:extLst>
             <c:ext xmlns:c16="http://schemas.microsoft.com/office/drawing/2014/chart" uri="{C3380CC4-5D6E-409C-BE32-E72D297353CC}">
-              <c16:uniqueId val="{00000000-D815-4B43-AE13-B0677E3EDC61}"/>
+              <c16:uniqueId val="{00000000-ACA8-42AC-A775-EAEFEC50619B}"/>
             </c:ext>
           </c:extLst>
         </c:ser>
@@ -4076,7 +5205,7 @@
           </c:val>
           <c:extLst>
             <c:ext xmlns:c16="http://schemas.microsoft.com/office/drawing/2014/chart" uri="{C3380CC4-5D6E-409C-BE32-E72D297353CC}">
-              <c16:uniqueId val="{00000001-D815-4B43-AE13-B0677E3EDC61}"/>
+              <c16:uniqueId val="{00000001-ACA8-42AC-A775-EAEFEC50619B}"/>
             </c:ext>
           </c:extLst>
         </c:ser>
@@ -4147,7 +5276,7 @@
           </c:val>
           <c:extLst>
             <c:ext xmlns:c16="http://schemas.microsoft.com/office/drawing/2014/chart" uri="{C3380CC4-5D6E-409C-BE32-E72D297353CC}">
-              <c16:uniqueId val="{00000002-D815-4B43-AE13-B0677E3EDC61}"/>
+              <c16:uniqueId val="{00000002-ACA8-42AC-A775-EAEFEC50619B}"/>
             </c:ext>
           </c:extLst>
         </c:ser>
@@ -4161,11 +5290,11 @@
         </c:dLbls>
         <c:gapWidth val="219"/>
         <c:overlap val="-27"/>
-        <c:axId val="9922928"/>
-        <c:axId val="1193309616"/>
+        <c:axId val="1680437520"/>
+        <c:axId val="253616880"/>
       </c:barChart>
       <c:catAx>
-        <c:axId val="9922928"/>
+        <c:axId val="1680437520"/>
         <c:scaling>
           <c:orientation val="minMax"/>
         </c:scaling>
@@ -4208,7 +5337,7 @@
             <a:endParaRPr lang="de-DE"/>
           </a:p>
         </c:txPr>
-        <c:crossAx val="1193309616"/>
+        <c:crossAx val="253616880"/>
         <c:crosses val="autoZero"/>
         <c:auto val="1"/>
         <c:lblAlgn val="ctr"/>
@@ -4216,7 +5345,7 @@
         <c:noMultiLvlLbl val="0"/>
       </c:catAx>
       <c:valAx>
-        <c:axId val="1193309616"/>
+        <c:axId val="253616880"/>
         <c:scaling>
           <c:orientation val="minMax"/>
         </c:scaling>
@@ -4267,7 +5396,7 @@
             <a:endParaRPr lang="de-DE"/>
           </a:p>
         </c:txPr>
-        <c:crossAx val="9922928"/>
+        <c:crossAx val="1680437520"/>
         <c:crosses val="autoZero"/>
         <c:crossBetween val="between"/>
       </c:valAx>
@@ -4428,6 +5557,86 @@
 </file>
 
 <file path=ppt/charts/colors11.xml><?xml version="1.0" encoding="utf-8"?>
+<cs:colorStyle xmlns:cs="http://schemas.microsoft.com/office/drawing/2012/chartStyle" xmlns:a="http://schemas.openxmlformats.org/drawingml/2006/main" meth="cycle" id="10">
+  <a:schemeClr val="accent1"/>
+  <a:schemeClr val="accent2"/>
+  <a:schemeClr val="accent3"/>
+  <a:schemeClr val="accent4"/>
+  <a:schemeClr val="accent5"/>
+  <a:schemeClr val="accent6"/>
+  <cs:variation/>
+  <cs:variation>
+    <a:lumMod val="60000"/>
+  </cs:variation>
+  <cs:variation>
+    <a:lumMod val="80000"/>
+    <a:lumOff val="20000"/>
+  </cs:variation>
+  <cs:variation>
+    <a:lumMod val="80000"/>
+  </cs:variation>
+  <cs:variation>
+    <a:lumMod val="60000"/>
+    <a:lumOff val="40000"/>
+  </cs:variation>
+  <cs:variation>
+    <a:lumMod val="50000"/>
+  </cs:variation>
+  <cs:variation>
+    <a:lumMod val="70000"/>
+    <a:lumOff val="30000"/>
+  </cs:variation>
+  <cs:variation>
+    <a:lumMod val="70000"/>
+  </cs:variation>
+  <cs:variation>
+    <a:lumMod val="50000"/>
+    <a:lumOff val="50000"/>
+  </cs:variation>
+</cs:colorStyle>
+</file>
+
+<file path=ppt/charts/colors12.xml><?xml version="1.0" encoding="utf-8"?>
+<cs:colorStyle xmlns:cs="http://schemas.microsoft.com/office/drawing/2012/chartStyle" xmlns:a="http://schemas.openxmlformats.org/drawingml/2006/main" meth="cycle" id="10">
+  <a:schemeClr val="accent1"/>
+  <a:schemeClr val="accent2"/>
+  <a:schemeClr val="accent3"/>
+  <a:schemeClr val="accent4"/>
+  <a:schemeClr val="accent5"/>
+  <a:schemeClr val="accent6"/>
+  <cs:variation/>
+  <cs:variation>
+    <a:lumMod val="60000"/>
+  </cs:variation>
+  <cs:variation>
+    <a:lumMod val="80000"/>
+    <a:lumOff val="20000"/>
+  </cs:variation>
+  <cs:variation>
+    <a:lumMod val="80000"/>
+  </cs:variation>
+  <cs:variation>
+    <a:lumMod val="60000"/>
+    <a:lumOff val="40000"/>
+  </cs:variation>
+  <cs:variation>
+    <a:lumMod val="50000"/>
+  </cs:variation>
+  <cs:variation>
+    <a:lumMod val="70000"/>
+    <a:lumOff val="30000"/>
+  </cs:variation>
+  <cs:variation>
+    <a:lumMod val="70000"/>
+  </cs:variation>
+  <cs:variation>
+    <a:lumMod val="50000"/>
+    <a:lumOff val="50000"/>
+  </cs:variation>
+</cs:colorStyle>
+</file>
+
+<file path=ppt/charts/colors13.xml><?xml version="1.0" encoding="utf-8"?>
 <cs:colorStyle xmlns:cs="http://schemas.microsoft.com/office/drawing/2012/chartStyle" xmlns:a="http://schemas.openxmlformats.org/drawingml/2006/main" meth="cycle" id="10">
   <a:schemeClr val="accent1"/>
   <a:schemeClr val="accent2"/>
@@ -6328,6 +7537,1014 @@
 </cs:chartStyle>
 </file>
 
+<file path=ppt/charts/style12.xml><?xml version="1.0" encoding="utf-8"?>
+<cs:chartStyle xmlns:cs="http://schemas.microsoft.com/office/drawing/2012/chartStyle" xmlns:a="http://schemas.openxmlformats.org/drawingml/2006/main" id="201">
+  <cs:axisTitle>
+    <cs:lnRef idx="0"/>
+    <cs:fillRef idx="0"/>
+    <cs:effectRef idx="0"/>
+    <cs:fontRef idx="minor">
+      <a:schemeClr val="tx1">
+        <a:lumMod val="65000"/>
+        <a:lumOff val="35000"/>
+      </a:schemeClr>
+    </cs:fontRef>
+    <cs:defRPr sz="1330" kern="1200"/>
+  </cs:axisTitle>
+  <cs:categoryAxis>
+    <cs:lnRef idx="0"/>
+    <cs:fillRef idx="0"/>
+    <cs:effectRef idx="0"/>
+    <cs:fontRef idx="minor">
+      <a:schemeClr val="tx1">
+        <a:lumMod val="65000"/>
+        <a:lumOff val="35000"/>
+      </a:schemeClr>
+    </cs:fontRef>
+    <cs:spPr>
+      <a:ln w="9525" cap="flat" cmpd="sng" algn="ctr">
+        <a:solidFill>
+          <a:schemeClr val="tx1">
+            <a:lumMod val="15000"/>
+            <a:lumOff val="85000"/>
+          </a:schemeClr>
+        </a:solidFill>
+        <a:round/>
+      </a:ln>
+    </cs:spPr>
+    <cs:defRPr sz="1197" kern="1200"/>
+  </cs:categoryAxis>
+  <cs:chartArea mods="allowNoFillOverride allowNoLineOverride">
+    <cs:lnRef idx="0"/>
+    <cs:fillRef idx="0"/>
+    <cs:effectRef idx="0"/>
+    <cs:fontRef idx="minor">
+      <a:schemeClr val="tx1"/>
+    </cs:fontRef>
+    <cs:spPr>
+      <a:solidFill>
+        <a:schemeClr val="bg1"/>
+      </a:solidFill>
+      <a:ln w="9525" cap="flat" cmpd="sng" algn="ctr">
+        <a:solidFill>
+          <a:schemeClr val="tx1">
+            <a:lumMod val="15000"/>
+            <a:lumOff val="85000"/>
+          </a:schemeClr>
+        </a:solidFill>
+        <a:round/>
+      </a:ln>
+    </cs:spPr>
+    <cs:defRPr sz="1330" kern="1200"/>
+  </cs:chartArea>
+  <cs:dataLabel>
+    <cs:lnRef idx="0"/>
+    <cs:fillRef idx="0"/>
+    <cs:effectRef idx="0"/>
+    <cs:fontRef idx="minor">
+      <a:schemeClr val="tx1">
+        <a:lumMod val="75000"/>
+        <a:lumOff val="25000"/>
+      </a:schemeClr>
+    </cs:fontRef>
+    <cs:defRPr sz="1197" kern="1200"/>
+  </cs:dataLabel>
+  <cs:dataLabelCallout>
+    <cs:lnRef idx="0"/>
+    <cs:fillRef idx="0"/>
+    <cs:effectRef idx="0"/>
+    <cs:fontRef idx="minor">
+      <a:schemeClr val="dk1">
+        <a:lumMod val="65000"/>
+        <a:lumOff val="35000"/>
+      </a:schemeClr>
+    </cs:fontRef>
+    <cs:spPr>
+      <a:solidFill>
+        <a:schemeClr val="lt1"/>
+      </a:solidFill>
+      <a:ln>
+        <a:solidFill>
+          <a:schemeClr val="dk1">
+            <a:lumMod val="25000"/>
+            <a:lumOff val="75000"/>
+          </a:schemeClr>
+        </a:solidFill>
+      </a:ln>
+    </cs:spPr>
+    <cs:defRPr sz="1197" kern="1200"/>
+    <cs:bodyPr rot="0" spcFirstLastPara="1" vertOverflow="clip" horzOverflow="clip" vert="horz" wrap="square" lIns="36576" tIns="18288" rIns="36576" bIns="18288" anchor="ctr" anchorCtr="1">
+      <a:spAutoFit/>
+    </cs:bodyPr>
+  </cs:dataLabelCallout>
+  <cs:dataPoint>
+    <cs:lnRef idx="0"/>
+    <cs:fillRef idx="1">
+      <cs:styleClr val="auto"/>
+    </cs:fillRef>
+    <cs:effectRef idx="0"/>
+    <cs:fontRef idx="minor">
+      <a:schemeClr val="tx1"/>
+    </cs:fontRef>
+  </cs:dataPoint>
+  <cs:dataPoint3D>
+    <cs:lnRef idx="0"/>
+    <cs:fillRef idx="1">
+      <cs:styleClr val="auto"/>
+    </cs:fillRef>
+    <cs:effectRef idx="0"/>
+    <cs:fontRef idx="minor">
+      <a:schemeClr val="tx1"/>
+    </cs:fontRef>
+  </cs:dataPoint3D>
+  <cs:dataPointLine>
+    <cs:lnRef idx="0">
+      <cs:styleClr val="auto"/>
+    </cs:lnRef>
+    <cs:fillRef idx="1"/>
+    <cs:effectRef idx="0"/>
+    <cs:fontRef idx="minor">
+      <a:schemeClr val="tx1"/>
+    </cs:fontRef>
+    <cs:spPr>
+      <a:ln w="28575" cap="rnd">
+        <a:solidFill>
+          <a:schemeClr val="phClr"/>
+        </a:solidFill>
+        <a:round/>
+      </a:ln>
+    </cs:spPr>
+  </cs:dataPointLine>
+  <cs:dataPointMarker>
+    <cs:lnRef idx="0">
+      <cs:styleClr val="auto"/>
+    </cs:lnRef>
+    <cs:fillRef idx="1">
+      <cs:styleClr val="auto"/>
+    </cs:fillRef>
+    <cs:effectRef idx="0"/>
+    <cs:fontRef idx="minor">
+      <a:schemeClr val="tx1"/>
+    </cs:fontRef>
+    <cs:spPr>
+      <a:ln w="9525">
+        <a:solidFill>
+          <a:schemeClr val="phClr"/>
+        </a:solidFill>
+      </a:ln>
+    </cs:spPr>
+  </cs:dataPointMarker>
+  <cs:dataPointMarkerLayout symbol="circle" size="5"/>
+  <cs:dataPointWireframe>
+    <cs:lnRef idx="0">
+      <cs:styleClr val="auto"/>
+    </cs:lnRef>
+    <cs:fillRef idx="1"/>
+    <cs:effectRef idx="0"/>
+    <cs:fontRef idx="minor">
+      <a:schemeClr val="tx1"/>
+    </cs:fontRef>
+    <cs:spPr>
+      <a:ln w="9525" cap="rnd">
+        <a:solidFill>
+          <a:schemeClr val="phClr"/>
+        </a:solidFill>
+        <a:round/>
+      </a:ln>
+    </cs:spPr>
+  </cs:dataPointWireframe>
+  <cs:dataTable>
+    <cs:lnRef idx="0"/>
+    <cs:fillRef idx="0"/>
+    <cs:effectRef idx="0"/>
+    <cs:fontRef idx="minor">
+      <a:schemeClr val="tx1">
+        <a:lumMod val="65000"/>
+        <a:lumOff val="35000"/>
+      </a:schemeClr>
+    </cs:fontRef>
+    <cs:spPr>
+      <a:noFill/>
+      <a:ln w="9525" cap="flat" cmpd="sng" algn="ctr">
+        <a:solidFill>
+          <a:schemeClr val="tx1">
+            <a:lumMod val="15000"/>
+            <a:lumOff val="85000"/>
+          </a:schemeClr>
+        </a:solidFill>
+        <a:round/>
+      </a:ln>
+    </cs:spPr>
+    <cs:defRPr sz="1197" kern="1200"/>
+  </cs:dataTable>
+  <cs:downBar>
+    <cs:lnRef idx="0"/>
+    <cs:fillRef idx="0"/>
+    <cs:effectRef idx="0"/>
+    <cs:fontRef idx="minor">
+      <a:schemeClr val="dk1"/>
+    </cs:fontRef>
+    <cs:spPr>
+      <a:solidFill>
+        <a:schemeClr val="dk1">
+          <a:lumMod val="65000"/>
+          <a:lumOff val="35000"/>
+        </a:schemeClr>
+      </a:solidFill>
+      <a:ln w="9525">
+        <a:solidFill>
+          <a:schemeClr val="tx1">
+            <a:lumMod val="65000"/>
+            <a:lumOff val="35000"/>
+          </a:schemeClr>
+        </a:solidFill>
+      </a:ln>
+    </cs:spPr>
+  </cs:downBar>
+  <cs:dropLine>
+    <cs:lnRef idx="0"/>
+    <cs:fillRef idx="0"/>
+    <cs:effectRef idx="0"/>
+    <cs:fontRef idx="minor">
+      <a:schemeClr val="tx1"/>
+    </cs:fontRef>
+    <cs:spPr>
+      <a:ln w="9525" cap="flat" cmpd="sng" algn="ctr">
+        <a:solidFill>
+          <a:schemeClr val="tx1">
+            <a:lumMod val="35000"/>
+            <a:lumOff val="65000"/>
+          </a:schemeClr>
+        </a:solidFill>
+        <a:round/>
+      </a:ln>
+    </cs:spPr>
+  </cs:dropLine>
+  <cs:errorBar>
+    <cs:lnRef idx="0"/>
+    <cs:fillRef idx="0"/>
+    <cs:effectRef idx="0"/>
+    <cs:fontRef idx="minor">
+      <a:schemeClr val="tx1"/>
+    </cs:fontRef>
+    <cs:spPr>
+      <a:ln w="9525" cap="flat" cmpd="sng" algn="ctr">
+        <a:solidFill>
+          <a:schemeClr val="tx1">
+            <a:lumMod val="65000"/>
+            <a:lumOff val="35000"/>
+          </a:schemeClr>
+        </a:solidFill>
+        <a:round/>
+      </a:ln>
+    </cs:spPr>
+  </cs:errorBar>
+  <cs:floor>
+    <cs:lnRef idx="0"/>
+    <cs:fillRef idx="0"/>
+    <cs:effectRef idx="0"/>
+    <cs:fontRef idx="minor">
+      <a:schemeClr val="tx1"/>
+    </cs:fontRef>
+    <cs:spPr>
+      <a:noFill/>
+      <a:ln>
+        <a:noFill/>
+      </a:ln>
+    </cs:spPr>
+  </cs:floor>
+  <cs:gridlineMajor>
+    <cs:lnRef idx="0"/>
+    <cs:fillRef idx="0"/>
+    <cs:effectRef idx="0"/>
+    <cs:fontRef idx="minor">
+      <a:schemeClr val="tx1"/>
+    </cs:fontRef>
+    <cs:spPr>
+      <a:ln w="9525" cap="flat" cmpd="sng" algn="ctr">
+        <a:solidFill>
+          <a:schemeClr val="tx1">
+            <a:lumMod val="15000"/>
+            <a:lumOff val="85000"/>
+          </a:schemeClr>
+        </a:solidFill>
+        <a:round/>
+      </a:ln>
+    </cs:spPr>
+  </cs:gridlineMajor>
+  <cs:gridlineMinor>
+    <cs:lnRef idx="0"/>
+    <cs:fillRef idx="0"/>
+    <cs:effectRef idx="0"/>
+    <cs:fontRef idx="minor">
+      <a:schemeClr val="tx1"/>
+    </cs:fontRef>
+    <cs:spPr>
+      <a:ln w="9525" cap="flat" cmpd="sng" algn="ctr">
+        <a:solidFill>
+          <a:schemeClr val="tx1">
+            <a:lumMod val="5000"/>
+            <a:lumOff val="95000"/>
+          </a:schemeClr>
+        </a:solidFill>
+        <a:round/>
+      </a:ln>
+    </cs:spPr>
+  </cs:gridlineMinor>
+  <cs:hiLoLine>
+    <cs:lnRef idx="0"/>
+    <cs:fillRef idx="0"/>
+    <cs:effectRef idx="0"/>
+    <cs:fontRef idx="minor">
+      <a:schemeClr val="tx1"/>
+    </cs:fontRef>
+    <cs:spPr>
+      <a:ln w="9525" cap="flat" cmpd="sng" algn="ctr">
+        <a:solidFill>
+          <a:schemeClr val="tx1">
+            <a:lumMod val="75000"/>
+            <a:lumOff val="25000"/>
+          </a:schemeClr>
+        </a:solidFill>
+        <a:round/>
+      </a:ln>
+    </cs:spPr>
+  </cs:hiLoLine>
+  <cs:leaderLine>
+    <cs:lnRef idx="0"/>
+    <cs:fillRef idx="0"/>
+    <cs:effectRef idx="0"/>
+    <cs:fontRef idx="minor">
+      <a:schemeClr val="tx1"/>
+    </cs:fontRef>
+    <cs:spPr>
+      <a:ln w="9525" cap="flat" cmpd="sng" algn="ctr">
+        <a:solidFill>
+          <a:schemeClr val="tx1">
+            <a:lumMod val="35000"/>
+            <a:lumOff val="65000"/>
+          </a:schemeClr>
+        </a:solidFill>
+        <a:round/>
+      </a:ln>
+    </cs:spPr>
+  </cs:leaderLine>
+  <cs:legend>
+    <cs:lnRef idx="0"/>
+    <cs:fillRef idx="0"/>
+    <cs:effectRef idx="0"/>
+    <cs:fontRef idx="minor">
+      <a:schemeClr val="tx1">
+        <a:lumMod val="65000"/>
+        <a:lumOff val="35000"/>
+      </a:schemeClr>
+    </cs:fontRef>
+    <cs:defRPr sz="1197" kern="1200"/>
+  </cs:legend>
+  <cs:plotArea mods="allowNoFillOverride allowNoLineOverride">
+    <cs:lnRef idx="0"/>
+    <cs:fillRef idx="0"/>
+    <cs:effectRef idx="0"/>
+    <cs:fontRef idx="minor">
+      <a:schemeClr val="tx1"/>
+    </cs:fontRef>
+  </cs:plotArea>
+  <cs:plotArea3D mods="allowNoFillOverride allowNoLineOverride">
+    <cs:lnRef idx="0"/>
+    <cs:fillRef idx="0"/>
+    <cs:effectRef idx="0"/>
+    <cs:fontRef idx="minor">
+      <a:schemeClr val="tx1"/>
+    </cs:fontRef>
+  </cs:plotArea3D>
+  <cs:seriesAxis>
+    <cs:lnRef idx="0"/>
+    <cs:fillRef idx="0"/>
+    <cs:effectRef idx="0"/>
+    <cs:fontRef idx="minor">
+      <a:schemeClr val="tx1">
+        <a:lumMod val="65000"/>
+        <a:lumOff val="35000"/>
+      </a:schemeClr>
+    </cs:fontRef>
+    <cs:defRPr sz="1197" kern="1200"/>
+  </cs:seriesAxis>
+  <cs:seriesLine>
+    <cs:lnRef idx="0"/>
+    <cs:fillRef idx="0"/>
+    <cs:effectRef idx="0"/>
+    <cs:fontRef idx="minor">
+      <a:schemeClr val="tx1"/>
+    </cs:fontRef>
+    <cs:spPr>
+      <a:ln w="9525" cap="flat" cmpd="sng" algn="ctr">
+        <a:solidFill>
+          <a:schemeClr val="tx1">
+            <a:lumMod val="35000"/>
+            <a:lumOff val="65000"/>
+          </a:schemeClr>
+        </a:solidFill>
+        <a:round/>
+      </a:ln>
+    </cs:spPr>
+  </cs:seriesLine>
+  <cs:title>
+    <cs:lnRef idx="0"/>
+    <cs:fillRef idx="0"/>
+    <cs:effectRef idx="0"/>
+    <cs:fontRef idx="minor">
+      <a:schemeClr val="tx1">
+        <a:lumMod val="65000"/>
+        <a:lumOff val="35000"/>
+      </a:schemeClr>
+    </cs:fontRef>
+    <cs:defRPr sz="1862" b="0" kern="1200" spc="0" baseline="0"/>
+  </cs:title>
+  <cs:trendline>
+    <cs:lnRef idx="0">
+      <cs:styleClr val="auto"/>
+    </cs:lnRef>
+    <cs:fillRef idx="0"/>
+    <cs:effectRef idx="0"/>
+    <cs:fontRef idx="minor">
+      <a:schemeClr val="tx1"/>
+    </cs:fontRef>
+    <cs:spPr>
+      <a:ln w="19050" cap="rnd">
+        <a:solidFill>
+          <a:schemeClr val="phClr"/>
+        </a:solidFill>
+        <a:prstDash val="sysDot"/>
+      </a:ln>
+    </cs:spPr>
+  </cs:trendline>
+  <cs:trendlineLabel>
+    <cs:lnRef idx="0"/>
+    <cs:fillRef idx="0"/>
+    <cs:effectRef idx="0"/>
+    <cs:fontRef idx="minor">
+      <a:schemeClr val="tx1">
+        <a:lumMod val="65000"/>
+        <a:lumOff val="35000"/>
+      </a:schemeClr>
+    </cs:fontRef>
+    <cs:defRPr sz="1197" kern="1200"/>
+  </cs:trendlineLabel>
+  <cs:upBar>
+    <cs:lnRef idx="0"/>
+    <cs:fillRef idx="0"/>
+    <cs:effectRef idx="0"/>
+    <cs:fontRef idx="minor">
+      <a:schemeClr val="dk1"/>
+    </cs:fontRef>
+    <cs:spPr>
+      <a:solidFill>
+        <a:schemeClr val="lt1"/>
+      </a:solidFill>
+      <a:ln w="9525">
+        <a:solidFill>
+          <a:schemeClr val="tx1">
+            <a:lumMod val="15000"/>
+            <a:lumOff val="85000"/>
+          </a:schemeClr>
+        </a:solidFill>
+      </a:ln>
+    </cs:spPr>
+  </cs:upBar>
+  <cs:valueAxis>
+    <cs:lnRef idx="0"/>
+    <cs:fillRef idx="0"/>
+    <cs:effectRef idx="0"/>
+    <cs:fontRef idx="minor">
+      <a:schemeClr val="tx1">
+        <a:lumMod val="65000"/>
+        <a:lumOff val="35000"/>
+      </a:schemeClr>
+    </cs:fontRef>
+    <cs:defRPr sz="1197" kern="1200"/>
+  </cs:valueAxis>
+  <cs:wall>
+    <cs:lnRef idx="0"/>
+    <cs:fillRef idx="0"/>
+    <cs:effectRef idx="0"/>
+    <cs:fontRef idx="minor">
+      <a:schemeClr val="tx1"/>
+    </cs:fontRef>
+    <cs:spPr>
+      <a:noFill/>
+      <a:ln>
+        <a:noFill/>
+      </a:ln>
+    </cs:spPr>
+  </cs:wall>
+</cs:chartStyle>
+</file>
+
+<file path=ppt/charts/style13.xml><?xml version="1.0" encoding="utf-8"?>
+<cs:chartStyle xmlns:cs="http://schemas.microsoft.com/office/drawing/2012/chartStyle" xmlns:a="http://schemas.openxmlformats.org/drawingml/2006/main" id="216">
+  <cs:axisTitle>
+    <cs:lnRef idx="0"/>
+    <cs:fillRef idx="0"/>
+    <cs:effectRef idx="0"/>
+    <cs:fontRef idx="minor">
+      <a:schemeClr val="tx1">
+        <a:lumMod val="65000"/>
+        <a:lumOff val="35000"/>
+      </a:schemeClr>
+    </cs:fontRef>
+    <cs:defRPr sz="1330" kern="1200"/>
+  </cs:axisTitle>
+  <cs:categoryAxis>
+    <cs:lnRef idx="0"/>
+    <cs:fillRef idx="0"/>
+    <cs:effectRef idx="0"/>
+    <cs:fontRef idx="minor">
+      <a:schemeClr val="tx1">
+        <a:lumMod val="65000"/>
+        <a:lumOff val="35000"/>
+      </a:schemeClr>
+    </cs:fontRef>
+    <cs:spPr>
+      <a:ln w="9525" cap="flat" cmpd="sng" algn="ctr">
+        <a:solidFill>
+          <a:schemeClr val="tx1">
+            <a:lumMod val="15000"/>
+            <a:lumOff val="85000"/>
+          </a:schemeClr>
+        </a:solidFill>
+        <a:round/>
+      </a:ln>
+    </cs:spPr>
+    <cs:defRPr sz="1197" kern="1200"/>
+  </cs:categoryAxis>
+  <cs:chartArea mods="allowNoFillOverride allowNoLineOverride">
+    <cs:lnRef idx="0"/>
+    <cs:fillRef idx="0"/>
+    <cs:effectRef idx="0"/>
+    <cs:fontRef idx="minor">
+      <a:schemeClr val="tx1"/>
+    </cs:fontRef>
+    <cs:spPr>
+      <a:solidFill>
+        <a:schemeClr val="bg1"/>
+      </a:solidFill>
+      <a:ln w="9525" cap="flat" cmpd="sng" algn="ctr">
+        <a:solidFill>
+          <a:schemeClr val="tx1">
+            <a:lumMod val="15000"/>
+            <a:lumOff val="85000"/>
+          </a:schemeClr>
+        </a:solidFill>
+        <a:round/>
+      </a:ln>
+    </cs:spPr>
+    <cs:defRPr sz="1330" kern="1200"/>
+  </cs:chartArea>
+  <cs:dataLabel>
+    <cs:lnRef idx="0"/>
+    <cs:fillRef idx="0"/>
+    <cs:effectRef idx="0"/>
+    <cs:fontRef idx="minor">
+      <a:schemeClr val="tx1">
+        <a:lumMod val="75000"/>
+        <a:lumOff val="25000"/>
+      </a:schemeClr>
+    </cs:fontRef>
+    <cs:defRPr sz="1197" kern="1200"/>
+  </cs:dataLabel>
+  <cs:dataLabelCallout>
+    <cs:lnRef idx="0"/>
+    <cs:fillRef idx="0"/>
+    <cs:effectRef idx="0"/>
+    <cs:fontRef idx="minor">
+      <a:schemeClr val="dk1">
+        <a:lumMod val="65000"/>
+        <a:lumOff val="35000"/>
+      </a:schemeClr>
+    </cs:fontRef>
+    <cs:spPr>
+      <a:solidFill>
+        <a:schemeClr val="lt1"/>
+      </a:solidFill>
+      <a:ln>
+        <a:solidFill>
+          <a:schemeClr val="dk1">
+            <a:lumMod val="25000"/>
+            <a:lumOff val="75000"/>
+          </a:schemeClr>
+        </a:solidFill>
+      </a:ln>
+    </cs:spPr>
+    <cs:defRPr sz="1197" kern="1200"/>
+    <cs:bodyPr rot="0" spcFirstLastPara="1" vertOverflow="clip" horzOverflow="clip" vert="horz" wrap="square" lIns="36576" tIns="18288" rIns="36576" bIns="18288" anchor="ctr" anchorCtr="1">
+      <a:spAutoFit/>
+    </cs:bodyPr>
+  </cs:dataLabelCallout>
+  <cs:dataPoint>
+    <cs:lnRef idx="0"/>
+    <cs:fillRef idx="1">
+      <cs:styleClr val="auto"/>
+    </cs:fillRef>
+    <cs:effectRef idx="0"/>
+    <cs:fontRef idx="minor">
+      <a:schemeClr val="tx1"/>
+    </cs:fontRef>
+  </cs:dataPoint>
+  <cs:dataPoint3D>
+    <cs:lnRef idx="0"/>
+    <cs:fillRef idx="1">
+      <cs:styleClr val="auto"/>
+    </cs:fillRef>
+    <cs:effectRef idx="0"/>
+    <cs:fontRef idx="minor">
+      <a:schemeClr val="tx1"/>
+    </cs:fontRef>
+  </cs:dataPoint3D>
+  <cs:dataPointLine>
+    <cs:lnRef idx="0">
+      <cs:styleClr val="auto"/>
+    </cs:lnRef>
+    <cs:fillRef idx="1"/>
+    <cs:effectRef idx="0"/>
+    <cs:fontRef idx="minor">
+      <a:schemeClr val="tx1"/>
+    </cs:fontRef>
+    <cs:spPr>
+      <a:ln w="28575" cap="rnd">
+        <a:solidFill>
+          <a:schemeClr val="phClr"/>
+        </a:solidFill>
+        <a:round/>
+      </a:ln>
+    </cs:spPr>
+  </cs:dataPointLine>
+  <cs:dataPointMarker>
+    <cs:lnRef idx="0">
+      <cs:styleClr val="auto"/>
+    </cs:lnRef>
+    <cs:fillRef idx="1">
+      <cs:styleClr val="auto"/>
+    </cs:fillRef>
+    <cs:effectRef idx="0"/>
+    <cs:fontRef idx="minor">
+      <a:schemeClr val="tx1"/>
+    </cs:fontRef>
+    <cs:spPr>
+      <a:ln w="9525">
+        <a:solidFill>
+          <a:schemeClr val="phClr"/>
+        </a:solidFill>
+      </a:ln>
+    </cs:spPr>
+  </cs:dataPointMarker>
+  <cs:dataPointMarkerLayout symbol="circle" size="5"/>
+  <cs:dataPointWireframe>
+    <cs:lnRef idx="0">
+      <cs:styleClr val="auto"/>
+    </cs:lnRef>
+    <cs:fillRef idx="1"/>
+    <cs:effectRef idx="0"/>
+    <cs:fontRef idx="minor">
+      <a:schemeClr val="tx1"/>
+    </cs:fontRef>
+    <cs:spPr>
+      <a:ln w="9525" cap="rnd">
+        <a:solidFill>
+          <a:schemeClr val="phClr"/>
+        </a:solidFill>
+        <a:round/>
+      </a:ln>
+    </cs:spPr>
+  </cs:dataPointWireframe>
+  <cs:dataTable>
+    <cs:lnRef idx="0"/>
+    <cs:fillRef idx="0"/>
+    <cs:effectRef idx="0"/>
+    <cs:fontRef idx="minor">
+      <a:schemeClr val="tx1">
+        <a:lumMod val="65000"/>
+        <a:lumOff val="35000"/>
+      </a:schemeClr>
+    </cs:fontRef>
+    <cs:spPr>
+      <a:noFill/>
+      <a:ln w="9525" cap="flat" cmpd="sng" algn="ctr">
+        <a:solidFill>
+          <a:schemeClr val="tx1">
+            <a:lumMod val="15000"/>
+            <a:lumOff val="85000"/>
+          </a:schemeClr>
+        </a:solidFill>
+        <a:round/>
+      </a:ln>
+    </cs:spPr>
+    <cs:defRPr sz="1197" kern="1200"/>
+  </cs:dataTable>
+  <cs:downBar>
+    <cs:lnRef idx="0"/>
+    <cs:fillRef idx="0"/>
+    <cs:effectRef idx="0"/>
+    <cs:fontRef idx="minor">
+      <a:schemeClr val="tx1"/>
+    </cs:fontRef>
+    <cs:spPr>
+      <a:solidFill>
+        <a:schemeClr val="dk1">
+          <a:lumMod val="75000"/>
+          <a:lumOff val="25000"/>
+        </a:schemeClr>
+      </a:solidFill>
+      <a:ln w="9525" cap="flat" cmpd="sng" algn="ctr">
+        <a:solidFill>
+          <a:schemeClr val="tx1">
+            <a:lumMod val="65000"/>
+            <a:lumOff val="35000"/>
+          </a:schemeClr>
+        </a:solidFill>
+        <a:round/>
+      </a:ln>
+    </cs:spPr>
+  </cs:downBar>
+  <cs:dropLine>
+    <cs:lnRef idx="0"/>
+    <cs:fillRef idx="0"/>
+    <cs:effectRef idx="0"/>
+    <cs:fontRef idx="minor">
+      <a:schemeClr val="tx1"/>
+    </cs:fontRef>
+    <cs:spPr>
+      <a:ln w="9525" cap="flat" cmpd="sng" algn="ctr">
+        <a:solidFill>
+          <a:schemeClr val="tx1">
+            <a:lumMod val="35000"/>
+            <a:lumOff val="65000"/>
+          </a:schemeClr>
+        </a:solidFill>
+        <a:round/>
+      </a:ln>
+    </cs:spPr>
+  </cs:dropLine>
+  <cs:errorBar>
+    <cs:lnRef idx="0"/>
+    <cs:fillRef idx="0"/>
+    <cs:effectRef idx="0"/>
+    <cs:fontRef idx="minor">
+      <a:schemeClr val="tx1"/>
+    </cs:fontRef>
+    <cs:spPr>
+      <a:ln w="9525" cap="flat" cmpd="sng" algn="ctr">
+        <a:solidFill>
+          <a:schemeClr val="tx1">
+            <a:lumMod val="65000"/>
+            <a:lumOff val="35000"/>
+          </a:schemeClr>
+        </a:solidFill>
+        <a:round/>
+      </a:ln>
+    </cs:spPr>
+  </cs:errorBar>
+  <cs:floor>
+    <cs:lnRef idx="0"/>
+    <cs:fillRef idx="0"/>
+    <cs:effectRef idx="0"/>
+    <cs:fontRef idx="minor">
+      <a:schemeClr val="tx1"/>
+    </cs:fontRef>
+    <cs:spPr>
+      <a:noFill/>
+      <a:ln>
+        <a:noFill/>
+      </a:ln>
+    </cs:spPr>
+  </cs:floor>
+  <cs:gridlineMajor>
+    <cs:lnRef idx="0"/>
+    <cs:fillRef idx="0"/>
+    <cs:effectRef idx="0"/>
+    <cs:fontRef idx="minor">
+      <a:schemeClr val="tx1"/>
+    </cs:fontRef>
+    <cs:spPr>
+      <a:ln w="9525" cap="flat" cmpd="sng" algn="ctr">
+        <a:solidFill>
+          <a:schemeClr val="tx1">
+            <a:lumMod val="15000"/>
+            <a:lumOff val="85000"/>
+          </a:schemeClr>
+        </a:solidFill>
+        <a:round/>
+      </a:ln>
+    </cs:spPr>
+  </cs:gridlineMajor>
+  <cs:gridlineMinor>
+    <cs:lnRef idx="0"/>
+    <cs:fillRef idx="0"/>
+    <cs:effectRef idx="0"/>
+    <cs:fontRef idx="minor">
+      <a:schemeClr val="tx1"/>
+    </cs:fontRef>
+    <cs:spPr>
+      <a:ln w="9525" cap="flat" cmpd="sng" algn="ctr">
+        <a:solidFill>
+          <a:schemeClr val="tx1">
+            <a:lumMod val="5000"/>
+            <a:lumOff val="95000"/>
+          </a:schemeClr>
+        </a:solidFill>
+        <a:round/>
+      </a:ln>
+    </cs:spPr>
+  </cs:gridlineMinor>
+  <cs:hiLoLine>
+    <cs:lnRef idx="0"/>
+    <cs:fillRef idx="0"/>
+    <cs:effectRef idx="0"/>
+    <cs:fontRef idx="minor">
+      <a:schemeClr val="tx1"/>
+    </cs:fontRef>
+    <cs:spPr>
+      <a:ln w="9525" cap="flat" cmpd="sng" algn="ctr">
+        <a:solidFill>
+          <a:schemeClr val="tx1">
+            <a:lumMod val="50000"/>
+            <a:lumOff val="50000"/>
+          </a:schemeClr>
+        </a:solidFill>
+        <a:round/>
+      </a:ln>
+    </cs:spPr>
+  </cs:hiLoLine>
+  <cs:leaderLine>
+    <cs:lnRef idx="0"/>
+    <cs:fillRef idx="0"/>
+    <cs:effectRef idx="0"/>
+    <cs:fontRef idx="minor">
+      <a:schemeClr val="tx1"/>
+    </cs:fontRef>
+    <cs:spPr>
+      <a:ln w="9525" cap="flat" cmpd="sng" algn="ctr">
+        <a:solidFill>
+          <a:schemeClr val="tx1">
+            <a:lumMod val="35000"/>
+            <a:lumOff val="65000"/>
+          </a:schemeClr>
+        </a:solidFill>
+        <a:round/>
+      </a:ln>
+    </cs:spPr>
+  </cs:leaderLine>
+  <cs:legend>
+    <cs:lnRef idx="0"/>
+    <cs:fillRef idx="0"/>
+    <cs:effectRef idx="0"/>
+    <cs:fontRef idx="minor">
+      <a:schemeClr val="tx1">
+        <a:lumMod val="65000"/>
+        <a:lumOff val="35000"/>
+      </a:schemeClr>
+    </cs:fontRef>
+    <cs:defRPr sz="1197" kern="1200"/>
+  </cs:legend>
+  <cs:plotArea mods="allowNoFillOverride allowNoLineOverride">
+    <cs:lnRef idx="0"/>
+    <cs:fillRef idx="0"/>
+    <cs:effectRef idx="0"/>
+    <cs:fontRef idx="minor">
+      <a:schemeClr val="tx1"/>
+    </cs:fontRef>
+  </cs:plotArea>
+  <cs:plotArea3D mods="allowNoFillOverride allowNoLineOverride">
+    <cs:lnRef idx="0"/>
+    <cs:fillRef idx="0"/>
+    <cs:effectRef idx="0"/>
+    <cs:fontRef idx="minor">
+      <a:schemeClr val="tx1"/>
+    </cs:fontRef>
+  </cs:plotArea3D>
+  <cs:seriesAxis>
+    <cs:lnRef idx="0"/>
+    <cs:fillRef idx="0"/>
+    <cs:effectRef idx="0"/>
+    <cs:fontRef idx="minor">
+      <a:schemeClr val="tx1">
+        <a:lumMod val="65000"/>
+        <a:lumOff val="35000"/>
+      </a:schemeClr>
+    </cs:fontRef>
+    <cs:defRPr sz="1197" kern="1200"/>
+  </cs:seriesAxis>
+  <cs:seriesLine>
+    <cs:lnRef idx="0"/>
+    <cs:fillRef idx="0"/>
+    <cs:effectRef idx="0"/>
+    <cs:fontRef idx="minor">
+      <a:schemeClr val="tx1"/>
+    </cs:fontRef>
+    <cs:spPr>
+      <a:ln w="9525" cap="flat" cmpd="sng" algn="ctr">
+        <a:solidFill>
+          <a:schemeClr val="tx1">
+            <a:lumMod val="35000"/>
+            <a:lumOff val="65000"/>
+          </a:schemeClr>
+        </a:solidFill>
+        <a:round/>
+      </a:ln>
+    </cs:spPr>
+  </cs:seriesLine>
+  <cs:title>
+    <cs:lnRef idx="0"/>
+    <cs:fillRef idx="0"/>
+    <cs:effectRef idx="0"/>
+    <cs:fontRef idx="minor">
+      <a:schemeClr val="tx1">
+        <a:lumMod val="65000"/>
+        <a:lumOff val="35000"/>
+      </a:schemeClr>
+    </cs:fontRef>
+    <cs:defRPr sz="1862" b="0" kern="1200" spc="0" baseline="0"/>
+  </cs:title>
+  <cs:trendline>
+    <cs:lnRef idx="0">
+      <cs:styleClr val="auto"/>
+    </cs:lnRef>
+    <cs:fillRef idx="0"/>
+    <cs:effectRef idx="0"/>
+    <cs:fontRef idx="minor">
+      <a:schemeClr val="tx1"/>
+    </cs:fontRef>
+    <cs:spPr>
+      <a:ln w="19050" cap="rnd">
+        <a:solidFill>
+          <a:schemeClr val="phClr"/>
+        </a:solidFill>
+        <a:prstDash val="sysDot"/>
+      </a:ln>
+    </cs:spPr>
+  </cs:trendline>
+  <cs:trendlineLabel>
+    <cs:lnRef idx="0"/>
+    <cs:fillRef idx="0"/>
+    <cs:effectRef idx="0"/>
+    <cs:fontRef idx="minor">
+      <a:schemeClr val="tx1">
+        <a:lumMod val="65000"/>
+        <a:lumOff val="35000"/>
+      </a:schemeClr>
+    </cs:fontRef>
+    <cs:defRPr sz="1197" kern="1200"/>
+  </cs:trendlineLabel>
+  <cs:upBar>
+    <cs:lnRef idx="0"/>
+    <cs:fillRef idx="0"/>
+    <cs:effectRef idx="0"/>
+    <cs:fontRef idx="minor">
+      <a:schemeClr val="tx1"/>
+    </cs:fontRef>
+    <cs:spPr>
+      <a:solidFill>
+        <a:schemeClr val="lt1"/>
+      </a:solidFill>
+      <a:ln w="9525" cap="flat" cmpd="sng" algn="ctr">
+        <a:solidFill>
+          <a:schemeClr val="tx1">
+            <a:lumMod val="65000"/>
+            <a:lumOff val="35000"/>
+          </a:schemeClr>
+        </a:solidFill>
+        <a:round/>
+      </a:ln>
+    </cs:spPr>
+  </cs:upBar>
+  <cs:valueAxis>
+    <cs:lnRef idx="0"/>
+    <cs:fillRef idx="0"/>
+    <cs:effectRef idx="0"/>
+    <cs:fontRef idx="minor">
+      <a:schemeClr val="tx1">
+        <a:lumMod val="65000"/>
+        <a:lumOff val="35000"/>
+      </a:schemeClr>
+    </cs:fontRef>
+    <cs:defRPr sz="1197" kern="1200"/>
+  </cs:valueAxis>
+  <cs:wall>
+    <cs:lnRef idx="0"/>
+    <cs:fillRef idx="0"/>
+    <cs:effectRef idx="0"/>
+    <cs:fontRef idx="minor">
+      <a:schemeClr val="tx1"/>
+    </cs:fontRef>
+    <cs:spPr>
+      <a:noFill/>
+      <a:ln>
+        <a:noFill/>
+      </a:ln>
+    </cs:spPr>
+  </cs:wall>
+</cs:chartStyle>
+</file>
+
 <file path=ppt/charts/style2.xml><?xml version="1.0" encoding="utf-8"?>
 <cs:chartStyle xmlns:cs="http://schemas.microsoft.com/office/drawing/2012/chartStyle" xmlns:a="http://schemas.openxmlformats.org/drawingml/2006/main" id="201">
   <cs:axisTitle>
@@ -10451,7 +12668,7 @@
           <p:cNvPr id="2" name="Titel 1">
             <a:extLst>
               <a:ext uri="{FF2B5EF4-FFF2-40B4-BE49-F238E27FC236}">
-                <a16:creationId xmlns:a16="http://schemas.microsoft.com/office/drawing/2014/main" id="{0E19AFC3-E2A8-0DB5-FA14-964B6BD91643}"/>
+                <a16:creationId xmlns:a16="http://schemas.microsoft.com/office/drawing/2014/main" id="{E3147FF4-306E-FC75-92AC-02BC0484065F}"/>
               </a:ext>
             </a:extLst>
           </p:cNvPr>
@@ -10488,7 +12705,7 @@
           <p:cNvPr id="3" name="Untertitel 2">
             <a:extLst>
               <a:ext uri="{FF2B5EF4-FFF2-40B4-BE49-F238E27FC236}">
-                <a16:creationId xmlns:a16="http://schemas.microsoft.com/office/drawing/2014/main" id="{C1846205-EA0C-5F50-859D-C74B12E690C4}"/>
+                <a16:creationId xmlns:a16="http://schemas.microsoft.com/office/drawing/2014/main" id="{B68C2A38-E704-84AC-A1AE-12491007E395}"/>
               </a:ext>
             </a:extLst>
           </p:cNvPr>
@@ -10558,7 +12775,7 @@
           <p:cNvPr id="4" name="Datumsplatzhalter 3">
             <a:extLst>
               <a:ext uri="{FF2B5EF4-FFF2-40B4-BE49-F238E27FC236}">
-                <a16:creationId xmlns:a16="http://schemas.microsoft.com/office/drawing/2014/main" id="{EDA5AE3A-74CE-22FD-E5BA-EAAF42A3D420}"/>
+                <a16:creationId xmlns:a16="http://schemas.microsoft.com/office/drawing/2014/main" id="{8187CE13-761A-62A4-DF5F-FD360A00A7E0}"/>
               </a:ext>
             </a:extLst>
           </p:cNvPr>
@@ -10574,7 +12791,7 @@
           <a:bodyPr/>
           <a:lstStyle/>
           <a:p>
-            <a:fld id="{C9962047-E2C8-4734-A689-668B36BC6A1D}" type="datetimeFigureOut">
+            <a:fld id="{921E86A6-473C-463A-A28B-F44BBA9E8087}" type="datetimeFigureOut">
               <a:rPr lang="de-DE" smtClean="0"/>
               <a:t>09.10.2026</a:t>
             </a:fld>
@@ -10587,7 +12804,7 @@
           <p:cNvPr id="5" name="Fußzeilenplatzhalter 4">
             <a:extLst>
               <a:ext uri="{FF2B5EF4-FFF2-40B4-BE49-F238E27FC236}">
-                <a16:creationId xmlns:a16="http://schemas.microsoft.com/office/drawing/2014/main" id="{738389DF-8F8B-F67A-4E2E-0FBA7C6C2FAA}"/>
+                <a16:creationId xmlns:a16="http://schemas.microsoft.com/office/drawing/2014/main" id="{55C1B696-0622-4ED8-D1CC-6909CECA6A00}"/>
               </a:ext>
             </a:extLst>
           </p:cNvPr>
@@ -10612,7 +12829,7 @@
           <p:cNvPr id="6" name="Foliennummernplatzhalter 5">
             <a:extLst>
               <a:ext uri="{FF2B5EF4-FFF2-40B4-BE49-F238E27FC236}">
-                <a16:creationId xmlns:a16="http://schemas.microsoft.com/office/drawing/2014/main" id="{E0B13E69-EB74-15BE-C901-50856BA54F44}"/>
+                <a16:creationId xmlns:a16="http://schemas.microsoft.com/office/drawing/2014/main" id="{EAAB78EC-50AA-7596-C07A-A9B20509C602}"/>
               </a:ext>
             </a:extLst>
           </p:cNvPr>
@@ -10628,7 +12845,7 @@
           <a:bodyPr/>
           <a:lstStyle/>
           <a:p>
-            <a:fld id="{377935EF-6752-464A-9B81-BA8CABB6107B}" type="slidenum">
+            <a:fld id="{5E48D93C-8800-4654-AF56-A23C3A94C9C2}" type="slidenum">
               <a:rPr lang="de-DE" smtClean="0"/>
               <a:t>‹Nr.›</a:t>
             </a:fld>
@@ -10639,7 +12856,7 @@
     </p:spTree>
     <p:extLst>
       <p:ext uri="{BB962C8B-B14F-4D97-AF65-F5344CB8AC3E}">
-        <p14:creationId xmlns:p14="http://schemas.microsoft.com/office/powerpoint/2010/main" val="2394947834"/>
+        <p14:creationId xmlns:p14="http://schemas.microsoft.com/office/powerpoint/2010/main" val="424325992"/>
       </p:ext>
     </p:extLst>
   </p:cSld>
@@ -10671,7 +12888,7 @@
           <p:cNvPr id="2" name="Titel 1">
             <a:extLst>
               <a:ext uri="{FF2B5EF4-FFF2-40B4-BE49-F238E27FC236}">
-                <a16:creationId xmlns:a16="http://schemas.microsoft.com/office/drawing/2014/main" id="{C4849DA7-7AED-0292-B6D9-40887B4DD5A8}"/>
+                <a16:creationId xmlns:a16="http://schemas.microsoft.com/office/drawing/2014/main" id="{55DDD53F-AC46-4225-7BDD-C3AC26BC16DD}"/>
               </a:ext>
             </a:extLst>
           </p:cNvPr>
@@ -10699,7 +12916,7 @@
           <p:cNvPr id="3" name="Vertikaler Textplatzhalter 2">
             <a:extLst>
               <a:ext uri="{FF2B5EF4-FFF2-40B4-BE49-F238E27FC236}">
-                <a16:creationId xmlns:a16="http://schemas.microsoft.com/office/drawing/2014/main" id="{19AFBBA2-E78A-ACF3-95CF-DD21CD9A5BDE}"/>
+                <a16:creationId xmlns:a16="http://schemas.microsoft.com/office/drawing/2014/main" id="{2AA512B2-8140-1578-7340-2F7A9744AD79}"/>
               </a:ext>
             </a:extLst>
           </p:cNvPr>
@@ -10756,7 +12973,7 @@
           <p:cNvPr id="4" name="Datumsplatzhalter 3">
             <a:extLst>
               <a:ext uri="{FF2B5EF4-FFF2-40B4-BE49-F238E27FC236}">
-                <a16:creationId xmlns:a16="http://schemas.microsoft.com/office/drawing/2014/main" id="{D03AA1D4-2CCE-57D2-34F6-D5FC6F1499A8}"/>
+                <a16:creationId xmlns:a16="http://schemas.microsoft.com/office/drawing/2014/main" id="{6A18E898-D77A-6534-C90D-883875DE2401}"/>
               </a:ext>
             </a:extLst>
           </p:cNvPr>
@@ -10772,7 +12989,7 @@
           <a:bodyPr/>
           <a:lstStyle/>
           <a:p>
-            <a:fld id="{C9962047-E2C8-4734-A689-668B36BC6A1D}" type="datetimeFigureOut">
+            <a:fld id="{921E86A6-473C-463A-A28B-F44BBA9E8087}" type="datetimeFigureOut">
               <a:rPr lang="de-DE" smtClean="0"/>
               <a:t>09.10.2026</a:t>
             </a:fld>
@@ -10785,7 +13002,7 @@
           <p:cNvPr id="5" name="Fußzeilenplatzhalter 4">
             <a:extLst>
               <a:ext uri="{FF2B5EF4-FFF2-40B4-BE49-F238E27FC236}">
-                <a16:creationId xmlns:a16="http://schemas.microsoft.com/office/drawing/2014/main" id="{C3CA4FBF-7890-AEBE-8904-11F0CDF1D7FF}"/>
+                <a16:creationId xmlns:a16="http://schemas.microsoft.com/office/drawing/2014/main" id="{BE3BCEBA-F780-4414-A2EF-B4FCAC6C185A}"/>
               </a:ext>
             </a:extLst>
           </p:cNvPr>
@@ -10810,7 +13027,7 @@
           <p:cNvPr id="6" name="Foliennummernplatzhalter 5">
             <a:extLst>
               <a:ext uri="{FF2B5EF4-FFF2-40B4-BE49-F238E27FC236}">
-                <a16:creationId xmlns:a16="http://schemas.microsoft.com/office/drawing/2014/main" id="{376AB75F-77AB-FAB0-6AB7-06FA29349283}"/>
+                <a16:creationId xmlns:a16="http://schemas.microsoft.com/office/drawing/2014/main" id="{BFE1C2ED-3F8F-D717-4D8D-3531AF286F29}"/>
               </a:ext>
             </a:extLst>
           </p:cNvPr>
@@ -10826,7 +13043,7 @@
           <a:bodyPr/>
           <a:lstStyle/>
           <a:p>
-            <a:fld id="{377935EF-6752-464A-9B81-BA8CABB6107B}" type="slidenum">
+            <a:fld id="{5E48D93C-8800-4654-AF56-A23C3A94C9C2}" type="slidenum">
               <a:rPr lang="de-DE" smtClean="0"/>
               <a:t>‹Nr.›</a:t>
             </a:fld>
@@ -10837,7 +13054,7 @@
     </p:spTree>
     <p:extLst>
       <p:ext uri="{BB962C8B-B14F-4D97-AF65-F5344CB8AC3E}">
-        <p14:creationId xmlns:p14="http://schemas.microsoft.com/office/powerpoint/2010/main" val="3674571750"/>
+        <p14:creationId xmlns:p14="http://schemas.microsoft.com/office/powerpoint/2010/main" val="3467409189"/>
       </p:ext>
     </p:extLst>
   </p:cSld>
@@ -10869,7 +13086,7 @@
           <p:cNvPr id="2" name="Vertikaler Titel 1">
             <a:extLst>
               <a:ext uri="{FF2B5EF4-FFF2-40B4-BE49-F238E27FC236}">
-                <a16:creationId xmlns:a16="http://schemas.microsoft.com/office/drawing/2014/main" id="{61B5C6B4-CEB1-973A-B66F-DDF332725F9D}"/>
+                <a16:creationId xmlns:a16="http://schemas.microsoft.com/office/drawing/2014/main" id="{DFFC901B-203E-B964-DD1D-85C1ED71E992}"/>
               </a:ext>
             </a:extLst>
           </p:cNvPr>
@@ -10902,7 +13119,7 @@
           <p:cNvPr id="3" name="Vertikaler Textplatzhalter 2">
             <a:extLst>
               <a:ext uri="{FF2B5EF4-FFF2-40B4-BE49-F238E27FC236}">
-                <a16:creationId xmlns:a16="http://schemas.microsoft.com/office/drawing/2014/main" id="{13A9F277-C525-C6A8-1F77-74D63B364017}"/>
+                <a16:creationId xmlns:a16="http://schemas.microsoft.com/office/drawing/2014/main" id="{F9AF76A9-D6C1-D0CA-C612-E1026E406D03}"/>
               </a:ext>
             </a:extLst>
           </p:cNvPr>
@@ -10964,7 +13181,7 @@
           <p:cNvPr id="4" name="Datumsplatzhalter 3">
             <a:extLst>
               <a:ext uri="{FF2B5EF4-FFF2-40B4-BE49-F238E27FC236}">
-                <a16:creationId xmlns:a16="http://schemas.microsoft.com/office/drawing/2014/main" id="{7408698F-AA60-FF9D-F9CA-419A9A43638C}"/>
+                <a16:creationId xmlns:a16="http://schemas.microsoft.com/office/drawing/2014/main" id="{88CA3E31-C049-0612-9E79-613CBE0451AF}"/>
               </a:ext>
             </a:extLst>
           </p:cNvPr>
@@ -10980,7 +13197,7 @@
           <a:bodyPr/>
           <a:lstStyle/>
           <a:p>
-            <a:fld id="{C9962047-E2C8-4734-A689-668B36BC6A1D}" type="datetimeFigureOut">
+            <a:fld id="{921E86A6-473C-463A-A28B-F44BBA9E8087}" type="datetimeFigureOut">
               <a:rPr lang="de-DE" smtClean="0"/>
               <a:t>09.10.2026</a:t>
             </a:fld>
@@ -10993,7 +13210,7 @@
           <p:cNvPr id="5" name="Fußzeilenplatzhalter 4">
             <a:extLst>
               <a:ext uri="{FF2B5EF4-FFF2-40B4-BE49-F238E27FC236}">
-                <a16:creationId xmlns:a16="http://schemas.microsoft.com/office/drawing/2014/main" id="{8FBD0E1D-B72E-A129-CA21-69F1DBD6293F}"/>
+                <a16:creationId xmlns:a16="http://schemas.microsoft.com/office/drawing/2014/main" id="{6FF15190-92B0-768F-170D-5AF93AA8182D}"/>
               </a:ext>
             </a:extLst>
           </p:cNvPr>
@@ -11018,7 +13235,7 @@
           <p:cNvPr id="6" name="Foliennummernplatzhalter 5">
             <a:extLst>
               <a:ext uri="{FF2B5EF4-FFF2-40B4-BE49-F238E27FC236}">
-                <a16:creationId xmlns:a16="http://schemas.microsoft.com/office/drawing/2014/main" id="{688DD645-A71D-6926-E961-E7C2D7D31B18}"/>
+                <a16:creationId xmlns:a16="http://schemas.microsoft.com/office/drawing/2014/main" id="{A4F6A59F-EA15-1008-A32C-59141ED0A536}"/>
               </a:ext>
             </a:extLst>
           </p:cNvPr>
@@ -11034,7 +13251,7 @@
           <a:bodyPr/>
           <a:lstStyle/>
           <a:p>
-            <a:fld id="{377935EF-6752-464A-9B81-BA8CABB6107B}" type="slidenum">
+            <a:fld id="{5E48D93C-8800-4654-AF56-A23C3A94C9C2}" type="slidenum">
               <a:rPr lang="de-DE" smtClean="0"/>
               <a:t>‹Nr.›</a:t>
             </a:fld>
@@ -11045,7 +13262,7 @@
     </p:spTree>
     <p:extLst>
       <p:ext uri="{BB962C8B-B14F-4D97-AF65-F5344CB8AC3E}">
-        <p14:creationId xmlns:p14="http://schemas.microsoft.com/office/powerpoint/2010/main" val="2929395954"/>
+        <p14:creationId xmlns:p14="http://schemas.microsoft.com/office/powerpoint/2010/main" val="2715296692"/>
       </p:ext>
     </p:extLst>
   </p:cSld>
@@ -11077,7 +13294,7 @@
           <p:cNvPr id="2" name="Titel 1">
             <a:extLst>
               <a:ext uri="{FF2B5EF4-FFF2-40B4-BE49-F238E27FC236}">
-                <a16:creationId xmlns:a16="http://schemas.microsoft.com/office/drawing/2014/main" id="{61FB3DD5-27B6-8F7E-68A9-637A294793F8}"/>
+                <a16:creationId xmlns:a16="http://schemas.microsoft.com/office/drawing/2014/main" id="{07879934-CFB5-66BB-59BB-BABD3CA176AF}"/>
               </a:ext>
             </a:extLst>
           </p:cNvPr>
@@ -11105,7 +13322,7 @@
           <p:cNvPr id="3" name="Inhaltsplatzhalter 2">
             <a:extLst>
               <a:ext uri="{FF2B5EF4-FFF2-40B4-BE49-F238E27FC236}">
-                <a16:creationId xmlns:a16="http://schemas.microsoft.com/office/drawing/2014/main" id="{6D158EB9-F8FF-D110-14AB-3C052A020577}"/>
+                <a16:creationId xmlns:a16="http://schemas.microsoft.com/office/drawing/2014/main" id="{EFC01319-F2C3-6015-A1E2-E3AC9A14B3A7}"/>
               </a:ext>
             </a:extLst>
           </p:cNvPr>
@@ -11162,7 +13379,7 @@
           <p:cNvPr id="4" name="Datumsplatzhalter 3">
             <a:extLst>
               <a:ext uri="{FF2B5EF4-FFF2-40B4-BE49-F238E27FC236}">
-                <a16:creationId xmlns:a16="http://schemas.microsoft.com/office/drawing/2014/main" id="{2140605A-56DD-BFF6-4334-653E0EDA353E}"/>
+                <a16:creationId xmlns:a16="http://schemas.microsoft.com/office/drawing/2014/main" id="{573F0D88-7264-998D-FD99-734251402639}"/>
               </a:ext>
             </a:extLst>
           </p:cNvPr>
@@ -11178,7 +13395,7 @@
           <a:bodyPr/>
           <a:lstStyle/>
           <a:p>
-            <a:fld id="{C9962047-E2C8-4734-A689-668B36BC6A1D}" type="datetimeFigureOut">
+            <a:fld id="{921E86A6-473C-463A-A28B-F44BBA9E8087}" type="datetimeFigureOut">
               <a:rPr lang="de-DE" smtClean="0"/>
               <a:t>09.10.2026</a:t>
             </a:fld>
@@ -11191,7 +13408,7 @@
           <p:cNvPr id="5" name="Fußzeilenplatzhalter 4">
             <a:extLst>
               <a:ext uri="{FF2B5EF4-FFF2-40B4-BE49-F238E27FC236}">
-                <a16:creationId xmlns:a16="http://schemas.microsoft.com/office/drawing/2014/main" id="{6FC32648-F6AA-F1C2-99A2-218274DDF7A5}"/>
+                <a16:creationId xmlns:a16="http://schemas.microsoft.com/office/drawing/2014/main" id="{FC89D8AF-8206-3C5C-38EA-021D35A63FA3}"/>
               </a:ext>
             </a:extLst>
           </p:cNvPr>
@@ -11216,7 +13433,7 @@
           <p:cNvPr id="6" name="Foliennummernplatzhalter 5">
             <a:extLst>
               <a:ext uri="{FF2B5EF4-FFF2-40B4-BE49-F238E27FC236}">
-                <a16:creationId xmlns:a16="http://schemas.microsoft.com/office/drawing/2014/main" id="{00EFE42B-2473-9A30-2702-4DF340EE2D08}"/>
+                <a16:creationId xmlns:a16="http://schemas.microsoft.com/office/drawing/2014/main" id="{D6A4579C-0E87-7E94-54B4-D62979384B2C}"/>
               </a:ext>
             </a:extLst>
           </p:cNvPr>
@@ -11232,7 +13449,7 @@
           <a:bodyPr/>
           <a:lstStyle/>
           <a:p>
-            <a:fld id="{377935EF-6752-464A-9B81-BA8CABB6107B}" type="slidenum">
+            <a:fld id="{5E48D93C-8800-4654-AF56-A23C3A94C9C2}" type="slidenum">
               <a:rPr lang="de-DE" smtClean="0"/>
               <a:t>‹Nr.›</a:t>
             </a:fld>
@@ -11243,7 +13460,7 @@
     </p:spTree>
     <p:extLst>
       <p:ext uri="{BB962C8B-B14F-4D97-AF65-F5344CB8AC3E}">
-        <p14:creationId xmlns:p14="http://schemas.microsoft.com/office/powerpoint/2010/main" val="426050687"/>
+        <p14:creationId xmlns:p14="http://schemas.microsoft.com/office/powerpoint/2010/main" val="1825662627"/>
       </p:ext>
     </p:extLst>
   </p:cSld>
@@ -11275,7 +13492,7 @@
           <p:cNvPr id="2" name="Titel 1">
             <a:extLst>
               <a:ext uri="{FF2B5EF4-FFF2-40B4-BE49-F238E27FC236}">
-                <a16:creationId xmlns:a16="http://schemas.microsoft.com/office/drawing/2014/main" id="{8348A74A-664C-4C2C-D379-5C858A3B255D}"/>
+                <a16:creationId xmlns:a16="http://schemas.microsoft.com/office/drawing/2014/main" id="{DBE1AD21-6370-FBA1-34BC-6FB02BA784CA}"/>
               </a:ext>
             </a:extLst>
           </p:cNvPr>
@@ -11312,7 +13529,7 @@
           <p:cNvPr id="3" name="Textplatzhalter 2">
             <a:extLst>
               <a:ext uri="{FF2B5EF4-FFF2-40B4-BE49-F238E27FC236}">
-                <a16:creationId xmlns:a16="http://schemas.microsoft.com/office/drawing/2014/main" id="{F7C2EF23-F764-395D-3CFD-067C5959ED84}"/>
+                <a16:creationId xmlns:a16="http://schemas.microsoft.com/office/drawing/2014/main" id="{287CD4BD-BF1D-4C48-6D93-C50487AE6BFE}"/>
               </a:ext>
             </a:extLst>
           </p:cNvPr>
@@ -11437,7 +13654,7 @@
           <p:cNvPr id="4" name="Datumsplatzhalter 3">
             <a:extLst>
               <a:ext uri="{FF2B5EF4-FFF2-40B4-BE49-F238E27FC236}">
-                <a16:creationId xmlns:a16="http://schemas.microsoft.com/office/drawing/2014/main" id="{388DA0E3-530D-1FE4-0EDF-C98C6AA3E857}"/>
+                <a16:creationId xmlns:a16="http://schemas.microsoft.com/office/drawing/2014/main" id="{A7B2D9CD-DE7D-7766-0189-1F7E44CFE23E}"/>
               </a:ext>
             </a:extLst>
           </p:cNvPr>
@@ -11453,7 +13670,7 @@
           <a:bodyPr/>
           <a:lstStyle/>
           <a:p>
-            <a:fld id="{C9962047-E2C8-4734-A689-668B36BC6A1D}" type="datetimeFigureOut">
+            <a:fld id="{921E86A6-473C-463A-A28B-F44BBA9E8087}" type="datetimeFigureOut">
               <a:rPr lang="de-DE" smtClean="0"/>
               <a:t>09.10.2026</a:t>
             </a:fld>
@@ -11466,7 +13683,7 @@
           <p:cNvPr id="5" name="Fußzeilenplatzhalter 4">
             <a:extLst>
               <a:ext uri="{FF2B5EF4-FFF2-40B4-BE49-F238E27FC236}">
-                <a16:creationId xmlns:a16="http://schemas.microsoft.com/office/drawing/2014/main" id="{634E895F-102F-88CC-0D58-64E8AB55B896}"/>
+                <a16:creationId xmlns:a16="http://schemas.microsoft.com/office/drawing/2014/main" id="{10BFC801-C06D-9B85-AD8E-C43AE8DA61EA}"/>
               </a:ext>
             </a:extLst>
           </p:cNvPr>
@@ -11491,7 +13708,7 @@
           <p:cNvPr id="6" name="Foliennummernplatzhalter 5">
             <a:extLst>
               <a:ext uri="{FF2B5EF4-FFF2-40B4-BE49-F238E27FC236}">
-                <a16:creationId xmlns:a16="http://schemas.microsoft.com/office/drawing/2014/main" id="{E31EB99E-A574-C128-D371-7EE6CE5E724E}"/>
+                <a16:creationId xmlns:a16="http://schemas.microsoft.com/office/drawing/2014/main" id="{25FECEE1-9083-D968-C152-1B5530EE45AD}"/>
               </a:ext>
             </a:extLst>
           </p:cNvPr>
@@ -11507,7 +13724,7 @@
           <a:bodyPr/>
           <a:lstStyle/>
           <a:p>
-            <a:fld id="{377935EF-6752-464A-9B81-BA8CABB6107B}" type="slidenum">
+            <a:fld id="{5E48D93C-8800-4654-AF56-A23C3A94C9C2}" type="slidenum">
               <a:rPr lang="de-DE" smtClean="0"/>
               <a:t>‹Nr.›</a:t>
             </a:fld>
@@ -11518,7 +13735,7 @@
     </p:spTree>
     <p:extLst>
       <p:ext uri="{BB962C8B-B14F-4D97-AF65-F5344CB8AC3E}">
-        <p14:creationId xmlns:p14="http://schemas.microsoft.com/office/powerpoint/2010/main" val="1768514542"/>
+        <p14:creationId xmlns:p14="http://schemas.microsoft.com/office/powerpoint/2010/main" val="1408313681"/>
       </p:ext>
     </p:extLst>
   </p:cSld>
@@ -11550,7 +13767,7 @@
           <p:cNvPr id="2" name="Titel 1">
             <a:extLst>
               <a:ext uri="{FF2B5EF4-FFF2-40B4-BE49-F238E27FC236}">
-                <a16:creationId xmlns:a16="http://schemas.microsoft.com/office/drawing/2014/main" id="{CC1E92D4-B7F2-72BC-B05B-F6BAFA631085}"/>
+                <a16:creationId xmlns:a16="http://schemas.microsoft.com/office/drawing/2014/main" id="{78C61F20-A2A9-968E-FDE0-6993500F47A0}"/>
               </a:ext>
             </a:extLst>
           </p:cNvPr>
@@ -11578,7 +13795,7 @@
           <p:cNvPr id="3" name="Inhaltsplatzhalter 2">
             <a:extLst>
               <a:ext uri="{FF2B5EF4-FFF2-40B4-BE49-F238E27FC236}">
-                <a16:creationId xmlns:a16="http://schemas.microsoft.com/office/drawing/2014/main" id="{8FBE7488-6420-F35D-0C79-FA4A43351BD5}"/>
+                <a16:creationId xmlns:a16="http://schemas.microsoft.com/office/drawing/2014/main" id="{58857116-2322-B36A-1AFD-C3773E331C8B}"/>
               </a:ext>
             </a:extLst>
           </p:cNvPr>
@@ -11640,7 +13857,7 @@
           <p:cNvPr id="4" name="Inhaltsplatzhalter 3">
             <a:extLst>
               <a:ext uri="{FF2B5EF4-FFF2-40B4-BE49-F238E27FC236}">
-                <a16:creationId xmlns:a16="http://schemas.microsoft.com/office/drawing/2014/main" id="{208D87BB-9096-D5C7-3D69-61A7FAE26020}"/>
+                <a16:creationId xmlns:a16="http://schemas.microsoft.com/office/drawing/2014/main" id="{ECEBD752-B8E4-DA70-4BA5-E82DC2A1B3DE}"/>
               </a:ext>
             </a:extLst>
           </p:cNvPr>
@@ -11702,7 +13919,7 @@
           <p:cNvPr id="5" name="Datumsplatzhalter 4">
             <a:extLst>
               <a:ext uri="{FF2B5EF4-FFF2-40B4-BE49-F238E27FC236}">
-                <a16:creationId xmlns:a16="http://schemas.microsoft.com/office/drawing/2014/main" id="{9D92772D-6ABC-0E35-9415-D8C972A349B2}"/>
+                <a16:creationId xmlns:a16="http://schemas.microsoft.com/office/drawing/2014/main" id="{C5179EF8-D762-8866-40A7-1F789C6D680B}"/>
               </a:ext>
             </a:extLst>
           </p:cNvPr>
@@ -11718,7 +13935,7 @@
           <a:bodyPr/>
           <a:lstStyle/>
           <a:p>
-            <a:fld id="{C9962047-E2C8-4734-A689-668B36BC6A1D}" type="datetimeFigureOut">
+            <a:fld id="{921E86A6-473C-463A-A28B-F44BBA9E8087}" type="datetimeFigureOut">
               <a:rPr lang="de-DE" smtClean="0"/>
               <a:t>09.10.2026</a:t>
             </a:fld>
@@ -11731,7 +13948,7 @@
           <p:cNvPr id="6" name="Fußzeilenplatzhalter 5">
             <a:extLst>
               <a:ext uri="{FF2B5EF4-FFF2-40B4-BE49-F238E27FC236}">
-                <a16:creationId xmlns:a16="http://schemas.microsoft.com/office/drawing/2014/main" id="{6679E43D-3355-3D46-A3D4-099A5DF83AB0}"/>
+                <a16:creationId xmlns:a16="http://schemas.microsoft.com/office/drawing/2014/main" id="{FD1ECB8E-7C99-B9B4-1F5D-457974CC3F69}"/>
               </a:ext>
             </a:extLst>
           </p:cNvPr>
@@ -11756,7 +13973,7 @@
           <p:cNvPr id="7" name="Foliennummernplatzhalter 6">
             <a:extLst>
               <a:ext uri="{FF2B5EF4-FFF2-40B4-BE49-F238E27FC236}">
-                <a16:creationId xmlns:a16="http://schemas.microsoft.com/office/drawing/2014/main" id="{25CD6765-E1CA-00F0-65D7-4567100FFB1A}"/>
+                <a16:creationId xmlns:a16="http://schemas.microsoft.com/office/drawing/2014/main" id="{D2C8EB91-BCDA-ABB3-9FA0-3BF2A7143D15}"/>
               </a:ext>
             </a:extLst>
           </p:cNvPr>
@@ -11772,7 +13989,7 @@
           <a:bodyPr/>
           <a:lstStyle/>
           <a:p>
-            <a:fld id="{377935EF-6752-464A-9B81-BA8CABB6107B}" type="slidenum">
+            <a:fld id="{5E48D93C-8800-4654-AF56-A23C3A94C9C2}" type="slidenum">
               <a:rPr lang="de-DE" smtClean="0"/>
               <a:t>‹Nr.›</a:t>
             </a:fld>
@@ -11783,7 +14000,7 @@
     </p:spTree>
     <p:extLst>
       <p:ext uri="{BB962C8B-B14F-4D97-AF65-F5344CB8AC3E}">
-        <p14:creationId xmlns:p14="http://schemas.microsoft.com/office/powerpoint/2010/main" val="1895703322"/>
+        <p14:creationId xmlns:p14="http://schemas.microsoft.com/office/powerpoint/2010/main" val="472940700"/>
       </p:ext>
     </p:extLst>
   </p:cSld>
@@ -11815,7 +14032,7 @@
           <p:cNvPr id="2" name="Titel 1">
             <a:extLst>
               <a:ext uri="{FF2B5EF4-FFF2-40B4-BE49-F238E27FC236}">
-                <a16:creationId xmlns:a16="http://schemas.microsoft.com/office/drawing/2014/main" id="{35AEEBCF-22B6-3F98-49F5-B9F2DDB8EFC6}"/>
+                <a16:creationId xmlns:a16="http://schemas.microsoft.com/office/drawing/2014/main" id="{12C7C165-CD1E-A9D8-D432-A21F1692492A}"/>
               </a:ext>
             </a:extLst>
           </p:cNvPr>
@@ -11848,7 +14065,7 @@
           <p:cNvPr id="3" name="Textplatzhalter 2">
             <a:extLst>
               <a:ext uri="{FF2B5EF4-FFF2-40B4-BE49-F238E27FC236}">
-                <a16:creationId xmlns:a16="http://schemas.microsoft.com/office/drawing/2014/main" id="{A5F20308-E00A-7CAD-AC4D-CE341DABCCFE}"/>
+                <a16:creationId xmlns:a16="http://schemas.microsoft.com/office/drawing/2014/main" id="{A6B42C27-3D6D-3FE1-EE24-595E191CBDEA}"/>
               </a:ext>
             </a:extLst>
           </p:cNvPr>
@@ -11919,7 +14136,7 @@
           <p:cNvPr id="4" name="Inhaltsplatzhalter 3">
             <a:extLst>
               <a:ext uri="{FF2B5EF4-FFF2-40B4-BE49-F238E27FC236}">
-                <a16:creationId xmlns:a16="http://schemas.microsoft.com/office/drawing/2014/main" id="{0091D037-9438-722B-9293-9ADE566ACF3D}"/>
+                <a16:creationId xmlns:a16="http://schemas.microsoft.com/office/drawing/2014/main" id="{2F24BE9E-7EDB-4CED-BDAE-1AC579F3A81F}"/>
               </a:ext>
             </a:extLst>
           </p:cNvPr>
@@ -11981,7 +14198,7 @@
           <p:cNvPr id="5" name="Textplatzhalter 4">
             <a:extLst>
               <a:ext uri="{FF2B5EF4-FFF2-40B4-BE49-F238E27FC236}">
-                <a16:creationId xmlns:a16="http://schemas.microsoft.com/office/drawing/2014/main" id="{FA259019-FB91-8673-0A6B-8F7EAA389946}"/>
+                <a16:creationId xmlns:a16="http://schemas.microsoft.com/office/drawing/2014/main" id="{9B341587-E96F-3DA9-2B36-4FFB2D93BA5A}"/>
               </a:ext>
             </a:extLst>
           </p:cNvPr>
@@ -12052,7 +14269,7 @@
           <p:cNvPr id="6" name="Inhaltsplatzhalter 5">
             <a:extLst>
               <a:ext uri="{FF2B5EF4-FFF2-40B4-BE49-F238E27FC236}">
-                <a16:creationId xmlns:a16="http://schemas.microsoft.com/office/drawing/2014/main" id="{A7535323-9854-90E8-BFF9-0AC471B1A13D}"/>
+                <a16:creationId xmlns:a16="http://schemas.microsoft.com/office/drawing/2014/main" id="{896F7553-94FB-08C6-3D90-4594B3486EA6}"/>
               </a:ext>
             </a:extLst>
           </p:cNvPr>
@@ -12114,7 +14331,7 @@
           <p:cNvPr id="7" name="Datumsplatzhalter 6">
             <a:extLst>
               <a:ext uri="{FF2B5EF4-FFF2-40B4-BE49-F238E27FC236}">
-                <a16:creationId xmlns:a16="http://schemas.microsoft.com/office/drawing/2014/main" id="{5E3BF176-98A9-141F-6BAB-A109C3C63F64}"/>
+                <a16:creationId xmlns:a16="http://schemas.microsoft.com/office/drawing/2014/main" id="{0E6867E0-354B-A45D-494A-D10C5B02C539}"/>
               </a:ext>
             </a:extLst>
           </p:cNvPr>
@@ -12130,7 +14347,7 @@
           <a:bodyPr/>
           <a:lstStyle/>
           <a:p>
-            <a:fld id="{C9962047-E2C8-4734-A689-668B36BC6A1D}" type="datetimeFigureOut">
+            <a:fld id="{921E86A6-473C-463A-A28B-F44BBA9E8087}" type="datetimeFigureOut">
               <a:rPr lang="de-DE" smtClean="0"/>
               <a:t>09.10.2026</a:t>
             </a:fld>
@@ -12143,7 +14360,7 @@
           <p:cNvPr id="8" name="Fußzeilenplatzhalter 7">
             <a:extLst>
               <a:ext uri="{FF2B5EF4-FFF2-40B4-BE49-F238E27FC236}">
-                <a16:creationId xmlns:a16="http://schemas.microsoft.com/office/drawing/2014/main" id="{E45AE3F5-3FEB-498F-2F35-BF711F86D22B}"/>
+                <a16:creationId xmlns:a16="http://schemas.microsoft.com/office/drawing/2014/main" id="{AEA2A456-A0F9-306A-C179-5CB15838C762}"/>
               </a:ext>
             </a:extLst>
           </p:cNvPr>
@@ -12168,7 +14385,7 @@
           <p:cNvPr id="9" name="Foliennummernplatzhalter 8">
             <a:extLst>
               <a:ext uri="{FF2B5EF4-FFF2-40B4-BE49-F238E27FC236}">
-                <a16:creationId xmlns:a16="http://schemas.microsoft.com/office/drawing/2014/main" id="{2D456F18-35F1-5141-B2C7-101CE2210F35}"/>
+                <a16:creationId xmlns:a16="http://schemas.microsoft.com/office/drawing/2014/main" id="{0B9CDCCB-E321-AE57-9071-75D94BF36DB2}"/>
               </a:ext>
             </a:extLst>
           </p:cNvPr>
@@ -12184,7 +14401,7 @@
           <a:bodyPr/>
           <a:lstStyle/>
           <a:p>
-            <a:fld id="{377935EF-6752-464A-9B81-BA8CABB6107B}" type="slidenum">
+            <a:fld id="{5E48D93C-8800-4654-AF56-A23C3A94C9C2}" type="slidenum">
               <a:rPr lang="de-DE" smtClean="0"/>
               <a:t>‹Nr.›</a:t>
             </a:fld>
@@ -12195,7 +14412,7 @@
     </p:spTree>
     <p:extLst>
       <p:ext uri="{BB962C8B-B14F-4D97-AF65-F5344CB8AC3E}">
-        <p14:creationId xmlns:p14="http://schemas.microsoft.com/office/powerpoint/2010/main" val="3958652924"/>
+        <p14:creationId xmlns:p14="http://schemas.microsoft.com/office/powerpoint/2010/main" val="1989437893"/>
       </p:ext>
     </p:extLst>
   </p:cSld>
@@ -12227,7 +14444,7 @@
           <p:cNvPr id="2" name="Titel 1">
             <a:extLst>
               <a:ext uri="{FF2B5EF4-FFF2-40B4-BE49-F238E27FC236}">
-                <a16:creationId xmlns:a16="http://schemas.microsoft.com/office/drawing/2014/main" id="{0CD36973-E164-7F2F-ADE1-74B16AAC3BA9}"/>
+                <a16:creationId xmlns:a16="http://schemas.microsoft.com/office/drawing/2014/main" id="{371F4290-2D21-5FE2-7CA1-4A0122991B4E}"/>
               </a:ext>
             </a:extLst>
           </p:cNvPr>
@@ -12255,7 +14472,7 @@
           <p:cNvPr id="3" name="Datumsplatzhalter 2">
             <a:extLst>
               <a:ext uri="{FF2B5EF4-FFF2-40B4-BE49-F238E27FC236}">
-                <a16:creationId xmlns:a16="http://schemas.microsoft.com/office/drawing/2014/main" id="{8749C6C8-1B0E-7363-2D9E-AC01F791350A}"/>
+                <a16:creationId xmlns:a16="http://schemas.microsoft.com/office/drawing/2014/main" id="{A92BCC88-DF38-DB9D-864E-200B5735FEF1}"/>
               </a:ext>
             </a:extLst>
           </p:cNvPr>
@@ -12271,7 +14488,7 @@
           <a:bodyPr/>
           <a:lstStyle/>
           <a:p>
-            <a:fld id="{C9962047-E2C8-4734-A689-668B36BC6A1D}" type="datetimeFigureOut">
+            <a:fld id="{921E86A6-473C-463A-A28B-F44BBA9E8087}" type="datetimeFigureOut">
               <a:rPr lang="de-DE" smtClean="0"/>
               <a:t>09.10.2026</a:t>
             </a:fld>
@@ -12284,7 +14501,7 @@
           <p:cNvPr id="4" name="Fußzeilenplatzhalter 3">
             <a:extLst>
               <a:ext uri="{FF2B5EF4-FFF2-40B4-BE49-F238E27FC236}">
-                <a16:creationId xmlns:a16="http://schemas.microsoft.com/office/drawing/2014/main" id="{96B94F9A-7AC6-02E3-C999-C2446E8F6EEE}"/>
+                <a16:creationId xmlns:a16="http://schemas.microsoft.com/office/drawing/2014/main" id="{279E114A-7760-971F-C480-B8A8EBE41F0B}"/>
               </a:ext>
             </a:extLst>
           </p:cNvPr>
@@ -12309,7 +14526,7 @@
           <p:cNvPr id="5" name="Foliennummernplatzhalter 4">
             <a:extLst>
               <a:ext uri="{FF2B5EF4-FFF2-40B4-BE49-F238E27FC236}">
-                <a16:creationId xmlns:a16="http://schemas.microsoft.com/office/drawing/2014/main" id="{07B18CDE-6776-F703-01D8-B5CE5256F1EB}"/>
+                <a16:creationId xmlns:a16="http://schemas.microsoft.com/office/drawing/2014/main" id="{49A86963-DCCE-B9F5-BE7E-A5410B5E81B3}"/>
               </a:ext>
             </a:extLst>
           </p:cNvPr>
@@ -12325,7 +14542,7 @@
           <a:bodyPr/>
           <a:lstStyle/>
           <a:p>
-            <a:fld id="{377935EF-6752-464A-9B81-BA8CABB6107B}" type="slidenum">
+            <a:fld id="{5E48D93C-8800-4654-AF56-A23C3A94C9C2}" type="slidenum">
               <a:rPr lang="de-DE" smtClean="0"/>
               <a:t>‹Nr.›</a:t>
             </a:fld>
@@ -12336,7 +14553,7 @@
     </p:spTree>
     <p:extLst>
       <p:ext uri="{BB962C8B-B14F-4D97-AF65-F5344CB8AC3E}">
-        <p14:creationId xmlns:p14="http://schemas.microsoft.com/office/powerpoint/2010/main" val="169783146"/>
+        <p14:creationId xmlns:p14="http://schemas.microsoft.com/office/powerpoint/2010/main" val="4044733402"/>
       </p:ext>
     </p:extLst>
   </p:cSld>
@@ -12368,7 +14585,7 @@
           <p:cNvPr id="2" name="Datumsplatzhalter 1">
             <a:extLst>
               <a:ext uri="{FF2B5EF4-FFF2-40B4-BE49-F238E27FC236}">
-                <a16:creationId xmlns:a16="http://schemas.microsoft.com/office/drawing/2014/main" id="{158E9554-FA0B-F30E-7A88-E7B924E35B11}"/>
+                <a16:creationId xmlns:a16="http://schemas.microsoft.com/office/drawing/2014/main" id="{07E38C7D-A881-0B32-F6BF-CA6C81336DA9}"/>
               </a:ext>
             </a:extLst>
           </p:cNvPr>
@@ -12384,7 +14601,7 @@
           <a:bodyPr/>
           <a:lstStyle/>
           <a:p>
-            <a:fld id="{C9962047-E2C8-4734-A689-668B36BC6A1D}" type="datetimeFigureOut">
+            <a:fld id="{921E86A6-473C-463A-A28B-F44BBA9E8087}" type="datetimeFigureOut">
               <a:rPr lang="de-DE" smtClean="0"/>
               <a:t>09.10.2026</a:t>
             </a:fld>
@@ -12397,7 +14614,7 @@
           <p:cNvPr id="3" name="Fußzeilenplatzhalter 2">
             <a:extLst>
               <a:ext uri="{FF2B5EF4-FFF2-40B4-BE49-F238E27FC236}">
-                <a16:creationId xmlns:a16="http://schemas.microsoft.com/office/drawing/2014/main" id="{3F52906A-5827-DA11-1C5B-D48FAF9FFE0E}"/>
+                <a16:creationId xmlns:a16="http://schemas.microsoft.com/office/drawing/2014/main" id="{3932C6E7-ABC7-B5A4-FDA8-823190778266}"/>
               </a:ext>
             </a:extLst>
           </p:cNvPr>
@@ -12422,7 +14639,7 @@
           <p:cNvPr id="4" name="Foliennummernplatzhalter 3">
             <a:extLst>
               <a:ext uri="{FF2B5EF4-FFF2-40B4-BE49-F238E27FC236}">
-                <a16:creationId xmlns:a16="http://schemas.microsoft.com/office/drawing/2014/main" id="{8F9DC859-2261-56C1-6BC7-8A8A748F9A52}"/>
+                <a16:creationId xmlns:a16="http://schemas.microsoft.com/office/drawing/2014/main" id="{05E04788-84AE-D25B-F338-BDC0576275AF}"/>
               </a:ext>
             </a:extLst>
           </p:cNvPr>
@@ -12438,7 +14655,7 @@
           <a:bodyPr/>
           <a:lstStyle/>
           <a:p>
-            <a:fld id="{377935EF-6752-464A-9B81-BA8CABB6107B}" type="slidenum">
+            <a:fld id="{5E48D93C-8800-4654-AF56-A23C3A94C9C2}" type="slidenum">
               <a:rPr lang="de-DE" smtClean="0"/>
               <a:t>‹Nr.›</a:t>
             </a:fld>
@@ -12449,7 +14666,7 @@
     </p:spTree>
     <p:extLst>
       <p:ext uri="{BB962C8B-B14F-4D97-AF65-F5344CB8AC3E}">
-        <p14:creationId xmlns:p14="http://schemas.microsoft.com/office/powerpoint/2010/main" val="1177588628"/>
+        <p14:creationId xmlns:p14="http://schemas.microsoft.com/office/powerpoint/2010/main" val="3939967630"/>
       </p:ext>
     </p:extLst>
   </p:cSld>
@@ -12481,7 +14698,7 @@
           <p:cNvPr id="2" name="Titel 1">
             <a:extLst>
               <a:ext uri="{FF2B5EF4-FFF2-40B4-BE49-F238E27FC236}">
-                <a16:creationId xmlns:a16="http://schemas.microsoft.com/office/drawing/2014/main" id="{C308A7BC-173E-1950-4483-C7EB83B61D49}"/>
+                <a16:creationId xmlns:a16="http://schemas.microsoft.com/office/drawing/2014/main" id="{684345CF-EA38-674A-CF5E-4825E912106C}"/>
               </a:ext>
             </a:extLst>
           </p:cNvPr>
@@ -12518,7 +14735,7 @@
           <p:cNvPr id="3" name="Inhaltsplatzhalter 2">
             <a:extLst>
               <a:ext uri="{FF2B5EF4-FFF2-40B4-BE49-F238E27FC236}">
-                <a16:creationId xmlns:a16="http://schemas.microsoft.com/office/drawing/2014/main" id="{49C968DD-E16F-5781-2591-D0C44BE24CD2}"/>
+                <a16:creationId xmlns:a16="http://schemas.microsoft.com/office/drawing/2014/main" id="{CBA0DB2F-1125-ED5D-0B96-9C8B9DF5F317}"/>
               </a:ext>
             </a:extLst>
           </p:cNvPr>
@@ -12608,7 +14825,7 @@
           <p:cNvPr id="4" name="Textplatzhalter 3">
             <a:extLst>
               <a:ext uri="{FF2B5EF4-FFF2-40B4-BE49-F238E27FC236}">
-                <a16:creationId xmlns:a16="http://schemas.microsoft.com/office/drawing/2014/main" id="{0B094689-8E08-F31B-1118-170B9C7F44C1}"/>
+                <a16:creationId xmlns:a16="http://schemas.microsoft.com/office/drawing/2014/main" id="{6FA63ACE-9D94-FB60-9A4E-4D27C8B3DA74}"/>
               </a:ext>
             </a:extLst>
           </p:cNvPr>
@@ -12679,7 +14896,7 @@
           <p:cNvPr id="5" name="Datumsplatzhalter 4">
             <a:extLst>
               <a:ext uri="{FF2B5EF4-FFF2-40B4-BE49-F238E27FC236}">
-                <a16:creationId xmlns:a16="http://schemas.microsoft.com/office/drawing/2014/main" id="{7B0FD140-7B5F-380D-B51A-4DE60F181BD5}"/>
+                <a16:creationId xmlns:a16="http://schemas.microsoft.com/office/drawing/2014/main" id="{7D38DBBE-CA0C-2897-5E12-0841C3397A1E}"/>
               </a:ext>
             </a:extLst>
           </p:cNvPr>
@@ -12695,7 +14912,7 @@
           <a:bodyPr/>
           <a:lstStyle/>
           <a:p>
-            <a:fld id="{C9962047-E2C8-4734-A689-668B36BC6A1D}" type="datetimeFigureOut">
+            <a:fld id="{921E86A6-473C-463A-A28B-F44BBA9E8087}" type="datetimeFigureOut">
               <a:rPr lang="de-DE" smtClean="0"/>
               <a:t>09.10.2026</a:t>
             </a:fld>
@@ -12708,7 +14925,7 @@
           <p:cNvPr id="6" name="Fußzeilenplatzhalter 5">
             <a:extLst>
               <a:ext uri="{FF2B5EF4-FFF2-40B4-BE49-F238E27FC236}">
-                <a16:creationId xmlns:a16="http://schemas.microsoft.com/office/drawing/2014/main" id="{6F92BBD0-2657-2EB2-0A74-4F49C69ECDAF}"/>
+                <a16:creationId xmlns:a16="http://schemas.microsoft.com/office/drawing/2014/main" id="{F2BF01A0-86F9-9BAF-ED6A-2951A2C8C40D}"/>
               </a:ext>
             </a:extLst>
           </p:cNvPr>
@@ -12733,7 +14950,7 @@
           <p:cNvPr id="7" name="Foliennummernplatzhalter 6">
             <a:extLst>
               <a:ext uri="{FF2B5EF4-FFF2-40B4-BE49-F238E27FC236}">
-                <a16:creationId xmlns:a16="http://schemas.microsoft.com/office/drawing/2014/main" id="{63C5E45C-8966-BA9E-BE27-097E6D3BC534}"/>
+                <a16:creationId xmlns:a16="http://schemas.microsoft.com/office/drawing/2014/main" id="{78B739D2-B2D5-BE06-960C-ED868F5203AC}"/>
               </a:ext>
             </a:extLst>
           </p:cNvPr>
@@ -12749,7 +14966,7 @@
           <a:bodyPr/>
           <a:lstStyle/>
           <a:p>
-            <a:fld id="{377935EF-6752-464A-9B81-BA8CABB6107B}" type="slidenum">
+            <a:fld id="{5E48D93C-8800-4654-AF56-A23C3A94C9C2}" type="slidenum">
               <a:rPr lang="de-DE" smtClean="0"/>
               <a:t>‹Nr.›</a:t>
             </a:fld>
@@ -12760,7 +14977,7 @@
     </p:spTree>
     <p:extLst>
       <p:ext uri="{BB962C8B-B14F-4D97-AF65-F5344CB8AC3E}">
-        <p14:creationId xmlns:p14="http://schemas.microsoft.com/office/powerpoint/2010/main" val="1848074316"/>
+        <p14:creationId xmlns:p14="http://schemas.microsoft.com/office/powerpoint/2010/main" val="1772657182"/>
       </p:ext>
     </p:extLst>
   </p:cSld>
@@ -12792,7 +15009,7 @@
           <p:cNvPr id="2" name="Titel 1">
             <a:extLst>
               <a:ext uri="{FF2B5EF4-FFF2-40B4-BE49-F238E27FC236}">
-                <a16:creationId xmlns:a16="http://schemas.microsoft.com/office/drawing/2014/main" id="{14CD96D7-1832-F3B8-9842-C2AB2F369333}"/>
+                <a16:creationId xmlns:a16="http://schemas.microsoft.com/office/drawing/2014/main" id="{3727F41C-52A7-6356-E208-DE4C876EDB77}"/>
               </a:ext>
             </a:extLst>
           </p:cNvPr>
@@ -12829,7 +15046,7 @@
           <p:cNvPr id="3" name="Bildplatzhalter 2">
             <a:extLst>
               <a:ext uri="{FF2B5EF4-FFF2-40B4-BE49-F238E27FC236}">
-                <a16:creationId xmlns:a16="http://schemas.microsoft.com/office/drawing/2014/main" id="{065477DC-3A8F-4FA1-2657-57EBDE61CD42}"/>
+                <a16:creationId xmlns:a16="http://schemas.microsoft.com/office/drawing/2014/main" id="{E0669E1C-46A8-A76B-4672-6B0ACDC4A1C9}"/>
               </a:ext>
             </a:extLst>
           </p:cNvPr>
@@ -12896,7 +15113,7 @@
           <p:cNvPr id="4" name="Textplatzhalter 3">
             <a:extLst>
               <a:ext uri="{FF2B5EF4-FFF2-40B4-BE49-F238E27FC236}">
-                <a16:creationId xmlns:a16="http://schemas.microsoft.com/office/drawing/2014/main" id="{64E94A0F-249A-4F8B-2A13-58551DA6368A}"/>
+                <a16:creationId xmlns:a16="http://schemas.microsoft.com/office/drawing/2014/main" id="{04CB05D8-123D-7105-EC86-EA45A61815E1}"/>
               </a:ext>
             </a:extLst>
           </p:cNvPr>
@@ -12967,7 +15184,7 @@
           <p:cNvPr id="5" name="Datumsplatzhalter 4">
             <a:extLst>
               <a:ext uri="{FF2B5EF4-FFF2-40B4-BE49-F238E27FC236}">
-                <a16:creationId xmlns:a16="http://schemas.microsoft.com/office/drawing/2014/main" id="{5897B951-D8FE-0CC1-9BE2-5B2364167F77}"/>
+                <a16:creationId xmlns:a16="http://schemas.microsoft.com/office/drawing/2014/main" id="{0FCCE7DA-CB60-5FBC-51ED-0CFEF146ADB1}"/>
               </a:ext>
             </a:extLst>
           </p:cNvPr>
@@ -12983,7 +15200,7 @@
           <a:bodyPr/>
           <a:lstStyle/>
           <a:p>
-            <a:fld id="{C9962047-E2C8-4734-A689-668B36BC6A1D}" type="datetimeFigureOut">
+            <a:fld id="{921E86A6-473C-463A-A28B-F44BBA9E8087}" type="datetimeFigureOut">
               <a:rPr lang="de-DE" smtClean="0"/>
               <a:t>09.10.2026</a:t>
             </a:fld>
@@ -12996,7 +15213,7 @@
           <p:cNvPr id="6" name="Fußzeilenplatzhalter 5">
             <a:extLst>
               <a:ext uri="{FF2B5EF4-FFF2-40B4-BE49-F238E27FC236}">
-                <a16:creationId xmlns:a16="http://schemas.microsoft.com/office/drawing/2014/main" id="{F598447C-5F4F-4037-8549-1DB1952A21E9}"/>
+                <a16:creationId xmlns:a16="http://schemas.microsoft.com/office/drawing/2014/main" id="{773E541D-72F7-7B31-011C-DE8CD93835B1}"/>
               </a:ext>
             </a:extLst>
           </p:cNvPr>
@@ -13021,7 +15238,7 @@
           <p:cNvPr id="7" name="Foliennummernplatzhalter 6">
             <a:extLst>
               <a:ext uri="{FF2B5EF4-FFF2-40B4-BE49-F238E27FC236}">
-                <a16:creationId xmlns:a16="http://schemas.microsoft.com/office/drawing/2014/main" id="{C6CAED72-85B7-E6AD-2B12-A1DFF0A3B352}"/>
+                <a16:creationId xmlns:a16="http://schemas.microsoft.com/office/drawing/2014/main" id="{2647F94C-3D93-7D08-107C-811B852274AF}"/>
               </a:ext>
             </a:extLst>
           </p:cNvPr>
@@ -13037,7 +15254,7 @@
           <a:bodyPr/>
           <a:lstStyle/>
           <a:p>
-            <a:fld id="{377935EF-6752-464A-9B81-BA8CABB6107B}" type="slidenum">
+            <a:fld id="{5E48D93C-8800-4654-AF56-A23C3A94C9C2}" type="slidenum">
               <a:rPr lang="de-DE" smtClean="0"/>
               <a:t>‹Nr.›</a:t>
             </a:fld>
@@ -13048,7 +15265,7 @@
     </p:spTree>
     <p:extLst>
       <p:ext uri="{BB962C8B-B14F-4D97-AF65-F5344CB8AC3E}">
-        <p14:creationId xmlns:p14="http://schemas.microsoft.com/office/powerpoint/2010/main" val="3927644076"/>
+        <p14:creationId xmlns:p14="http://schemas.microsoft.com/office/powerpoint/2010/main" val="731581815"/>
       </p:ext>
     </p:extLst>
   </p:cSld>
@@ -13085,7 +15302,7 @@
           <p:cNvPr id="2" name="Titelplatzhalter 1">
             <a:extLst>
               <a:ext uri="{FF2B5EF4-FFF2-40B4-BE49-F238E27FC236}">
-                <a16:creationId xmlns:a16="http://schemas.microsoft.com/office/drawing/2014/main" id="{48AF5C9E-86AA-08EC-FAA7-CC4932ED966B}"/>
+                <a16:creationId xmlns:a16="http://schemas.microsoft.com/office/drawing/2014/main" id="{FC9A2F4E-B953-ECC1-C92A-364C8D3BDCDF}"/>
               </a:ext>
             </a:extLst>
           </p:cNvPr>
@@ -13123,7 +15340,7 @@
           <p:cNvPr id="3" name="Textplatzhalter 2">
             <a:extLst>
               <a:ext uri="{FF2B5EF4-FFF2-40B4-BE49-F238E27FC236}">
-                <a16:creationId xmlns:a16="http://schemas.microsoft.com/office/drawing/2014/main" id="{F5EAB3AB-9B8B-780F-02EB-845E2095ACFC}"/>
+                <a16:creationId xmlns:a16="http://schemas.microsoft.com/office/drawing/2014/main" id="{DC51D95F-F74C-3673-D317-2299CE1C5460}"/>
               </a:ext>
             </a:extLst>
           </p:cNvPr>
@@ -13190,7 +15407,7 @@
           <p:cNvPr id="4" name="Datumsplatzhalter 3">
             <a:extLst>
               <a:ext uri="{FF2B5EF4-FFF2-40B4-BE49-F238E27FC236}">
-                <a16:creationId xmlns:a16="http://schemas.microsoft.com/office/drawing/2014/main" id="{56F16CA4-79D3-C070-004C-B4263D2E5270}"/>
+                <a16:creationId xmlns:a16="http://schemas.microsoft.com/office/drawing/2014/main" id="{C64BA83F-FD7A-EEA0-CCD2-591CB3F051FB}"/>
               </a:ext>
             </a:extLst>
           </p:cNvPr>
@@ -13224,7 +15441,7 @@
             </a:lvl1pPr>
           </a:lstStyle>
           <a:p>
-            <a:fld id="{C9962047-E2C8-4734-A689-668B36BC6A1D}" type="datetimeFigureOut">
+            <a:fld id="{921E86A6-473C-463A-A28B-F44BBA9E8087}" type="datetimeFigureOut">
               <a:rPr lang="de-DE" smtClean="0"/>
               <a:t>09.10.2026</a:t>
             </a:fld>
@@ -13237,7 +15454,7 @@
           <p:cNvPr id="5" name="Fußzeilenplatzhalter 4">
             <a:extLst>
               <a:ext uri="{FF2B5EF4-FFF2-40B4-BE49-F238E27FC236}">
-                <a16:creationId xmlns:a16="http://schemas.microsoft.com/office/drawing/2014/main" id="{1E85DF77-F128-4654-BFE8-DEABCE832339}"/>
+                <a16:creationId xmlns:a16="http://schemas.microsoft.com/office/drawing/2014/main" id="{8B7E7DF5-8A11-16F5-4CD6-EC489E60F2DC}"/>
               </a:ext>
             </a:extLst>
           </p:cNvPr>
@@ -13280,7 +15497,7 @@
           <p:cNvPr id="6" name="Foliennummernplatzhalter 5">
             <a:extLst>
               <a:ext uri="{FF2B5EF4-FFF2-40B4-BE49-F238E27FC236}">
-                <a16:creationId xmlns:a16="http://schemas.microsoft.com/office/drawing/2014/main" id="{0C936764-7B3D-A5D8-779A-73F3E7A778BF}"/>
+                <a16:creationId xmlns:a16="http://schemas.microsoft.com/office/drawing/2014/main" id="{D9E7FD84-D4F4-34B9-8FDF-888B80A15104}"/>
               </a:ext>
             </a:extLst>
           </p:cNvPr>
@@ -13314,7 +15531,7 @@
             </a:lvl1pPr>
           </a:lstStyle>
           <a:p>
-            <a:fld id="{377935EF-6752-464A-9B81-BA8CABB6107B}" type="slidenum">
+            <a:fld id="{5E48D93C-8800-4654-AF56-A23C3A94C9C2}" type="slidenum">
               <a:rPr lang="de-DE" smtClean="0"/>
               <a:t>‹Nr.›</a:t>
             </a:fld>
@@ -13325,7 +15542,7 @@
     </p:spTree>
     <p:extLst>
       <p:ext uri="{BB962C8B-B14F-4D97-AF65-F5344CB8AC3E}">
-        <p14:creationId xmlns:p14="http://schemas.microsoft.com/office/powerpoint/2010/main" val="2024606226"/>
+        <p14:creationId xmlns:p14="http://schemas.microsoft.com/office/powerpoint/2010/main" val="869361240"/>
       </p:ext>
     </p:extLst>
   </p:cSld>
@@ -13648,7 +15865,7 @@
           <p:cNvPr id="2" name="Titel 1">
             <a:extLst>
               <a:ext uri="{FF2B5EF4-FFF2-40B4-BE49-F238E27FC236}">
-                <a16:creationId xmlns:a16="http://schemas.microsoft.com/office/drawing/2014/main" id="{53EAACA3-EA18-3ACE-25AC-E907D276298B}"/>
+                <a16:creationId xmlns:a16="http://schemas.microsoft.com/office/drawing/2014/main" id="{E86C38D0-3BD5-D732-9179-6F1B68E12057}"/>
               </a:ext>
             </a:extLst>
           </p:cNvPr>
@@ -13677,7 +15894,7 @@
           <p:cNvPr id="3" name="Diagramm 2">
             <a:extLst>
               <a:ext uri="{FF2B5EF4-FFF2-40B4-BE49-F238E27FC236}">
-                <a16:creationId xmlns:a16="http://schemas.microsoft.com/office/drawing/2014/main" id="{3C01D9CD-217A-BF19-0576-56876BED3974}"/>
+                <a16:creationId xmlns:a16="http://schemas.microsoft.com/office/drawing/2014/main" id="{74F0637A-D22A-AE2B-77CD-7F9298D91FC7}"/>
               </a:ext>
             </a:extLst>
           </p:cNvPr>
@@ -13685,7 +15902,7 @@
           <p:nvPr>
             <p:extLst>
               <p:ext uri="{D42A27DB-BD31-4B8C-83A1-F6EECF244321}">
-                <p14:modId xmlns:p14="http://schemas.microsoft.com/office/powerpoint/2010/main" val="1182428717"/>
+                <p14:modId xmlns:p14="http://schemas.microsoft.com/office/powerpoint/2010/main" val="1650794000"/>
               </p:ext>
             </p:extLst>
           </p:nvPr>
@@ -13705,7 +15922,7 @@
           <p:cNvPr id="4" name="Diagramm 3">
             <a:extLst>
               <a:ext uri="{FF2B5EF4-FFF2-40B4-BE49-F238E27FC236}">
-                <a16:creationId xmlns:a16="http://schemas.microsoft.com/office/drawing/2014/main" id="{004CD60A-EE22-DC67-2238-21BD621425C7}"/>
+                <a16:creationId xmlns:a16="http://schemas.microsoft.com/office/drawing/2014/main" id="{AA9C547F-CE3B-4D19-7719-76B6AE024F21}"/>
               </a:ext>
             </a:extLst>
           </p:cNvPr>
@@ -13713,7 +15930,7 @@
           <p:nvPr>
             <p:extLst>
               <p:ext uri="{D42A27DB-BD31-4B8C-83A1-F6EECF244321}">
-                <p14:modId xmlns:p14="http://schemas.microsoft.com/office/powerpoint/2010/main" val="213811935"/>
+                <p14:modId xmlns:p14="http://schemas.microsoft.com/office/powerpoint/2010/main" val="407059004"/>
               </p:ext>
             </p:extLst>
           </p:nvPr>
@@ -13731,7 +15948,7 @@
     </p:spTree>
     <p:extLst>
       <p:ext uri="{BB962C8B-B14F-4D97-AF65-F5344CB8AC3E}">
-        <p14:creationId xmlns:p14="http://schemas.microsoft.com/office/powerpoint/2010/main" val="574115935"/>
+        <p14:creationId xmlns:p14="http://schemas.microsoft.com/office/powerpoint/2010/main" val="1392365029"/>
       </p:ext>
     </p:extLst>
   </p:cSld>
@@ -13763,7 +15980,7 @@
           <p:cNvPr id="2" name="Titel 1">
             <a:extLst>
               <a:ext uri="{FF2B5EF4-FFF2-40B4-BE49-F238E27FC236}">
-                <a16:creationId xmlns:a16="http://schemas.microsoft.com/office/drawing/2014/main" id="{55B283F3-AAE8-6F9F-3294-65661F15FE66}"/>
+                <a16:creationId xmlns:a16="http://schemas.microsoft.com/office/drawing/2014/main" id="{CA2EC12C-06C7-95B5-8A71-75084928A8F1}"/>
               </a:ext>
             </a:extLst>
           </p:cNvPr>
@@ -13792,7 +16009,7 @@
           <p:cNvPr id="3" name="Diagramm 2">
             <a:extLst>
               <a:ext uri="{FF2B5EF4-FFF2-40B4-BE49-F238E27FC236}">
-                <a16:creationId xmlns:a16="http://schemas.microsoft.com/office/drawing/2014/main" id="{AA9C8BB1-BC88-4A6B-7042-5392F19B64BA}"/>
+                <a16:creationId xmlns:a16="http://schemas.microsoft.com/office/drawing/2014/main" id="{66F8AB44-4E8C-D050-94B5-E9ED43D70CD2}"/>
               </a:ext>
             </a:extLst>
           </p:cNvPr>
@@ -13800,7 +16017,7 @@
           <p:nvPr>
             <p:extLst>
               <p:ext uri="{D42A27DB-BD31-4B8C-83A1-F6EECF244321}">
-                <p14:modId xmlns:p14="http://schemas.microsoft.com/office/powerpoint/2010/main" val="140767115"/>
+                <p14:modId xmlns:p14="http://schemas.microsoft.com/office/powerpoint/2010/main" val="2595484943"/>
               </p:ext>
             </p:extLst>
           </p:nvPr>
@@ -13820,7 +16037,7 @@
           <p:cNvPr id="4" name="Diagramm 3">
             <a:extLst>
               <a:ext uri="{FF2B5EF4-FFF2-40B4-BE49-F238E27FC236}">
-                <a16:creationId xmlns:a16="http://schemas.microsoft.com/office/drawing/2014/main" id="{6DCDB0FD-B923-D61B-B587-5E08AECC82FD}"/>
+                <a16:creationId xmlns:a16="http://schemas.microsoft.com/office/drawing/2014/main" id="{595F26E6-DD22-160B-F61F-C9D213869AEA}"/>
               </a:ext>
             </a:extLst>
           </p:cNvPr>
@@ -13828,7 +16045,7 @@
           <p:nvPr>
             <p:extLst>
               <p:ext uri="{D42A27DB-BD31-4B8C-83A1-F6EECF244321}">
-                <p14:modId xmlns:p14="http://schemas.microsoft.com/office/powerpoint/2010/main" val="3640681988"/>
+                <p14:modId xmlns:p14="http://schemas.microsoft.com/office/powerpoint/2010/main" val="3325323902"/>
               </p:ext>
             </p:extLst>
           </p:nvPr>
@@ -13846,7 +16063,7 @@
     </p:spTree>
     <p:extLst>
       <p:ext uri="{BB962C8B-B14F-4D97-AF65-F5344CB8AC3E}">
-        <p14:creationId xmlns:p14="http://schemas.microsoft.com/office/powerpoint/2010/main" val="809531301"/>
+        <p14:creationId xmlns:p14="http://schemas.microsoft.com/office/powerpoint/2010/main" val="2183542493"/>
       </p:ext>
     </p:extLst>
   </p:cSld>
@@ -13878,7 +16095,7 @@
           <p:cNvPr id="2" name="Titel 1">
             <a:extLst>
               <a:ext uri="{FF2B5EF4-FFF2-40B4-BE49-F238E27FC236}">
-                <a16:creationId xmlns:a16="http://schemas.microsoft.com/office/drawing/2014/main" id="{17EF85DC-365B-8C08-DF61-5F2A0C62A9DA}"/>
+                <a16:creationId xmlns:a16="http://schemas.microsoft.com/office/drawing/2014/main" id="{A0CA00E8-72EC-9903-5F63-0D2C4353A0A3}"/>
               </a:ext>
             </a:extLst>
           </p:cNvPr>
@@ -13907,7 +16124,7 @@
           <p:cNvPr id="3" name="Diagramm 2">
             <a:extLst>
               <a:ext uri="{FF2B5EF4-FFF2-40B4-BE49-F238E27FC236}">
-                <a16:creationId xmlns:a16="http://schemas.microsoft.com/office/drawing/2014/main" id="{EF7938AA-373C-4FDC-20F0-03B14C0E1B61}"/>
+                <a16:creationId xmlns:a16="http://schemas.microsoft.com/office/drawing/2014/main" id="{8DEE6D7A-9A77-92DD-8156-85CDFCE4E400}"/>
               </a:ext>
             </a:extLst>
           </p:cNvPr>
@@ -13915,7 +16132,7 @@
           <p:nvPr>
             <p:extLst>
               <p:ext uri="{D42A27DB-BD31-4B8C-83A1-F6EECF244321}">
-                <p14:modId xmlns:p14="http://schemas.microsoft.com/office/powerpoint/2010/main" val="305480100"/>
+                <p14:modId xmlns:p14="http://schemas.microsoft.com/office/powerpoint/2010/main" val="2238319985"/>
               </p:ext>
             </p:extLst>
           </p:nvPr>
@@ -13935,7 +16152,7 @@
           <p:cNvPr id="4" name="Diagramm 3">
             <a:extLst>
               <a:ext uri="{FF2B5EF4-FFF2-40B4-BE49-F238E27FC236}">
-                <a16:creationId xmlns:a16="http://schemas.microsoft.com/office/drawing/2014/main" id="{16BE79A1-D4CD-2A81-165B-E9C78AEF96FC}"/>
+                <a16:creationId xmlns:a16="http://schemas.microsoft.com/office/drawing/2014/main" id="{09279FD6-5391-9AD4-C805-A36D210466FD}"/>
               </a:ext>
             </a:extLst>
           </p:cNvPr>
@@ -13943,7 +16160,7 @@
           <p:nvPr>
             <p:extLst>
               <p:ext uri="{D42A27DB-BD31-4B8C-83A1-F6EECF244321}">
-                <p14:modId xmlns:p14="http://schemas.microsoft.com/office/powerpoint/2010/main" val="3610986942"/>
+                <p14:modId xmlns:p14="http://schemas.microsoft.com/office/powerpoint/2010/main" val="2645602623"/>
               </p:ext>
             </p:extLst>
           </p:nvPr>
@@ -13961,7 +16178,7 @@
     </p:spTree>
     <p:extLst>
       <p:ext uri="{BB962C8B-B14F-4D97-AF65-F5344CB8AC3E}">
-        <p14:creationId xmlns:p14="http://schemas.microsoft.com/office/powerpoint/2010/main" val="1911903433"/>
+        <p14:creationId xmlns:p14="http://schemas.microsoft.com/office/powerpoint/2010/main" val="799714202"/>
       </p:ext>
     </p:extLst>
   </p:cSld>
@@ -13993,7 +16210,7 @@
           <p:cNvPr id="2" name="Titel 1">
             <a:extLst>
               <a:ext uri="{FF2B5EF4-FFF2-40B4-BE49-F238E27FC236}">
-                <a16:creationId xmlns:a16="http://schemas.microsoft.com/office/drawing/2014/main" id="{2B29FBC4-6C87-A850-5505-08939A71CAED}"/>
+                <a16:creationId xmlns:a16="http://schemas.microsoft.com/office/drawing/2014/main" id="{26DA9E73-6E7B-2965-119A-C236E9ED6E71}"/>
               </a:ext>
             </a:extLst>
           </p:cNvPr>
@@ -14022,7 +16239,7 @@
           <p:cNvPr id="3" name="Diagramm 2">
             <a:extLst>
               <a:ext uri="{FF2B5EF4-FFF2-40B4-BE49-F238E27FC236}">
-                <a16:creationId xmlns:a16="http://schemas.microsoft.com/office/drawing/2014/main" id="{29DD8E1E-9EE9-47DA-54CA-EB348088445C}"/>
+                <a16:creationId xmlns:a16="http://schemas.microsoft.com/office/drawing/2014/main" id="{8112CE60-1DC3-A8EA-949D-EEF8E2C77C1D}"/>
               </a:ext>
             </a:extLst>
           </p:cNvPr>
@@ -14030,7 +16247,7 @@
           <p:nvPr>
             <p:extLst>
               <p:ext uri="{D42A27DB-BD31-4B8C-83A1-F6EECF244321}">
-                <p14:modId xmlns:p14="http://schemas.microsoft.com/office/powerpoint/2010/main" val="1272251118"/>
+                <p14:modId xmlns:p14="http://schemas.microsoft.com/office/powerpoint/2010/main" val="4009695993"/>
               </p:ext>
             </p:extLst>
           </p:nvPr>
@@ -14050,7 +16267,7 @@
           <p:cNvPr id="4" name="Diagramm 3">
             <a:extLst>
               <a:ext uri="{FF2B5EF4-FFF2-40B4-BE49-F238E27FC236}">
-                <a16:creationId xmlns:a16="http://schemas.microsoft.com/office/drawing/2014/main" id="{8B5A2F1B-4046-67F1-4BD6-AEB895ACD733}"/>
+                <a16:creationId xmlns:a16="http://schemas.microsoft.com/office/drawing/2014/main" id="{D2CEAE46-B2BD-E240-A838-027728F25FD8}"/>
               </a:ext>
             </a:extLst>
           </p:cNvPr>
@@ -14058,7 +16275,7 @@
           <p:nvPr>
             <p:extLst>
               <p:ext uri="{D42A27DB-BD31-4B8C-83A1-F6EECF244321}">
-                <p14:modId xmlns:p14="http://schemas.microsoft.com/office/powerpoint/2010/main" val="85409089"/>
+                <p14:modId xmlns:p14="http://schemas.microsoft.com/office/powerpoint/2010/main" val="3274393509"/>
               </p:ext>
             </p:extLst>
           </p:nvPr>
@@ -14076,7 +16293,7 @@
     </p:spTree>
     <p:extLst>
       <p:ext uri="{BB962C8B-B14F-4D97-AF65-F5344CB8AC3E}">
-        <p14:creationId xmlns:p14="http://schemas.microsoft.com/office/powerpoint/2010/main" val="2256778902"/>
+        <p14:creationId xmlns:p14="http://schemas.microsoft.com/office/powerpoint/2010/main" val="3326830483"/>
       </p:ext>
     </p:extLst>
   </p:cSld>
@@ -14108,7 +16325,7 @@
           <p:cNvPr id="2" name="Titel 1">
             <a:extLst>
               <a:ext uri="{FF2B5EF4-FFF2-40B4-BE49-F238E27FC236}">
-                <a16:creationId xmlns:a16="http://schemas.microsoft.com/office/drawing/2014/main" id="{FB0BF6E0-8AD4-83B2-BFCE-B8A40613758A}"/>
+                <a16:creationId xmlns:a16="http://schemas.microsoft.com/office/drawing/2014/main" id="{BB4667A8-D134-A0E2-807E-555BE926BAB2}"/>
               </a:ext>
             </a:extLst>
           </p:cNvPr>
@@ -14137,7 +16354,7 @@
           <p:cNvPr id="3" name="Diagramm 2">
             <a:extLst>
               <a:ext uri="{FF2B5EF4-FFF2-40B4-BE49-F238E27FC236}">
-                <a16:creationId xmlns:a16="http://schemas.microsoft.com/office/drawing/2014/main" id="{B515185C-EB13-37E4-6198-5B8551135277}"/>
+                <a16:creationId xmlns:a16="http://schemas.microsoft.com/office/drawing/2014/main" id="{326C0992-C59B-0D25-398C-4EA39B2186F0}"/>
               </a:ext>
             </a:extLst>
           </p:cNvPr>
@@ -14145,7 +16362,7 @@
           <p:nvPr>
             <p:extLst>
               <p:ext uri="{D42A27DB-BD31-4B8C-83A1-F6EECF244321}">
-                <p14:modId xmlns:p14="http://schemas.microsoft.com/office/powerpoint/2010/main" val="3249793868"/>
+                <p14:modId xmlns:p14="http://schemas.microsoft.com/office/powerpoint/2010/main" val="1974353754"/>
               </p:ext>
             </p:extLst>
           </p:nvPr>
@@ -14165,7 +16382,7 @@
           <p:cNvPr id="4" name="Diagramm 3">
             <a:extLst>
               <a:ext uri="{FF2B5EF4-FFF2-40B4-BE49-F238E27FC236}">
-                <a16:creationId xmlns:a16="http://schemas.microsoft.com/office/drawing/2014/main" id="{E6B5FB2D-438F-541C-CB69-BC963D53560B}"/>
+                <a16:creationId xmlns:a16="http://schemas.microsoft.com/office/drawing/2014/main" id="{81EE61EA-825E-6DAD-0DCC-099F9A72B27F}"/>
               </a:ext>
             </a:extLst>
           </p:cNvPr>
@@ -14173,7 +16390,7 @@
           <p:nvPr>
             <p:extLst>
               <p:ext uri="{D42A27DB-BD31-4B8C-83A1-F6EECF244321}">
-                <p14:modId xmlns:p14="http://schemas.microsoft.com/office/powerpoint/2010/main" val="2509046853"/>
+                <p14:modId xmlns:p14="http://schemas.microsoft.com/office/powerpoint/2010/main" val="1002662291"/>
               </p:ext>
             </p:extLst>
           </p:nvPr>
@@ -14193,7 +16410,7 @@
           <p:cNvPr id="5" name="Diagramm 4">
             <a:extLst>
               <a:ext uri="{FF2B5EF4-FFF2-40B4-BE49-F238E27FC236}">
-                <a16:creationId xmlns:a16="http://schemas.microsoft.com/office/drawing/2014/main" id="{04CCB4E4-9096-93DE-2539-B80D7DE722AC}"/>
+                <a16:creationId xmlns:a16="http://schemas.microsoft.com/office/drawing/2014/main" id="{1798C69D-D17C-60E0-2ABE-AD151DECFE97}"/>
               </a:ext>
             </a:extLst>
           </p:cNvPr>
@@ -14201,7 +16418,7 @@
           <p:nvPr>
             <p:extLst>
               <p:ext uri="{D42A27DB-BD31-4B8C-83A1-F6EECF244321}">
-                <p14:modId xmlns:p14="http://schemas.microsoft.com/office/powerpoint/2010/main" val="3083615134"/>
+                <p14:modId xmlns:p14="http://schemas.microsoft.com/office/powerpoint/2010/main" val="3348270170"/>
               </p:ext>
             </p:extLst>
           </p:nvPr>
@@ -14219,7 +16436,121 @@
     </p:spTree>
     <p:extLst>
       <p:ext uri="{BB962C8B-B14F-4D97-AF65-F5344CB8AC3E}">
-        <p14:creationId xmlns:p14="http://schemas.microsoft.com/office/powerpoint/2010/main" val="971056430"/>
+        <p14:creationId xmlns:p14="http://schemas.microsoft.com/office/powerpoint/2010/main" val="2318946443"/>
+      </p:ext>
+    </p:extLst>
+  </p:cSld>
+  <p:clrMapOvr>
+    <a:masterClrMapping/>
+  </p:clrMapOvr>
+</p:sld>
+</file>
+
+<file path=ppt/slides/slide6.xml><?xml version="1.0" encoding="utf-8"?>
+<p:sld xmlns:a="http://schemas.openxmlformats.org/drawingml/2006/main" xmlns:r="http://schemas.openxmlformats.org/officeDocument/2006/relationships" xmlns:p="http://schemas.openxmlformats.org/presentationml/2006/main">
+  <p:cSld>
+    <p:spTree>
+      <p:nvGrpSpPr>
+        <p:cNvPr id="1" name=""/>
+        <p:cNvGrpSpPr/>
+        <p:nvPr/>
+      </p:nvGrpSpPr>
+      <p:grpSpPr>
+        <a:xfrm>
+          <a:off x="0" y="0"/>
+          <a:ext cx="0" cy="0"/>
+          <a:chOff x="0" y="0"/>
+          <a:chExt cx="0" cy="0"/>
+        </a:xfrm>
+      </p:grpSpPr>
+      <p:sp>
+        <p:nvSpPr>
+          <p:cNvPr id="2" name="Titel 1">
+            <a:extLst>
+              <a:ext uri="{FF2B5EF4-FFF2-40B4-BE49-F238E27FC236}">
+                <a16:creationId xmlns:a16="http://schemas.microsoft.com/office/drawing/2014/main" id="{EB0A34C2-2826-40E4-2E8B-A817CE527825}"/>
+              </a:ext>
+            </a:extLst>
+          </p:cNvPr>
+          <p:cNvSpPr>
+            <a:spLocks noGrp="1"/>
+          </p:cNvSpPr>
+          <p:nvPr>
+            <p:ph type="title"/>
+          </p:nvPr>
+        </p:nvSpPr>
+        <p:spPr/>
+        <p:txBody>
+          <a:bodyPr/>
+          <a:lstStyle/>
+          <a:p>
+            <a:r>
+              <a:rPr lang="de-DE"/>
+              <a:t>Formatted data label text</a:t>
+            </a:r>
+          </a:p>
+        </p:txBody>
+      </p:sp>
+      <p:graphicFrame>
+        <p:nvGraphicFramePr>
+          <p:cNvPr id="3" name="Diagramm 2">
+            <a:extLst>
+              <a:ext uri="{FF2B5EF4-FFF2-40B4-BE49-F238E27FC236}">
+                <a16:creationId xmlns:a16="http://schemas.microsoft.com/office/drawing/2014/main" id="{CD4E39BD-2656-9D6A-7178-17A16B3FD35F}"/>
+              </a:ext>
+            </a:extLst>
+          </p:cNvPr>
+          <p:cNvGraphicFramePr/>
+          <p:nvPr>
+            <p:extLst>
+              <p:ext uri="{D42A27DB-BD31-4B8C-83A1-F6EECF244321}">
+                <p14:modId xmlns:p14="http://schemas.microsoft.com/office/powerpoint/2010/main" val="243384477"/>
+              </p:ext>
+            </p:extLst>
+          </p:nvPr>
+        </p:nvGraphicFramePr>
+        <p:xfrm>
+          <a:off x="254000" y="1397000"/>
+          <a:ext cx="5842000" cy="5207000"/>
+        </p:xfrm>
+        <a:graphic>
+          <a:graphicData uri="http://schemas.openxmlformats.org/drawingml/2006/chart">
+            <c:chart xmlns:c="http://schemas.openxmlformats.org/drawingml/2006/chart" xmlns:r="http://schemas.openxmlformats.org/officeDocument/2006/relationships" r:id="rId2"/>
+          </a:graphicData>
+        </a:graphic>
+      </p:graphicFrame>
+      <p:graphicFrame>
+        <p:nvGraphicFramePr>
+          <p:cNvPr id="4" name="Diagramm 3">
+            <a:extLst>
+              <a:ext uri="{FF2B5EF4-FFF2-40B4-BE49-F238E27FC236}">
+                <a16:creationId xmlns:a16="http://schemas.microsoft.com/office/drawing/2014/main" id="{322F7FFE-CFB9-7638-2040-493C4AE46003}"/>
+              </a:ext>
+            </a:extLst>
+          </p:cNvPr>
+          <p:cNvGraphicFramePr/>
+          <p:nvPr>
+            <p:extLst>
+              <p:ext uri="{D42A27DB-BD31-4B8C-83A1-F6EECF244321}">
+                <p14:modId xmlns:p14="http://schemas.microsoft.com/office/powerpoint/2010/main" val="3690308995"/>
+              </p:ext>
+            </p:extLst>
+          </p:nvPr>
+        </p:nvGraphicFramePr>
+        <p:xfrm>
+          <a:off x="6223000" y="1397000"/>
+          <a:ext cx="5842000" cy="5207000"/>
+        </p:xfrm>
+        <a:graphic>
+          <a:graphicData uri="http://schemas.openxmlformats.org/drawingml/2006/chart">
+            <c:chart xmlns:c="http://schemas.openxmlformats.org/drawingml/2006/chart" xmlns:r="http://schemas.openxmlformats.org/officeDocument/2006/relationships" r:id="rId3"/>
+          </a:graphicData>
+        </a:graphic>
+      </p:graphicFrame>
+    </p:spTree>
+    <p:extLst>
+      <p:ext uri="{BB962C8B-B14F-4D97-AF65-F5344CB8AC3E}">
+        <p14:creationId xmlns:p14="http://schemas.microsoft.com/office/powerpoint/2010/main" val="3442615891"/>
       </p:ext>
     </p:extLst>
   </p:cSld>

</xml_diff>